<commit_message>
v0.4.0: stability & security release
Code-review bug-fix pass (data loss, index integrity, citation graph,
metadata, UI), secretStorage key migration, add-time dedup + PMID
confirm, multi-turn chat citation carry, and security hardening
(URL scheme checks, path sanitization, chat trust boundary).
See CHANGELOG.md for the full list.

Co-Authored-By: Claude Fable 5 <noreply@anthropic.com>
</commit_message>
<xml_diff>
--- a/presentation/rag_obsidian_deck.pptx
+++ b/presentation/rag_obsidian_deck.pptx
@@ -6305,7 +6305,7 @@
                 <a:ea typeface="Pretendard"/>
                 <a:cs typeface="Pretendard"/>
               </a:rPr>
-              <a:t>v0.3.0 · github.com/grotyx/rag-obsidian</a:t>
+              <a:t>v0.4.0 · github.com/grotyx/rag-obsidian</a:t>
             </a:r>
           </a:p>
         </p:txBody>
@@ -7924,7 +7924,7 @@
                 <a:ea typeface="Pretendard"/>
                 <a:cs typeface="Pretendard"/>
               </a:rPr>
-              <a:t>현재 v0.3.0 · 개발 빌드로 사용 중 · 공개 배포 예정</a:t>
+              <a:t>현재 v0.4.0 · 개발 빌드로 사용 중 · 공개 배포 예정</a:t>
             </a:r>
           </a:p>
         </p:txBody>

</xml_diff>

<commit_message>
docs: deck — add HOW TO USE slide (5 concrete actions, 17 slides)
Slide 15: command-palette workflow — add reference, semantic search,
chat, @-cite autocomplete, update bibliography — with the actual
command names and a one-time 'Rebuild search index' note. Script,
plan, and slide spec renumbered 16→17.

Co-Authored-By: Claude Fable 5 <noreply@anthropic.com>
</commit_message>
<xml_diff>
--- a/presentation/rag_obsidian_deck.pptx
+++ b/presentation/rag_obsidian_deck.pptx
@@ -21,6 +21,7 @@
     <p:sldId id="269" r:id="rId20"/>
     <p:sldId id="270" r:id="rId21"/>
     <p:sldId id="271" r:id="rId22"/>
+    <p:sldId id="272" r:id="rId23"/>
   </p:sldIdLst>
   <p:sldSz cx="12191695" cy="6858000" type="screen4x3"/>
   <p:notesSz cx="6858000" cy="9144000"/>
@@ -8106,7 +8107,7 @@
                 <a:ea typeface="Pretendard"/>
                 <a:cs typeface="Pretendard"/>
               </a:rPr>
-              <a:t>CONCLUSION</a:t>
+              <a:t>HOW TO USE</a:t>
             </a:r>
           </a:p>
         </p:txBody>
@@ -8147,7 +8148,7 @@
                 <a:ea typeface="Pretendard"/>
                 <a:cs typeface="Pretendard"/>
               </a:rPr>
-              <a:t>Zotero 없이, 서버 없이, 늘 출처와 함께</a:t>
+              <a:t>쓰는 법은 다섯 동작이 전부다</a:t>
             </a:r>
           </a:p>
         </p:txBody>
@@ -8264,18 +8265,1793 @@
       </p:sp>
       <p:sp>
         <p:nvSpPr>
-          <p:cNvPr id="8" name="Rounded Rectangle 7"/>
+          <p:cNvPr id="8" name="TextBox 7"/>
+          <p:cNvSpPr txBox="1"/>
+          <p:nvPr/>
+        </p:nvSpPr>
+        <p:spPr>
+          <a:xfrm>
+            <a:off x="6567403" y="6617421"/>
+            <a:ext cx="5486400" cy="228600"/>
+          </a:xfrm>
+          <a:prstGeom prst="rect">
+            <a:avLst/>
+          </a:prstGeom>
+          <a:noFill/>
+        </p:spPr>
+        <p:txBody>
+          <a:bodyPr wrap="square" anchor="t" lIns="0" rIns="0" tIns="0" bIns="0">
+            <a:spAutoFit/>
+          </a:bodyPr>
+          <a:lstStyle/>
+          <a:p>
+            <a:pPr algn="r"/>
+            <a:r>
+              <a:rPr sz="800" b="0" i="0" spc="-8">
+                <a:solidFill>
+                  <a:srgbClr val="8E8E93"/>
+                </a:solidFill>
+                <a:latin typeface="Pretendard"/>
+                <a:ea typeface="Pretendard"/>
+                <a:cs typeface="Pretendard"/>
+              </a:rPr>
+              <a:t>명령 팔레트 = Cmd/Ctrl+P · 'RAG'만 쳐도 전부 검색됨</a:t>
+            </a:r>
+          </a:p>
+        </p:txBody>
+      </p:sp>
+      <p:sp>
+        <p:nvSpPr>
+          <p:cNvPr id="9" name="Rounded Rectangle 8"/>
           <p:cNvSpPr/>
           <p:nvPr/>
         </p:nvSpPr>
         <p:spPr>
           <a:xfrm>
-            <a:off x="663122" y="1747509"/>
-            <a:ext cx="3491362" cy="3200400"/>
+            <a:off x="663122" y="1701789"/>
+            <a:ext cx="10876422" cy="676656"/>
           </a:xfrm>
           <a:prstGeom prst="roundRect">
             <a:avLst>
-              <a:gd name="adj" fmla="val 6000"/>
+              <a:gd name="adj" fmla="val 8000"/>
+            </a:avLst>
+          </a:prstGeom>
+          <a:solidFill>
+            <a:srgbClr val="FFFFFF"/>
+          </a:solidFill>
+          <a:ln w="11430">
+            <a:solidFill>
+              <a:srgbClr val="D9D9D9"/>
+            </a:solidFill>
+          </a:ln>
+          <a:effectLst/>
+        </p:spPr>
+        <p:style>
+          <a:lnRef idx="1">
+            <a:schemeClr val="accent1"/>
+          </a:lnRef>
+          <a:fillRef idx="3">
+            <a:schemeClr val="accent1"/>
+          </a:fillRef>
+          <a:effectRef idx="2">
+            <a:schemeClr val="accent1"/>
+          </a:effectRef>
+          <a:fontRef idx="minor">
+            <a:schemeClr val="lt1"/>
+          </a:fontRef>
+        </p:style>
+        <p:txBody>
+          <a:bodyPr rtlCol="0" anchor="ctr"/>
+          <a:lstStyle/>
+          <a:p>
+            <a:pPr algn="ctr"/>
+          </a:p>
+        </p:txBody>
+      </p:sp>
+      <p:sp>
+        <p:nvSpPr>
+          <p:cNvPr id="10" name="Oval 9"/>
+          <p:cNvSpPr/>
+          <p:nvPr/>
+        </p:nvSpPr>
+        <p:spPr>
+          <a:xfrm>
+            <a:off x="864290" y="1857237"/>
+            <a:ext cx="365760" cy="365760"/>
+          </a:xfrm>
+          <a:prstGeom prst="ellipse">
+            <a:avLst/>
+          </a:prstGeom>
+          <a:solidFill>
+            <a:srgbClr val="00754A"/>
+          </a:solidFill>
+          <a:ln>
+            <a:noFill/>
+          </a:ln>
+          <a:effectLst/>
+        </p:spPr>
+        <p:style>
+          <a:lnRef idx="1">
+            <a:schemeClr val="accent1"/>
+          </a:lnRef>
+          <a:fillRef idx="3">
+            <a:schemeClr val="accent1"/>
+          </a:fillRef>
+          <a:effectRef idx="2">
+            <a:schemeClr val="accent1"/>
+          </a:effectRef>
+          <a:fontRef idx="minor">
+            <a:schemeClr val="lt1"/>
+          </a:fontRef>
+        </p:style>
+        <p:txBody>
+          <a:bodyPr rtlCol="0" anchor="ctr"/>
+          <a:lstStyle/>
+          <a:p>
+            <a:pPr algn="ctr"/>
+          </a:p>
+        </p:txBody>
+      </p:sp>
+      <p:sp>
+        <p:nvSpPr>
+          <p:cNvPr id="11" name="TextBox 10"/>
+          <p:cNvSpPr txBox="1"/>
+          <p:nvPr/>
+        </p:nvSpPr>
+        <p:spPr>
+          <a:xfrm>
+            <a:off x="864290" y="1857237"/>
+            <a:ext cx="365760" cy="365760"/>
+          </a:xfrm>
+          <a:prstGeom prst="rect">
+            <a:avLst/>
+          </a:prstGeom>
+          <a:noFill/>
+        </p:spPr>
+        <p:txBody>
+          <a:bodyPr wrap="square" anchor="ctr" lIns="0" rIns="0" tIns="0" bIns="0">
+            <a:spAutoFit/>
+          </a:bodyPr>
+          <a:lstStyle/>
+          <a:p>
+            <a:pPr algn="ctr"/>
+            <a:r>
+              <a:rPr sz="1500" b="1" i="0" spc="-15">
+                <a:solidFill>
+                  <a:srgbClr val="FFFFFF"/>
+                </a:solidFill>
+                <a:latin typeface="Pretendard"/>
+                <a:ea typeface="Pretendard"/>
+                <a:cs typeface="Pretendard"/>
+              </a:rPr>
+              <a:t>1</a:t>
+            </a:r>
+          </a:p>
+        </p:txBody>
+      </p:sp>
+      <p:sp>
+        <p:nvSpPr>
+          <p:cNvPr id="12" name="TextBox 11"/>
+          <p:cNvSpPr txBox="1"/>
+          <p:nvPr/>
+        </p:nvSpPr>
+        <p:spPr>
+          <a:xfrm>
+            <a:off x="1348922" y="1701789"/>
+            <a:ext cx="1783080" cy="676656"/>
+          </a:xfrm>
+          <a:prstGeom prst="rect">
+            <a:avLst/>
+          </a:prstGeom>
+          <a:noFill/>
+        </p:spPr>
+        <p:txBody>
+          <a:bodyPr wrap="square" anchor="ctr" lIns="0" rIns="0" tIns="0" bIns="0">
+            <a:spAutoFit/>
+          </a:bodyPr>
+          <a:lstStyle/>
+          <a:p>
+            <a:pPr algn="l">
+              <a:lnSpc>
+                <a:spcPts val="1800"/>
+              </a:lnSpc>
+            </a:pPr>
+            <a:r>
+              <a:rPr sz="1500" b="1" i="0" spc="-15">
+                <a:solidFill>
+                  <a:srgbClr val="006241"/>
+                </a:solidFill>
+                <a:latin typeface="Pretendard"/>
+                <a:ea typeface="Pretendard"/>
+                <a:cs typeface="Pretendard"/>
+              </a:rPr>
+              <a:t>논문 추가</a:t>
+            </a:r>
+          </a:p>
+        </p:txBody>
+      </p:sp>
+      <p:sp>
+        <p:nvSpPr>
+          <p:cNvPr id="13" name="Rounded Rectangle 12"/>
+          <p:cNvSpPr/>
+          <p:nvPr/>
+        </p:nvSpPr>
+        <p:spPr>
+          <a:xfrm>
+            <a:off x="3177722" y="1820661"/>
+            <a:ext cx="4526280" cy="438912"/>
+          </a:xfrm>
+          <a:prstGeom prst="roundRect">
+            <a:avLst>
+              <a:gd name="adj" fmla="val 12000"/>
+            </a:avLst>
+          </a:prstGeom>
+          <a:solidFill>
+            <a:srgbClr val="F2F0EB"/>
+          </a:solidFill>
+          <a:ln>
+            <a:noFill/>
+          </a:ln>
+          <a:effectLst/>
+        </p:spPr>
+        <p:style>
+          <a:lnRef idx="1">
+            <a:schemeClr val="accent1"/>
+          </a:lnRef>
+          <a:fillRef idx="3">
+            <a:schemeClr val="accent1"/>
+          </a:fillRef>
+          <a:effectRef idx="2">
+            <a:schemeClr val="accent1"/>
+          </a:effectRef>
+          <a:fontRef idx="minor">
+            <a:schemeClr val="lt1"/>
+          </a:fontRef>
+        </p:style>
+        <p:txBody>
+          <a:bodyPr rtlCol="0" anchor="ctr"/>
+          <a:lstStyle/>
+          <a:p>
+            <a:pPr algn="ctr"/>
+          </a:p>
+        </p:txBody>
+      </p:sp>
+      <p:sp>
+        <p:nvSpPr>
+          <p:cNvPr id="14" name="TextBox 13"/>
+          <p:cNvSpPr txBox="1"/>
+          <p:nvPr/>
+        </p:nvSpPr>
+        <p:spPr>
+          <a:xfrm>
+            <a:off x="3314882" y="1820661"/>
+            <a:ext cx="4251960" cy="438912"/>
+          </a:xfrm>
+          <a:prstGeom prst="rect">
+            <a:avLst/>
+          </a:prstGeom>
+          <a:noFill/>
+        </p:spPr>
+        <p:txBody>
+          <a:bodyPr wrap="square" anchor="ctr" lIns="0" rIns="0" tIns="0" bIns="0">
+            <a:spAutoFit/>
+          </a:bodyPr>
+          <a:lstStyle/>
+          <a:p>
+            <a:pPr algn="l">
+              <a:lnSpc>
+                <a:spcPts val="1500"/>
+              </a:lnSpc>
+            </a:pPr>
+            <a:r>
+              <a:rPr sz="1200" b="1" i="0" spc="-12">
+                <a:solidFill>
+                  <a:srgbClr val="00754A"/>
+                </a:solidFill>
+                <a:latin typeface="Pretendard"/>
+                <a:ea typeface="Pretendard"/>
+                <a:cs typeface="Pretendard"/>
+              </a:rPr>
+              <a:t>Cmd+P → “Add reference by DOI / PMID / arXiv”</a:t>
+            </a:r>
+          </a:p>
+        </p:txBody>
+      </p:sp>
+      <p:sp>
+        <p:nvSpPr>
+          <p:cNvPr id="15" name="TextBox 14"/>
+          <p:cNvSpPr txBox="1"/>
+          <p:nvPr/>
+        </p:nvSpPr>
+        <p:spPr>
+          <a:xfrm>
+            <a:off x="7932602" y="1701789"/>
+            <a:ext cx="3469782" cy="676656"/>
+          </a:xfrm>
+          <a:prstGeom prst="rect">
+            <a:avLst/>
+          </a:prstGeom>
+          <a:noFill/>
+        </p:spPr>
+        <p:txBody>
+          <a:bodyPr wrap="square" anchor="ctr" lIns="0" rIns="0" tIns="0" bIns="0">
+            <a:spAutoFit/>
+          </a:bodyPr>
+          <a:lstStyle/>
+          <a:p>
+            <a:pPr algn="l">
+              <a:lnSpc>
+                <a:spcPts val="1600"/>
+              </a:lnSpc>
+            </a:pPr>
+            <a:r>
+              <a:rPr sz="1250" b="0" i="0" spc="-12">
+                <a:solidFill>
+                  <a:srgbClr val="6B6B6B"/>
+                </a:solidFill>
+                <a:latin typeface="Pretendard"/>
+                <a:ea typeface="Pretendard"/>
+                <a:cs typeface="Pretendard"/>
+              </a:rPr>
+              <a:t>DOI·PMID 붙여넣기 → References/에 노트 자동 생성</a:t>
+            </a:r>
+          </a:p>
+        </p:txBody>
+      </p:sp>
+      <p:sp>
+        <p:nvSpPr>
+          <p:cNvPr id="16" name="Rounded Rectangle 15"/>
+          <p:cNvSpPr/>
+          <p:nvPr/>
+        </p:nvSpPr>
+        <p:spPr>
+          <a:xfrm>
+            <a:off x="663122" y="2479029"/>
+            <a:ext cx="10876422" cy="676656"/>
+          </a:xfrm>
+          <a:prstGeom prst="roundRect">
+            <a:avLst>
+              <a:gd name="adj" fmla="val 8000"/>
+            </a:avLst>
+          </a:prstGeom>
+          <a:solidFill>
+            <a:srgbClr val="FFFFFF"/>
+          </a:solidFill>
+          <a:ln w="11430">
+            <a:solidFill>
+              <a:srgbClr val="D9D9D9"/>
+            </a:solidFill>
+          </a:ln>
+          <a:effectLst/>
+        </p:spPr>
+        <p:style>
+          <a:lnRef idx="1">
+            <a:schemeClr val="accent1"/>
+          </a:lnRef>
+          <a:fillRef idx="3">
+            <a:schemeClr val="accent1"/>
+          </a:fillRef>
+          <a:effectRef idx="2">
+            <a:schemeClr val="accent1"/>
+          </a:effectRef>
+          <a:fontRef idx="minor">
+            <a:schemeClr val="lt1"/>
+          </a:fontRef>
+        </p:style>
+        <p:txBody>
+          <a:bodyPr rtlCol="0" anchor="ctr"/>
+          <a:lstStyle/>
+          <a:p>
+            <a:pPr algn="ctr"/>
+          </a:p>
+        </p:txBody>
+      </p:sp>
+      <p:sp>
+        <p:nvSpPr>
+          <p:cNvPr id="17" name="Oval 16"/>
+          <p:cNvSpPr/>
+          <p:nvPr/>
+        </p:nvSpPr>
+        <p:spPr>
+          <a:xfrm>
+            <a:off x="864290" y="2634477"/>
+            <a:ext cx="365760" cy="365760"/>
+          </a:xfrm>
+          <a:prstGeom prst="ellipse">
+            <a:avLst/>
+          </a:prstGeom>
+          <a:solidFill>
+            <a:srgbClr val="00754A"/>
+          </a:solidFill>
+          <a:ln>
+            <a:noFill/>
+          </a:ln>
+          <a:effectLst/>
+        </p:spPr>
+        <p:style>
+          <a:lnRef idx="1">
+            <a:schemeClr val="accent1"/>
+          </a:lnRef>
+          <a:fillRef idx="3">
+            <a:schemeClr val="accent1"/>
+          </a:fillRef>
+          <a:effectRef idx="2">
+            <a:schemeClr val="accent1"/>
+          </a:effectRef>
+          <a:fontRef idx="minor">
+            <a:schemeClr val="lt1"/>
+          </a:fontRef>
+        </p:style>
+        <p:txBody>
+          <a:bodyPr rtlCol="0" anchor="ctr"/>
+          <a:lstStyle/>
+          <a:p>
+            <a:pPr algn="ctr"/>
+          </a:p>
+        </p:txBody>
+      </p:sp>
+      <p:sp>
+        <p:nvSpPr>
+          <p:cNvPr id="18" name="TextBox 17"/>
+          <p:cNvSpPr txBox="1"/>
+          <p:nvPr/>
+        </p:nvSpPr>
+        <p:spPr>
+          <a:xfrm>
+            <a:off x="864290" y="2634477"/>
+            <a:ext cx="365760" cy="365760"/>
+          </a:xfrm>
+          <a:prstGeom prst="rect">
+            <a:avLst/>
+          </a:prstGeom>
+          <a:noFill/>
+        </p:spPr>
+        <p:txBody>
+          <a:bodyPr wrap="square" anchor="ctr" lIns="0" rIns="0" tIns="0" bIns="0">
+            <a:spAutoFit/>
+          </a:bodyPr>
+          <a:lstStyle/>
+          <a:p>
+            <a:pPr algn="ctr"/>
+            <a:r>
+              <a:rPr sz="1500" b="1" i="0" spc="-15">
+                <a:solidFill>
+                  <a:srgbClr val="FFFFFF"/>
+                </a:solidFill>
+                <a:latin typeface="Pretendard"/>
+                <a:ea typeface="Pretendard"/>
+                <a:cs typeface="Pretendard"/>
+              </a:rPr>
+              <a:t>2</a:t>
+            </a:r>
+          </a:p>
+        </p:txBody>
+      </p:sp>
+      <p:sp>
+        <p:nvSpPr>
+          <p:cNvPr id="19" name="TextBox 18"/>
+          <p:cNvSpPr txBox="1"/>
+          <p:nvPr/>
+        </p:nvSpPr>
+        <p:spPr>
+          <a:xfrm>
+            <a:off x="1348922" y="2479029"/>
+            <a:ext cx="1783080" cy="676656"/>
+          </a:xfrm>
+          <a:prstGeom prst="rect">
+            <a:avLst/>
+          </a:prstGeom>
+          <a:noFill/>
+        </p:spPr>
+        <p:txBody>
+          <a:bodyPr wrap="square" anchor="ctr" lIns="0" rIns="0" tIns="0" bIns="0">
+            <a:spAutoFit/>
+          </a:bodyPr>
+          <a:lstStyle/>
+          <a:p>
+            <a:pPr algn="l">
+              <a:lnSpc>
+                <a:spcPts val="1800"/>
+              </a:lnSpc>
+            </a:pPr>
+            <a:r>
+              <a:rPr sz="1500" b="1" i="0" spc="-15">
+                <a:solidFill>
+                  <a:srgbClr val="006241"/>
+                </a:solidFill>
+                <a:latin typeface="Pretendard"/>
+                <a:ea typeface="Pretendard"/>
+                <a:cs typeface="Pretendard"/>
+              </a:rPr>
+              <a:t>뜻으로 검색</a:t>
+            </a:r>
+          </a:p>
+        </p:txBody>
+      </p:sp>
+      <p:sp>
+        <p:nvSpPr>
+          <p:cNvPr id="20" name="Rounded Rectangle 19"/>
+          <p:cNvSpPr/>
+          <p:nvPr/>
+        </p:nvSpPr>
+        <p:spPr>
+          <a:xfrm>
+            <a:off x="3177722" y="2597901"/>
+            <a:ext cx="4526280" cy="438912"/>
+          </a:xfrm>
+          <a:prstGeom prst="roundRect">
+            <a:avLst>
+              <a:gd name="adj" fmla="val 12000"/>
+            </a:avLst>
+          </a:prstGeom>
+          <a:solidFill>
+            <a:srgbClr val="F2F0EB"/>
+          </a:solidFill>
+          <a:ln>
+            <a:noFill/>
+          </a:ln>
+          <a:effectLst/>
+        </p:spPr>
+        <p:style>
+          <a:lnRef idx="1">
+            <a:schemeClr val="accent1"/>
+          </a:lnRef>
+          <a:fillRef idx="3">
+            <a:schemeClr val="accent1"/>
+          </a:fillRef>
+          <a:effectRef idx="2">
+            <a:schemeClr val="accent1"/>
+          </a:effectRef>
+          <a:fontRef idx="minor">
+            <a:schemeClr val="lt1"/>
+          </a:fontRef>
+        </p:style>
+        <p:txBody>
+          <a:bodyPr rtlCol="0" anchor="ctr"/>
+          <a:lstStyle/>
+          <a:p>
+            <a:pPr algn="ctr"/>
+          </a:p>
+        </p:txBody>
+      </p:sp>
+      <p:sp>
+        <p:nvSpPr>
+          <p:cNvPr id="21" name="TextBox 20"/>
+          <p:cNvSpPr txBox="1"/>
+          <p:nvPr/>
+        </p:nvSpPr>
+        <p:spPr>
+          <a:xfrm>
+            <a:off x="3314882" y="2597901"/>
+            <a:ext cx="4251960" cy="438912"/>
+          </a:xfrm>
+          <a:prstGeom prst="rect">
+            <a:avLst/>
+          </a:prstGeom>
+          <a:noFill/>
+        </p:spPr>
+        <p:txBody>
+          <a:bodyPr wrap="square" anchor="ctr" lIns="0" rIns="0" tIns="0" bIns="0">
+            <a:spAutoFit/>
+          </a:bodyPr>
+          <a:lstStyle/>
+          <a:p>
+            <a:pPr algn="l">
+              <a:lnSpc>
+                <a:spcPts val="1500"/>
+              </a:lnSpc>
+            </a:pPr>
+            <a:r>
+              <a:rPr sz="1200" b="1" i="0" spc="-12">
+                <a:solidFill>
+                  <a:srgbClr val="00754A"/>
+                </a:solidFill>
+                <a:latin typeface="Pretendard"/>
+                <a:ea typeface="Pretendard"/>
+                <a:cs typeface="Pretendard"/>
+              </a:rPr>
+              <a:t>“Search library (semantic)”  (리본: 돋보기)</a:t>
+            </a:r>
+          </a:p>
+        </p:txBody>
+      </p:sp>
+      <p:sp>
+        <p:nvSpPr>
+          <p:cNvPr id="22" name="TextBox 21"/>
+          <p:cNvSpPr txBox="1"/>
+          <p:nvPr/>
+        </p:nvSpPr>
+        <p:spPr>
+          <a:xfrm>
+            <a:off x="7932602" y="2479029"/>
+            <a:ext cx="3469782" cy="676656"/>
+          </a:xfrm>
+          <a:prstGeom prst="rect">
+            <a:avLst/>
+          </a:prstGeom>
+          <a:noFill/>
+        </p:spPr>
+        <p:txBody>
+          <a:bodyPr wrap="square" anchor="ctr" lIns="0" rIns="0" tIns="0" bIns="0">
+            <a:spAutoFit/>
+          </a:bodyPr>
+          <a:lstStyle/>
+          <a:p>
+            <a:pPr algn="l">
+              <a:lnSpc>
+                <a:spcPts val="1600"/>
+              </a:lnSpc>
+            </a:pPr>
+            <a:r>
+              <a:rPr sz="1250" b="0" i="0" spc="-12">
+                <a:solidFill>
+                  <a:srgbClr val="6B6B6B"/>
+                </a:solidFill>
+                <a:latin typeface="Pretendard"/>
+                <a:ea typeface="Pretendard"/>
+                <a:cs typeface="Pretendard"/>
+              </a:rPr>
+              <a:t>단어+뜻 하이브리드 검색, 저자·연도로 좁히기</a:t>
+            </a:r>
+          </a:p>
+        </p:txBody>
+      </p:sp>
+      <p:sp>
+        <p:nvSpPr>
+          <p:cNvPr id="23" name="Rounded Rectangle 22"/>
+          <p:cNvSpPr/>
+          <p:nvPr/>
+        </p:nvSpPr>
+        <p:spPr>
+          <a:xfrm>
+            <a:off x="663122" y="3256269"/>
+            <a:ext cx="10876422" cy="676656"/>
+          </a:xfrm>
+          <a:prstGeom prst="roundRect">
+            <a:avLst>
+              <a:gd name="adj" fmla="val 8000"/>
+            </a:avLst>
+          </a:prstGeom>
+          <a:solidFill>
+            <a:srgbClr val="FFFFFF"/>
+          </a:solidFill>
+          <a:ln w="11430">
+            <a:solidFill>
+              <a:srgbClr val="D9D9D9"/>
+            </a:solidFill>
+          </a:ln>
+          <a:effectLst/>
+        </p:spPr>
+        <p:style>
+          <a:lnRef idx="1">
+            <a:schemeClr val="accent1"/>
+          </a:lnRef>
+          <a:fillRef idx="3">
+            <a:schemeClr val="accent1"/>
+          </a:fillRef>
+          <a:effectRef idx="2">
+            <a:schemeClr val="accent1"/>
+          </a:effectRef>
+          <a:fontRef idx="minor">
+            <a:schemeClr val="lt1"/>
+          </a:fontRef>
+        </p:style>
+        <p:txBody>
+          <a:bodyPr rtlCol="0" anchor="ctr"/>
+          <a:lstStyle/>
+          <a:p>
+            <a:pPr algn="ctr"/>
+          </a:p>
+        </p:txBody>
+      </p:sp>
+      <p:sp>
+        <p:nvSpPr>
+          <p:cNvPr id="24" name="Oval 23"/>
+          <p:cNvSpPr/>
+          <p:nvPr/>
+        </p:nvSpPr>
+        <p:spPr>
+          <a:xfrm>
+            <a:off x="864290" y="3411717"/>
+            <a:ext cx="365760" cy="365760"/>
+          </a:xfrm>
+          <a:prstGeom prst="ellipse">
+            <a:avLst/>
+          </a:prstGeom>
+          <a:solidFill>
+            <a:srgbClr val="00754A"/>
+          </a:solidFill>
+          <a:ln>
+            <a:noFill/>
+          </a:ln>
+          <a:effectLst/>
+        </p:spPr>
+        <p:style>
+          <a:lnRef idx="1">
+            <a:schemeClr val="accent1"/>
+          </a:lnRef>
+          <a:fillRef idx="3">
+            <a:schemeClr val="accent1"/>
+          </a:fillRef>
+          <a:effectRef idx="2">
+            <a:schemeClr val="accent1"/>
+          </a:effectRef>
+          <a:fontRef idx="minor">
+            <a:schemeClr val="lt1"/>
+          </a:fontRef>
+        </p:style>
+        <p:txBody>
+          <a:bodyPr rtlCol="0" anchor="ctr"/>
+          <a:lstStyle/>
+          <a:p>
+            <a:pPr algn="ctr"/>
+          </a:p>
+        </p:txBody>
+      </p:sp>
+      <p:sp>
+        <p:nvSpPr>
+          <p:cNvPr id="25" name="TextBox 24"/>
+          <p:cNvSpPr txBox="1"/>
+          <p:nvPr/>
+        </p:nvSpPr>
+        <p:spPr>
+          <a:xfrm>
+            <a:off x="864290" y="3411717"/>
+            <a:ext cx="365760" cy="365760"/>
+          </a:xfrm>
+          <a:prstGeom prst="rect">
+            <a:avLst/>
+          </a:prstGeom>
+          <a:noFill/>
+        </p:spPr>
+        <p:txBody>
+          <a:bodyPr wrap="square" anchor="ctr" lIns="0" rIns="0" tIns="0" bIns="0">
+            <a:spAutoFit/>
+          </a:bodyPr>
+          <a:lstStyle/>
+          <a:p>
+            <a:pPr algn="ctr"/>
+            <a:r>
+              <a:rPr sz="1500" b="1" i="0" spc="-15">
+                <a:solidFill>
+                  <a:srgbClr val="FFFFFF"/>
+                </a:solidFill>
+                <a:latin typeface="Pretendard"/>
+                <a:ea typeface="Pretendard"/>
+                <a:cs typeface="Pretendard"/>
+              </a:rPr>
+              <a:t>3</a:t>
+            </a:r>
+          </a:p>
+        </p:txBody>
+      </p:sp>
+      <p:sp>
+        <p:nvSpPr>
+          <p:cNvPr id="26" name="TextBox 25"/>
+          <p:cNvSpPr txBox="1"/>
+          <p:nvPr/>
+        </p:nvSpPr>
+        <p:spPr>
+          <a:xfrm>
+            <a:off x="1348922" y="3256269"/>
+            <a:ext cx="1783080" cy="676656"/>
+          </a:xfrm>
+          <a:prstGeom prst="rect">
+            <a:avLst/>
+          </a:prstGeom>
+          <a:noFill/>
+        </p:spPr>
+        <p:txBody>
+          <a:bodyPr wrap="square" anchor="ctr" lIns="0" rIns="0" tIns="0" bIns="0">
+            <a:spAutoFit/>
+          </a:bodyPr>
+          <a:lstStyle/>
+          <a:p>
+            <a:pPr algn="l">
+              <a:lnSpc>
+                <a:spcPts val="1800"/>
+              </a:lnSpc>
+            </a:pPr>
+            <a:r>
+              <a:rPr sz="1500" b="1" i="0" spc="-15">
+                <a:solidFill>
+                  <a:srgbClr val="006241"/>
+                </a:solidFill>
+                <a:latin typeface="Pretendard"/>
+                <a:ea typeface="Pretendard"/>
+                <a:cs typeface="Pretendard"/>
+              </a:rPr>
+              <a:t>서재에 질문</a:t>
+            </a:r>
+          </a:p>
+        </p:txBody>
+      </p:sp>
+      <p:sp>
+        <p:nvSpPr>
+          <p:cNvPr id="27" name="Rounded Rectangle 26"/>
+          <p:cNvSpPr/>
+          <p:nvPr/>
+        </p:nvSpPr>
+        <p:spPr>
+          <a:xfrm>
+            <a:off x="3177722" y="3375141"/>
+            <a:ext cx="4526280" cy="438912"/>
+          </a:xfrm>
+          <a:prstGeom prst="roundRect">
+            <a:avLst>
+              <a:gd name="adj" fmla="val 12000"/>
+            </a:avLst>
+          </a:prstGeom>
+          <a:solidFill>
+            <a:srgbClr val="F2F0EB"/>
+          </a:solidFill>
+          <a:ln>
+            <a:noFill/>
+          </a:ln>
+          <a:effectLst/>
+        </p:spPr>
+        <p:style>
+          <a:lnRef idx="1">
+            <a:schemeClr val="accent1"/>
+          </a:lnRef>
+          <a:fillRef idx="3">
+            <a:schemeClr val="accent1"/>
+          </a:fillRef>
+          <a:effectRef idx="2">
+            <a:schemeClr val="accent1"/>
+          </a:effectRef>
+          <a:fontRef idx="minor">
+            <a:schemeClr val="lt1"/>
+          </a:fontRef>
+        </p:style>
+        <p:txBody>
+          <a:bodyPr rtlCol="0" anchor="ctr"/>
+          <a:lstStyle/>
+          <a:p>
+            <a:pPr algn="ctr"/>
+          </a:p>
+        </p:txBody>
+      </p:sp>
+      <p:sp>
+        <p:nvSpPr>
+          <p:cNvPr id="28" name="TextBox 27"/>
+          <p:cNvSpPr txBox="1"/>
+          <p:nvPr/>
+        </p:nvSpPr>
+        <p:spPr>
+          <a:xfrm>
+            <a:off x="3314882" y="3375141"/>
+            <a:ext cx="4251960" cy="438912"/>
+          </a:xfrm>
+          <a:prstGeom prst="rect">
+            <a:avLst/>
+          </a:prstGeom>
+          <a:noFill/>
+        </p:spPr>
+        <p:txBody>
+          <a:bodyPr wrap="square" anchor="ctr" lIns="0" rIns="0" tIns="0" bIns="0">
+            <a:spAutoFit/>
+          </a:bodyPr>
+          <a:lstStyle/>
+          <a:p>
+            <a:pPr algn="l">
+              <a:lnSpc>
+                <a:spcPts val="1500"/>
+              </a:lnSpc>
+            </a:pPr>
+            <a:r>
+              <a:rPr sz="1200" b="1" i="0" spc="-12">
+                <a:solidFill>
+                  <a:srgbClr val="00754A"/>
+                </a:solidFill>
+                <a:latin typeface="Pretendard"/>
+                <a:ea typeface="Pretendard"/>
+                <a:cs typeface="Pretendard"/>
+              </a:rPr>
+              <a:t>“Chat with library”  (리본: 말풍선)</a:t>
+            </a:r>
+          </a:p>
+        </p:txBody>
+      </p:sp>
+      <p:sp>
+        <p:nvSpPr>
+          <p:cNvPr id="29" name="TextBox 28"/>
+          <p:cNvSpPr txBox="1"/>
+          <p:nvPr/>
+        </p:nvSpPr>
+        <p:spPr>
+          <a:xfrm>
+            <a:off x="7932602" y="3256269"/>
+            <a:ext cx="3469782" cy="676656"/>
+          </a:xfrm>
+          <a:prstGeom prst="rect">
+            <a:avLst/>
+          </a:prstGeom>
+          <a:noFill/>
+        </p:spPr>
+        <p:txBody>
+          <a:bodyPr wrap="square" anchor="ctr" lIns="0" rIns="0" tIns="0" bIns="0">
+            <a:spAutoFit/>
+          </a:bodyPr>
+          <a:lstStyle/>
+          <a:p>
+            <a:pPr algn="l">
+              <a:lnSpc>
+                <a:spcPts val="1600"/>
+              </a:lnSpc>
+            </a:pPr>
+            <a:r>
+              <a:rPr sz="1250" b="0" i="0" spc="-12">
+                <a:solidFill>
+                  <a:srgbClr val="6B6B6B"/>
+                </a:solidFill>
+                <a:latin typeface="Pretendard"/>
+                <a:ea typeface="Pretendard"/>
+                <a:cs typeface="Pretendard"/>
+              </a:rPr>
+              <a:t>출처 [n] 달린 답 — [n] 클릭하면 원문 노트로</a:t>
+            </a:r>
+          </a:p>
+        </p:txBody>
+      </p:sp>
+      <p:sp>
+        <p:nvSpPr>
+          <p:cNvPr id="30" name="Rounded Rectangle 29"/>
+          <p:cNvSpPr/>
+          <p:nvPr/>
+        </p:nvSpPr>
+        <p:spPr>
+          <a:xfrm>
+            <a:off x="663122" y="4033509"/>
+            <a:ext cx="10876422" cy="676656"/>
+          </a:xfrm>
+          <a:prstGeom prst="roundRect">
+            <a:avLst>
+              <a:gd name="adj" fmla="val 8000"/>
+            </a:avLst>
+          </a:prstGeom>
+          <a:solidFill>
+            <a:srgbClr val="FFFFFF"/>
+          </a:solidFill>
+          <a:ln w="11430">
+            <a:solidFill>
+              <a:srgbClr val="D9D9D9"/>
+            </a:solidFill>
+          </a:ln>
+          <a:effectLst/>
+        </p:spPr>
+        <p:style>
+          <a:lnRef idx="1">
+            <a:schemeClr val="accent1"/>
+          </a:lnRef>
+          <a:fillRef idx="3">
+            <a:schemeClr val="accent1"/>
+          </a:fillRef>
+          <a:effectRef idx="2">
+            <a:schemeClr val="accent1"/>
+          </a:effectRef>
+          <a:fontRef idx="minor">
+            <a:schemeClr val="lt1"/>
+          </a:fontRef>
+        </p:style>
+        <p:txBody>
+          <a:bodyPr rtlCol="0" anchor="ctr"/>
+          <a:lstStyle/>
+          <a:p>
+            <a:pPr algn="ctr"/>
+          </a:p>
+        </p:txBody>
+      </p:sp>
+      <p:sp>
+        <p:nvSpPr>
+          <p:cNvPr id="31" name="Oval 30"/>
+          <p:cNvSpPr/>
+          <p:nvPr/>
+        </p:nvSpPr>
+        <p:spPr>
+          <a:xfrm>
+            <a:off x="864290" y="4188957"/>
+            <a:ext cx="365760" cy="365760"/>
+          </a:xfrm>
+          <a:prstGeom prst="ellipse">
+            <a:avLst/>
+          </a:prstGeom>
+          <a:solidFill>
+            <a:srgbClr val="00754A"/>
+          </a:solidFill>
+          <a:ln>
+            <a:noFill/>
+          </a:ln>
+          <a:effectLst/>
+        </p:spPr>
+        <p:style>
+          <a:lnRef idx="1">
+            <a:schemeClr val="accent1"/>
+          </a:lnRef>
+          <a:fillRef idx="3">
+            <a:schemeClr val="accent1"/>
+          </a:fillRef>
+          <a:effectRef idx="2">
+            <a:schemeClr val="accent1"/>
+          </a:effectRef>
+          <a:fontRef idx="minor">
+            <a:schemeClr val="lt1"/>
+          </a:fontRef>
+        </p:style>
+        <p:txBody>
+          <a:bodyPr rtlCol="0" anchor="ctr"/>
+          <a:lstStyle/>
+          <a:p>
+            <a:pPr algn="ctr"/>
+          </a:p>
+        </p:txBody>
+      </p:sp>
+      <p:sp>
+        <p:nvSpPr>
+          <p:cNvPr id="32" name="TextBox 31"/>
+          <p:cNvSpPr txBox="1"/>
+          <p:nvPr/>
+        </p:nvSpPr>
+        <p:spPr>
+          <a:xfrm>
+            <a:off x="864290" y="4188957"/>
+            <a:ext cx="365760" cy="365760"/>
+          </a:xfrm>
+          <a:prstGeom prst="rect">
+            <a:avLst/>
+          </a:prstGeom>
+          <a:noFill/>
+        </p:spPr>
+        <p:txBody>
+          <a:bodyPr wrap="square" anchor="ctr" lIns="0" rIns="0" tIns="0" bIns="0">
+            <a:spAutoFit/>
+          </a:bodyPr>
+          <a:lstStyle/>
+          <a:p>
+            <a:pPr algn="ctr"/>
+            <a:r>
+              <a:rPr sz="1500" b="1" i="0" spc="-15">
+                <a:solidFill>
+                  <a:srgbClr val="FFFFFF"/>
+                </a:solidFill>
+                <a:latin typeface="Pretendard"/>
+                <a:ea typeface="Pretendard"/>
+                <a:cs typeface="Pretendard"/>
+              </a:rPr>
+              <a:t>4</a:t>
+            </a:r>
+          </a:p>
+        </p:txBody>
+      </p:sp>
+      <p:sp>
+        <p:nvSpPr>
+          <p:cNvPr id="33" name="TextBox 32"/>
+          <p:cNvSpPr txBox="1"/>
+          <p:nvPr/>
+        </p:nvSpPr>
+        <p:spPr>
+          <a:xfrm>
+            <a:off x="1348922" y="4033509"/>
+            <a:ext cx="1783080" cy="676656"/>
+          </a:xfrm>
+          <a:prstGeom prst="rect">
+            <a:avLst/>
+          </a:prstGeom>
+          <a:noFill/>
+        </p:spPr>
+        <p:txBody>
+          <a:bodyPr wrap="square" anchor="ctr" lIns="0" rIns="0" tIns="0" bIns="0">
+            <a:spAutoFit/>
+          </a:bodyPr>
+          <a:lstStyle/>
+          <a:p>
+            <a:pPr algn="l">
+              <a:lnSpc>
+                <a:spcPts val="1800"/>
+              </a:lnSpc>
+            </a:pPr>
+            <a:r>
+              <a:rPr sz="1500" b="1" i="0" spc="-15">
+                <a:solidFill>
+                  <a:srgbClr val="006241"/>
+                </a:solidFill>
+                <a:latin typeface="Pretendard"/>
+                <a:ea typeface="Pretendard"/>
+                <a:cs typeface="Pretendard"/>
+              </a:rPr>
+              <a:t>글 쓰며 인용</a:t>
+            </a:r>
+          </a:p>
+        </p:txBody>
+      </p:sp>
+      <p:sp>
+        <p:nvSpPr>
+          <p:cNvPr id="34" name="Rounded Rectangle 33"/>
+          <p:cNvSpPr/>
+          <p:nvPr/>
+        </p:nvSpPr>
+        <p:spPr>
+          <a:xfrm>
+            <a:off x="3177722" y="4152381"/>
+            <a:ext cx="4526280" cy="438912"/>
+          </a:xfrm>
+          <a:prstGeom prst="roundRect">
+            <a:avLst>
+              <a:gd name="adj" fmla="val 12000"/>
+            </a:avLst>
+          </a:prstGeom>
+          <a:solidFill>
+            <a:srgbClr val="F2F0EB"/>
+          </a:solidFill>
+          <a:ln>
+            <a:noFill/>
+          </a:ln>
+          <a:effectLst/>
+        </p:spPr>
+        <p:style>
+          <a:lnRef idx="1">
+            <a:schemeClr val="accent1"/>
+          </a:lnRef>
+          <a:fillRef idx="3">
+            <a:schemeClr val="accent1"/>
+          </a:fillRef>
+          <a:effectRef idx="2">
+            <a:schemeClr val="accent1"/>
+          </a:effectRef>
+          <a:fontRef idx="minor">
+            <a:schemeClr val="lt1"/>
+          </a:fontRef>
+        </p:style>
+        <p:txBody>
+          <a:bodyPr rtlCol="0" anchor="ctr"/>
+          <a:lstStyle/>
+          <a:p>
+            <a:pPr algn="ctr"/>
+          </a:p>
+        </p:txBody>
+      </p:sp>
+      <p:sp>
+        <p:nvSpPr>
+          <p:cNvPr id="35" name="TextBox 34"/>
+          <p:cNvSpPr txBox="1"/>
+          <p:nvPr/>
+        </p:nvSpPr>
+        <p:spPr>
+          <a:xfrm>
+            <a:off x="3314882" y="4152381"/>
+            <a:ext cx="4251960" cy="438912"/>
+          </a:xfrm>
+          <a:prstGeom prst="rect">
+            <a:avLst/>
+          </a:prstGeom>
+          <a:noFill/>
+        </p:spPr>
+        <p:txBody>
+          <a:bodyPr wrap="square" anchor="ctr" lIns="0" rIns="0" tIns="0" bIns="0">
+            <a:spAutoFit/>
+          </a:bodyPr>
+          <a:lstStyle/>
+          <a:p>
+            <a:pPr algn="l">
+              <a:lnSpc>
+                <a:spcPts val="1500"/>
+              </a:lnSpc>
+            </a:pPr>
+            <a:r>
+              <a:rPr sz="1200" b="1" i="0" spc="-12">
+                <a:solidFill>
+                  <a:srgbClr val="00754A"/>
+                </a:solidFill>
+                <a:latin typeface="Pretendard"/>
+                <a:ea typeface="Pretendard"/>
+                <a:cs typeface="Pretendard"/>
+              </a:rPr>
+              <a:t>본문에서  @  입력</a:t>
+            </a:r>
+          </a:p>
+        </p:txBody>
+      </p:sp>
+      <p:sp>
+        <p:nvSpPr>
+          <p:cNvPr id="36" name="TextBox 35"/>
+          <p:cNvSpPr txBox="1"/>
+          <p:nvPr/>
+        </p:nvSpPr>
+        <p:spPr>
+          <a:xfrm>
+            <a:off x="7932602" y="4033509"/>
+            <a:ext cx="3469782" cy="676656"/>
+          </a:xfrm>
+          <a:prstGeom prst="rect">
+            <a:avLst/>
+          </a:prstGeom>
+          <a:noFill/>
+        </p:spPr>
+        <p:txBody>
+          <a:bodyPr wrap="square" anchor="ctr" lIns="0" rIns="0" tIns="0" bIns="0">
+            <a:spAutoFit/>
+          </a:bodyPr>
+          <a:lstStyle/>
+          <a:p>
+            <a:pPr algn="l">
+              <a:lnSpc>
+                <a:spcPts val="1600"/>
+              </a:lnSpc>
+            </a:pPr>
+            <a:r>
+              <a:rPr sz="1250" b="0" i="0" spc="-12">
+                <a:solidFill>
+                  <a:srgbClr val="6B6B6B"/>
+                </a:solidFill>
+                <a:latin typeface="Pretendard"/>
+                <a:ea typeface="Pretendard"/>
+                <a:cs typeface="Pretendard"/>
+              </a:rPr>
+              <a:t>제목·저자로 골라 [@citekey] 자동완성 삽입</a:t>
+            </a:r>
+          </a:p>
+        </p:txBody>
+      </p:sp>
+      <p:sp>
+        <p:nvSpPr>
+          <p:cNvPr id="37" name="Rounded Rectangle 36"/>
+          <p:cNvSpPr/>
+          <p:nvPr/>
+        </p:nvSpPr>
+        <p:spPr>
+          <a:xfrm>
+            <a:off x="663122" y="4810749"/>
+            <a:ext cx="10876422" cy="676656"/>
+          </a:xfrm>
+          <a:prstGeom prst="roundRect">
+            <a:avLst>
+              <a:gd name="adj" fmla="val 8000"/>
+            </a:avLst>
+          </a:prstGeom>
+          <a:solidFill>
+            <a:srgbClr val="FFFFFF"/>
+          </a:solidFill>
+          <a:ln w="11430">
+            <a:solidFill>
+              <a:srgbClr val="D9D9D9"/>
+            </a:solidFill>
+          </a:ln>
+          <a:effectLst/>
+        </p:spPr>
+        <p:style>
+          <a:lnRef idx="1">
+            <a:schemeClr val="accent1"/>
+          </a:lnRef>
+          <a:fillRef idx="3">
+            <a:schemeClr val="accent1"/>
+          </a:fillRef>
+          <a:effectRef idx="2">
+            <a:schemeClr val="accent1"/>
+          </a:effectRef>
+          <a:fontRef idx="minor">
+            <a:schemeClr val="lt1"/>
+          </a:fontRef>
+        </p:style>
+        <p:txBody>
+          <a:bodyPr rtlCol="0" anchor="ctr"/>
+          <a:lstStyle/>
+          <a:p>
+            <a:pPr algn="ctr"/>
+          </a:p>
+        </p:txBody>
+      </p:sp>
+      <p:sp>
+        <p:nvSpPr>
+          <p:cNvPr id="38" name="Oval 37"/>
+          <p:cNvSpPr/>
+          <p:nvPr/>
+        </p:nvSpPr>
+        <p:spPr>
+          <a:xfrm>
+            <a:off x="864290" y="4966197"/>
+            <a:ext cx="365760" cy="365760"/>
+          </a:xfrm>
+          <a:prstGeom prst="ellipse">
+            <a:avLst/>
+          </a:prstGeom>
+          <a:solidFill>
+            <a:srgbClr val="00754A"/>
+          </a:solidFill>
+          <a:ln>
+            <a:noFill/>
+          </a:ln>
+          <a:effectLst/>
+        </p:spPr>
+        <p:style>
+          <a:lnRef idx="1">
+            <a:schemeClr val="accent1"/>
+          </a:lnRef>
+          <a:fillRef idx="3">
+            <a:schemeClr val="accent1"/>
+          </a:fillRef>
+          <a:effectRef idx="2">
+            <a:schemeClr val="accent1"/>
+          </a:effectRef>
+          <a:fontRef idx="minor">
+            <a:schemeClr val="lt1"/>
+          </a:fontRef>
+        </p:style>
+        <p:txBody>
+          <a:bodyPr rtlCol="0" anchor="ctr"/>
+          <a:lstStyle/>
+          <a:p>
+            <a:pPr algn="ctr"/>
+          </a:p>
+        </p:txBody>
+      </p:sp>
+      <p:sp>
+        <p:nvSpPr>
+          <p:cNvPr id="39" name="TextBox 38"/>
+          <p:cNvSpPr txBox="1"/>
+          <p:nvPr/>
+        </p:nvSpPr>
+        <p:spPr>
+          <a:xfrm>
+            <a:off x="864290" y="4966197"/>
+            <a:ext cx="365760" cy="365760"/>
+          </a:xfrm>
+          <a:prstGeom prst="rect">
+            <a:avLst/>
+          </a:prstGeom>
+          <a:noFill/>
+        </p:spPr>
+        <p:txBody>
+          <a:bodyPr wrap="square" anchor="ctr" lIns="0" rIns="0" tIns="0" bIns="0">
+            <a:spAutoFit/>
+          </a:bodyPr>
+          <a:lstStyle/>
+          <a:p>
+            <a:pPr algn="ctr"/>
+            <a:r>
+              <a:rPr sz="1500" b="1" i="0" spc="-15">
+                <a:solidFill>
+                  <a:srgbClr val="FFFFFF"/>
+                </a:solidFill>
+                <a:latin typeface="Pretendard"/>
+                <a:ea typeface="Pretendard"/>
+                <a:cs typeface="Pretendard"/>
+              </a:rPr>
+              <a:t>5</a:t>
+            </a:r>
+          </a:p>
+        </p:txBody>
+      </p:sp>
+      <p:sp>
+        <p:nvSpPr>
+          <p:cNvPr id="40" name="TextBox 39"/>
+          <p:cNvSpPr txBox="1"/>
+          <p:nvPr/>
+        </p:nvSpPr>
+        <p:spPr>
+          <a:xfrm>
+            <a:off x="1348922" y="4810749"/>
+            <a:ext cx="1783080" cy="676656"/>
+          </a:xfrm>
+          <a:prstGeom prst="rect">
+            <a:avLst/>
+          </a:prstGeom>
+          <a:noFill/>
+        </p:spPr>
+        <p:txBody>
+          <a:bodyPr wrap="square" anchor="ctr" lIns="0" rIns="0" tIns="0" bIns="0">
+            <a:spAutoFit/>
+          </a:bodyPr>
+          <a:lstStyle/>
+          <a:p>
+            <a:pPr algn="l">
+              <a:lnSpc>
+                <a:spcPts val="1800"/>
+              </a:lnSpc>
+            </a:pPr>
+            <a:r>
+              <a:rPr sz="1500" b="1" i="0" spc="-15">
+                <a:solidFill>
+                  <a:srgbClr val="006241"/>
+                </a:solidFill>
+                <a:latin typeface="Pretendard"/>
+                <a:ea typeface="Pretendard"/>
+                <a:cs typeface="Pretendard"/>
+              </a:rPr>
+              <a:t>참고문헌 생성</a:t>
+            </a:r>
+          </a:p>
+        </p:txBody>
+      </p:sp>
+      <p:sp>
+        <p:nvSpPr>
+          <p:cNvPr id="41" name="Rounded Rectangle 40"/>
+          <p:cNvSpPr/>
+          <p:nvPr/>
+        </p:nvSpPr>
+        <p:spPr>
+          <a:xfrm>
+            <a:off x="3177722" y="4929621"/>
+            <a:ext cx="4526280" cy="438912"/>
+          </a:xfrm>
+          <a:prstGeom prst="roundRect">
+            <a:avLst>
+              <a:gd name="adj" fmla="val 12000"/>
+            </a:avLst>
+          </a:prstGeom>
+          <a:solidFill>
+            <a:srgbClr val="F2F0EB"/>
+          </a:solidFill>
+          <a:ln>
+            <a:noFill/>
+          </a:ln>
+          <a:effectLst/>
+        </p:spPr>
+        <p:style>
+          <a:lnRef idx="1">
+            <a:schemeClr val="accent1"/>
+          </a:lnRef>
+          <a:fillRef idx="3">
+            <a:schemeClr val="accent1"/>
+          </a:fillRef>
+          <a:effectRef idx="2">
+            <a:schemeClr val="accent1"/>
+          </a:effectRef>
+          <a:fontRef idx="minor">
+            <a:schemeClr val="lt1"/>
+          </a:fontRef>
+        </p:style>
+        <p:txBody>
+          <a:bodyPr rtlCol="0" anchor="ctr"/>
+          <a:lstStyle/>
+          <a:p>
+            <a:pPr algn="ctr"/>
+          </a:p>
+        </p:txBody>
+      </p:sp>
+      <p:sp>
+        <p:nvSpPr>
+          <p:cNvPr id="42" name="TextBox 41"/>
+          <p:cNvSpPr txBox="1"/>
+          <p:nvPr/>
+        </p:nvSpPr>
+        <p:spPr>
+          <a:xfrm>
+            <a:off x="3314882" y="4929621"/>
+            <a:ext cx="4251960" cy="438912"/>
+          </a:xfrm>
+          <a:prstGeom prst="rect">
+            <a:avLst/>
+          </a:prstGeom>
+          <a:noFill/>
+        </p:spPr>
+        <p:txBody>
+          <a:bodyPr wrap="square" anchor="ctr" lIns="0" rIns="0" tIns="0" bIns="0">
+            <a:spAutoFit/>
+          </a:bodyPr>
+          <a:lstStyle/>
+          <a:p>
+            <a:pPr algn="l">
+              <a:lnSpc>
+                <a:spcPts val="1500"/>
+              </a:lnSpc>
+            </a:pPr>
+            <a:r>
+              <a:rPr sz="1200" b="1" i="0" spc="-12">
+                <a:solidFill>
+                  <a:srgbClr val="00754A"/>
+                </a:solidFill>
+                <a:latin typeface="Pretendard"/>
+                <a:ea typeface="Pretendard"/>
+                <a:cs typeface="Pretendard"/>
+              </a:rPr>
+              <a:t>“Update bibliography in current note”</a:t>
+            </a:r>
+          </a:p>
+        </p:txBody>
+      </p:sp>
+      <p:sp>
+        <p:nvSpPr>
+          <p:cNvPr id="43" name="TextBox 42"/>
+          <p:cNvSpPr txBox="1"/>
+          <p:nvPr/>
+        </p:nvSpPr>
+        <p:spPr>
+          <a:xfrm>
+            <a:off x="7932602" y="4810749"/>
+            <a:ext cx="3469782" cy="676656"/>
+          </a:xfrm>
+          <a:prstGeom prst="rect">
+            <a:avLst/>
+          </a:prstGeom>
+          <a:noFill/>
+        </p:spPr>
+        <p:txBody>
+          <a:bodyPr wrap="square" anchor="ctr" lIns="0" rIns="0" tIns="0" bIns="0">
+            <a:spAutoFit/>
+          </a:bodyPr>
+          <a:lstStyle/>
+          <a:p>
+            <a:pPr algn="l">
+              <a:lnSpc>
+                <a:spcPts val="1600"/>
+              </a:lnSpc>
+            </a:pPr>
+            <a:r>
+              <a:rPr sz="1250" b="0" i="0" spc="-12">
+                <a:solidFill>
+                  <a:srgbClr val="6B6B6B"/>
+                </a:solidFill>
+                <a:latin typeface="Pretendard"/>
+                <a:ea typeface="Pretendard"/>
+                <a:cs typeface="Pretendard"/>
+              </a:rPr>
+              <a:t>## References를 저널 스타일(APA·Vancouver·CSL)로 자동 생성</a:t>
+            </a:r>
+          </a:p>
+        </p:txBody>
+      </p:sp>
+      <p:sp>
+        <p:nvSpPr>
+          <p:cNvPr id="44" name="Rounded Rectangle 43"/>
+          <p:cNvSpPr/>
+          <p:nvPr/>
+        </p:nvSpPr>
+        <p:spPr>
+          <a:xfrm>
+            <a:off x="571682" y="5859292"/>
+            <a:ext cx="11059302" cy="457200"/>
+          </a:xfrm>
+          <a:prstGeom prst="roundRect">
+            <a:avLst>
+              <a:gd name="adj" fmla="val 18000"/>
+            </a:avLst>
+          </a:prstGeom>
+          <a:solidFill>
+            <a:srgbClr val="1E3932"/>
+          </a:solidFill>
+          <a:ln>
+            <a:noFill/>
+          </a:ln>
+          <a:effectLst/>
+        </p:spPr>
+        <p:style>
+          <a:lnRef idx="1">
+            <a:schemeClr val="accent1"/>
+          </a:lnRef>
+          <a:fillRef idx="3">
+            <a:schemeClr val="accent1"/>
+          </a:fillRef>
+          <a:effectRef idx="2">
+            <a:schemeClr val="accent1"/>
+          </a:effectRef>
+          <a:fontRef idx="minor">
+            <a:schemeClr val="lt1"/>
+          </a:fontRef>
+        </p:style>
+        <p:txBody>
+          <a:bodyPr rtlCol="0" anchor="ctr"/>
+          <a:lstStyle/>
+          <a:p>
+            <a:pPr algn="ctr"/>
+          </a:p>
+        </p:txBody>
+      </p:sp>
+      <p:sp>
+        <p:nvSpPr>
+          <p:cNvPr id="45" name="TextBox 44"/>
+          <p:cNvSpPr txBox="1"/>
+          <p:nvPr/>
+        </p:nvSpPr>
+        <p:spPr>
+          <a:xfrm>
+            <a:off x="800282" y="5859292"/>
+            <a:ext cx="10602102" cy="457200"/>
+          </a:xfrm>
+          <a:prstGeom prst="rect">
+            <a:avLst/>
+          </a:prstGeom>
+          <a:noFill/>
+        </p:spPr>
+        <p:txBody>
+          <a:bodyPr wrap="square" anchor="ctr" lIns="0" rIns="0" tIns="0" bIns="0">
+            <a:spAutoFit/>
+          </a:bodyPr>
+          <a:lstStyle/>
+          <a:p>
+            <a:pPr algn="l"/>
+            <a:r>
+              <a:rPr sz="1400" b="1" i="0" spc="-14">
+                <a:solidFill>
+                  <a:srgbClr val="FFFFFF"/>
+                </a:solidFill>
+                <a:latin typeface="Pretendard"/>
+                <a:ea typeface="Pretendard"/>
+                <a:cs typeface="Pretendard"/>
+              </a:rPr>
+              <a:t>전부 Cmd+P 한 곳에서 — 처음 딱 한 번 “Rebuild search index”로 색인만 만들어 두면 끝</a:t>
+            </a:r>
+          </a:p>
+        </p:txBody>
+      </p:sp>
+    </p:spTree>
+  </p:cSld>
+  <p:clrMapOvr>
+    <a:masterClrMapping/>
+  </p:clrMapOvr>
+</p:sld>
+</file>
+
+<file path=ppt/slides/slide16.xml><?xml version="1.0" encoding="utf-8"?>
+<p:sld xmlns:a="http://schemas.openxmlformats.org/drawingml/2006/main" xmlns:p="http://schemas.openxmlformats.org/presentationml/2006/main" xmlns:r="http://schemas.openxmlformats.org/officeDocument/2006/relationships">
+  <p:cSld>
+    <p:spTree>
+      <p:nvGrpSpPr>
+        <p:cNvPr id="1" name=""/>
+        <p:cNvGrpSpPr/>
+        <p:nvPr/>
+      </p:nvGrpSpPr>
+      <p:grpSpPr/>
+      <p:sp>
+        <p:nvSpPr>
+          <p:cNvPr id="2" name="Rectangle 1"/>
+          <p:cNvSpPr/>
+          <p:nvPr/>
+        </p:nvSpPr>
+        <p:spPr>
+          <a:xfrm>
+            <a:off x="0" y="0"/>
+            <a:ext cx="12191695" cy="6858000"/>
+          </a:xfrm>
+          <a:prstGeom prst="rect">
+            <a:avLst/>
+          </a:prstGeom>
+          <a:solidFill>
+            <a:srgbClr val="F2F0EB"/>
+          </a:solidFill>
+          <a:ln>
+            <a:noFill/>
+          </a:ln>
+          <a:effectLst/>
+        </p:spPr>
+        <p:style>
+          <a:lnRef idx="1">
+            <a:schemeClr val="accent1"/>
+          </a:lnRef>
+          <a:fillRef idx="3">
+            <a:schemeClr val="accent1"/>
+          </a:fillRef>
+          <a:effectRef idx="2">
+            <a:schemeClr val="accent1"/>
+          </a:effectRef>
+          <a:fontRef idx="minor">
+            <a:schemeClr val="lt1"/>
+          </a:fontRef>
+        </p:style>
+        <p:txBody>
+          <a:bodyPr rtlCol="0" anchor="ctr"/>
+          <a:lstStyle/>
+          <a:p>
+            <a:pPr algn="ctr"/>
+          </a:p>
+        </p:txBody>
+      </p:sp>
+      <p:sp>
+        <p:nvSpPr>
+          <p:cNvPr id="3" name="TextBox 2"/>
+          <p:cNvSpPr txBox="1"/>
+          <p:nvPr/>
+        </p:nvSpPr>
+        <p:spPr>
+          <a:xfrm>
+            <a:off x="138257" y="123444"/>
+            <a:ext cx="5486400" cy="256032"/>
+          </a:xfrm>
+          <a:prstGeom prst="rect">
+            <a:avLst/>
+          </a:prstGeom>
+          <a:noFill/>
+        </p:spPr>
+        <p:txBody>
+          <a:bodyPr wrap="square" anchor="t" lIns="0" rIns="0" tIns="0" bIns="0">
+            <a:spAutoFit/>
+          </a:bodyPr>
+          <a:lstStyle/>
+          <a:p>
+            <a:pPr algn="l"/>
+            <a:r>
+              <a:rPr sz="1100" b="1" i="0" spc="-11">
+                <a:solidFill>
+                  <a:srgbClr val="8E8E93"/>
+                </a:solidFill>
+                <a:latin typeface="Pretendard"/>
+                <a:ea typeface="Pretendard"/>
+                <a:cs typeface="Pretendard"/>
+              </a:rPr>
+              <a:t>CONCLUSION</a:t>
+            </a:r>
+          </a:p>
+        </p:txBody>
+      </p:sp>
+      <p:sp>
+        <p:nvSpPr>
+          <p:cNvPr id="4" name="TextBox 3"/>
+          <p:cNvSpPr txBox="1"/>
+          <p:nvPr/>
+        </p:nvSpPr>
+        <p:spPr>
+          <a:xfrm>
+            <a:off x="251642" y="436260"/>
+            <a:ext cx="10972800" cy="640080"/>
+          </a:xfrm>
+          <a:prstGeom prst="rect">
+            <a:avLst/>
+          </a:prstGeom>
+          <a:noFill/>
+        </p:spPr>
+        <p:txBody>
+          <a:bodyPr wrap="square" anchor="t" lIns="0" rIns="0" tIns="0" bIns="0">
+            <a:spAutoFit/>
+          </a:bodyPr>
+          <a:lstStyle/>
+          <a:p>
+            <a:pPr algn="l">
+              <a:lnSpc>
+                <a:spcPts val="3600"/>
+              </a:lnSpc>
+            </a:pPr>
+            <a:r>
+              <a:rPr sz="3000" b="1" i="0" spc="-30">
+                <a:solidFill>
+                  <a:srgbClr val="006241"/>
+                </a:solidFill>
+                <a:latin typeface="Pretendard"/>
+                <a:ea typeface="Pretendard"/>
+                <a:cs typeface="Pretendard"/>
+              </a:rPr>
+              <a:t>Zotero 없이, 서버 없이, 늘 출처와 함께</a:t>
+            </a:r>
+          </a:p>
+        </p:txBody>
+      </p:sp>
+      <p:pic>
+        <p:nvPicPr>
+          <p:cNvPr id="5" name="Picture 4" descr="logo.png"/>
+          <p:cNvPicPr>
+            <a:picLocks noChangeAspect="1"/>
+          </p:cNvPicPr>
+          <p:nvPr/>
+        </p:nvPicPr>
+        <p:blipFill>
+          <a:blip r:embed="rId2"/>
+          <a:srcRect l="3240" r="16360" t="21390" b="11330"/>
+          <a:stretch>
+            <a:fillRect/>
+          </a:stretch>
+        </p:blipFill>
+        <p:spPr>
+          <a:xfrm>
+            <a:off x="10748314" y="11978"/>
+            <a:ext cx="1443654" cy="798545"/>
+          </a:xfrm>
+          <a:prstGeom prst="rect">
+            <a:avLst/>
+          </a:prstGeom>
+        </p:spPr>
+      </p:pic>
+      <p:sp>
+        <p:nvSpPr>
+          <p:cNvPr id="6" name="Rounded Rectangle 5"/>
+          <p:cNvSpPr/>
+          <p:nvPr/>
+        </p:nvSpPr>
+        <p:spPr>
+          <a:xfrm>
+            <a:off x="251642" y="1290309"/>
+            <a:ext cx="11699382" cy="5227350"/>
+          </a:xfrm>
+          <a:prstGeom prst="roundRect">
+            <a:avLst>
+              <a:gd name="adj" fmla="val 3500"/>
             </a:avLst>
           </a:prstGeom>
           <a:solidFill>
@@ -8312,217 +10088,50 @@
       </p:sp>
       <p:sp>
         <p:nvSpPr>
-          <p:cNvPr id="9" name="Rectangle 8"/>
+          <p:cNvPr id="7" name="TextBox 6"/>
+          <p:cNvSpPr txBox="1"/>
+          <p:nvPr/>
+        </p:nvSpPr>
+        <p:spPr>
+          <a:xfrm>
+            <a:off x="138257" y="6620256"/>
+            <a:ext cx="548640" cy="228600"/>
+          </a:xfrm>
+          <a:prstGeom prst="rect">
+            <a:avLst/>
+          </a:prstGeom>
+          <a:noFill/>
+        </p:spPr>
+        <p:txBody>
+          <a:bodyPr wrap="square" anchor="t" lIns="0" rIns="0" tIns="0" bIns="0">
+            <a:spAutoFit/>
+          </a:bodyPr>
+          <a:lstStyle/>
+          <a:p>
+            <a:pPr algn="l"/>
+            <a:r>
+              <a:rPr sz="900" b="0" i="0" spc="-9">
+                <a:solidFill>
+                  <a:srgbClr val="8E8E93"/>
+                </a:solidFill>
+                <a:latin typeface="Pretendard"/>
+                <a:ea typeface="Pretendard"/>
+                <a:cs typeface="Pretendard"/>
+              </a:rPr>
+              <a:t>16</a:t>
+            </a:r>
+          </a:p>
+        </p:txBody>
+      </p:sp>
+      <p:sp>
+        <p:nvSpPr>
+          <p:cNvPr id="8" name="Rounded Rectangle 7"/>
           <p:cNvSpPr/>
           <p:nvPr/>
         </p:nvSpPr>
         <p:spPr>
           <a:xfrm>
             <a:off x="663122" y="1747509"/>
-            <a:ext cx="3491362" cy="64008"/>
-          </a:xfrm>
-          <a:prstGeom prst="rect">
-            <a:avLst/>
-          </a:prstGeom>
-          <a:solidFill>
-            <a:srgbClr val="00754A"/>
-          </a:solidFill>
-          <a:ln>
-            <a:noFill/>
-          </a:ln>
-          <a:effectLst/>
-        </p:spPr>
-        <p:style>
-          <a:lnRef idx="1">
-            <a:schemeClr val="accent1"/>
-          </a:lnRef>
-          <a:fillRef idx="3">
-            <a:schemeClr val="accent1"/>
-          </a:fillRef>
-          <a:effectRef idx="2">
-            <a:schemeClr val="accent1"/>
-          </a:effectRef>
-          <a:fontRef idx="minor">
-            <a:schemeClr val="lt1"/>
-          </a:fontRef>
-        </p:style>
-        <p:txBody>
-          <a:bodyPr rtlCol="0" anchor="ctr"/>
-          <a:lstStyle/>
-          <a:p>
-            <a:pPr algn="ctr"/>
-          </a:p>
-        </p:txBody>
-      </p:sp>
-      <p:sp>
-        <p:nvSpPr>
-          <p:cNvPr id="10" name="Rounded Rectangle 9"/>
-          <p:cNvSpPr/>
-          <p:nvPr/>
-        </p:nvSpPr>
-        <p:spPr>
-          <a:xfrm>
-            <a:off x="1540123" y="2003541"/>
-            <a:ext cx="1737360" cy="310896"/>
-          </a:xfrm>
-          <a:prstGeom prst="roundRect">
-            <a:avLst>
-              <a:gd name="adj" fmla="val 50000"/>
-            </a:avLst>
-          </a:prstGeom>
-          <a:solidFill>
-            <a:srgbClr val="00754A"/>
-          </a:solidFill>
-          <a:ln>
-            <a:noFill/>
-          </a:ln>
-          <a:effectLst/>
-        </p:spPr>
-        <p:style>
-          <a:lnRef idx="1">
-            <a:schemeClr val="accent1"/>
-          </a:lnRef>
-          <a:fillRef idx="3">
-            <a:schemeClr val="accent1"/>
-          </a:fillRef>
-          <a:effectRef idx="2">
-            <a:schemeClr val="accent1"/>
-          </a:effectRef>
-          <a:fontRef idx="minor">
-            <a:schemeClr val="lt1"/>
-          </a:fontRef>
-        </p:style>
-        <p:txBody>
-          <a:bodyPr rtlCol="0" anchor="ctr"/>
-          <a:lstStyle/>
-          <a:p>
-            <a:pPr algn="ctr"/>
-          </a:p>
-        </p:txBody>
-      </p:sp>
-      <p:sp>
-        <p:nvSpPr>
-          <p:cNvPr id="11" name="TextBox 10"/>
-          <p:cNvSpPr txBox="1"/>
-          <p:nvPr/>
-        </p:nvSpPr>
-        <p:spPr>
-          <a:xfrm>
-            <a:off x="1540123" y="2003541"/>
-            <a:ext cx="1737360" cy="310896"/>
-          </a:xfrm>
-          <a:prstGeom prst="rect">
-            <a:avLst/>
-          </a:prstGeom>
-          <a:noFill/>
-        </p:spPr>
-        <p:txBody>
-          <a:bodyPr wrap="square" anchor="ctr" lIns="0" rIns="0" tIns="0" bIns="0">
-            <a:spAutoFit/>
-          </a:bodyPr>
-          <a:lstStyle/>
-          <a:p>
-            <a:pPr algn="ctr"/>
-            <a:r>
-              <a:rPr sz="1100" b="1" i="0" spc="-11">
-                <a:solidFill>
-                  <a:srgbClr val="FFFFFF"/>
-                </a:solidFill>
-                <a:latin typeface="Pretendard"/>
-                <a:ea typeface="Pretendard"/>
-                <a:cs typeface="Pretendard"/>
-              </a:rPr>
-              <a:t>OWN YOUR DATA</a:t>
-            </a:r>
-          </a:p>
-        </p:txBody>
-      </p:sp>
-      <p:sp>
-        <p:nvSpPr>
-          <p:cNvPr id="12" name="TextBox 11"/>
-          <p:cNvSpPr txBox="1"/>
-          <p:nvPr/>
-        </p:nvSpPr>
-        <p:spPr>
-          <a:xfrm>
-            <a:off x="754562" y="2616189"/>
-            <a:ext cx="3308482" cy="1554480"/>
-          </a:xfrm>
-          <a:prstGeom prst="rect">
-            <a:avLst/>
-          </a:prstGeom>
-          <a:noFill/>
-        </p:spPr>
-        <p:txBody>
-          <a:bodyPr wrap="square" anchor="t" lIns="0" rIns="0" tIns="0" bIns="0">
-            <a:spAutoFit/>
-          </a:bodyPr>
-          <a:lstStyle/>
-          <a:p>
-            <a:pPr algn="ctr"/>
-            <a:r>
-              <a:rPr sz="3400" b="1" i="0" spc="-34">
-                <a:solidFill>
-                  <a:srgbClr val="006241"/>
-                </a:solidFill>
-                <a:latin typeface="Pretendard"/>
-                <a:ea typeface="Pretendard"/>
-                <a:cs typeface="Pretendard"/>
-              </a:rPr>
-              <a:t>마크다운</a:t>
-            </a:r>
-          </a:p>
-          <a:p>
-            <a:pPr algn="ctr">
-              <a:spcBef>
-                <a:spcPts val="200"/>
-              </a:spcBef>
-            </a:pPr>
-            <a:r>
-              <a:rPr sz="1600" b="1" i="0" spc="-16">
-                <a:solidFill>
-                  <a:srgbClr val="1F1F1F"/>
-                </a:solidFill>
-                <a:latin typeface="Pretendard"/>
-                <a:ea typeface="Pretendard"/>
-                <a:cs typeface="Pretendard"/>
-              </a:rPr>
-              <a:t>= 내 DB</a:t>
-            </a:r>
-          </a:p>
-          <a:p>
-            <a:pPr algn="ctr">
-              <a:lnSpc>
-                <a:spcPts val="1600"/>
-              </a:lnSpc>
-              <a:spcBef>
-                <a:spcPts val="1000"/>
-              </a:spcBef>
-            </a:pPr>
-            <a:r>
-              <a:rPr sz="1200" b="0" i="0" spc="-12">
-                <a:solidFill>
-                  <a:srgbClr val="6B6B6B"/>
-                </a:solidFill>
-                <a:latin typeface="Pretendard"/>
-                <a:ea typeface="Pretendard"/>
-                <a:cs typeface="Pretendard"/>
-              </a:rPr>
-              <a:t>평문·git·로컬 우선
-플러그인보다 오래 남음</a:t>
-            </a:r>
-          </a:p>
-        </p:txBody>
-      </p:sp>
-      <p:sp>
-        <p:nvSpPr>
-          <p:cNvPr id="13" name="Rounded Rectangle 12"/>
-          <p:cNvSpPr/>
-          <p:nvPr/>
-        </p:nvSpPr>
-        <p:spPr>
-          <a:xfrm>
-            <a:off x="4355652" y="1747509"/>
             <a:ext cx="3491362" cy="3200400"/>
           </a:xfrm>
           <a:prstGeom prst="roundRect">
@@ -8564,13 +10173,13 @@
       </p:sp>
       <p:sp>
         <p:nvSpPr>
-          <p:cNvPr id="14" name="Rectangle 13"/>
+          <p:cNvPr id="9" name="Rectangle 8"/>
           <p:cNvSpPr/>
           <p:nvPr/>
         </p:nvSpPr>
         <p:spPr>
           <a:xfrm>
-            <a:off x="4355652" y="1747509"/>
+            <a:off x="663122" y="1747509"/>
             <a:ext cx="3491362" cy="64008"/>
           </a:xfrm>
           <a:prstGeom prst="rect">
@@ -8608,13 +10217,13 @@
       </p:sp>
       <p:sp>
         <p:nvSpPr>
-          <p:cNvPr id="15" name="Rounded Rectangle 14"/>
+          <p:cNvPr id="10" name="Rounded Rectangle 9"/>
           <p:cNvSpPr/>
           <p:nvPr/>
         </p:nvSpPr>
         <p:spPr>
           <a:xfrm>
-            <a:off x="5232654" y="2003541"/>
+            <a:off x="1540123" y="2003541"/>
             <a:ext cx="1737360" cy="310896"/>
           </a:xfrm>
           <a:prstGeom prst="roundRect">
@@ -8654,13 +10263,13 @@
       </p:sp>
       <p:sp>
         <p:nvSpPr>
-          <p:cNvPr id="16" name="TextBox 15"/>
-          <p:cNvSpPr txBox="1"/>
-          <p:nvPr/>
-        </p:nvSpPr>
-        <p:spPr>
-          <a:xfrm>
-            <a:off x="5232654" y="2003541"/>
+          <p:cNvPr id="11" name="TextBox 10"/>
+          <p:cNvSpPr txBox="1"/>
+          <p:nvPr/>
+        </p:nvSpPr>
+        <p:spPr>
+          <a:xfrm>
+            <a:off x="1540123" y="2003541"/>
             <a:ext cx="1737360" cy="310896"/>
           </a:xfrm>
           <a:prstGeom prst="rect">
@@ -8684,20 +10293,20 @@
                 <a:ea typeface="Pretendard"/>
                 <a:cs typeface="Pretendard"/>
               </a:rPr>
-              <a:t>GROUNDED</a:t>
-            </a:r>
-          </a:p>
-        </p:txBody>
-      </p:sp>
-      <p:sp>
-        <p:nvSpPr>
-          <p:cNvPr id="17" name="TextBox 16"/>
-          <p:cNvSpPr txBox="1"/>
-          <p:nvPr/>
-        </p:nvSpPr>
-        <p:spPr>
-          <a:xfrm>
-            <a:off x="4447092" y="2616189"/>
+              <a:t>OWN YOUR DATA</a:t>
+            </a:r>
+          </a:p>
+        </p:txBody>
+      </p:sp>
+      <p:sp>
+        <p:nvSpPr>
+          <p:cNvPr id="12" name="TextBox 11"/>
+          <p:cNvSpPr txBox="1"/>
+          <p:nvPr/>
+        </p:nvSpPr>
+        <p:spPr>
+          <a:xfrm>
+            <a:off x="754562" y="2616189"/>
             <a:ext cx="3308482" cy="1554480"/>
           </a:xfrm>
           <a:prstGeom prst="rect">
@@ -8721,7 +10330,7 @@
                 <a:ea typeface="Pretendard"/>
                 <a:cs typeface="Pretendard"/>
               </a:rPr>
-              <a:t>근거</a:t>
+              <a:t>마크다운</a:t>
             </a:r>
           </a:p>
           <a:p>
@@ -8739,7 +10348,7 @@
                 <a:ea typeface="Pretendard"/>
                 <a:cs typeface="Pretendard"/>
               </a:rPr>
-              <a:t>구절 인용</a:t>
+              <a:t>= 내 DB</a:t>
             </a:r>
           </a:p>
           <a:p>
@@ -8760,21 +10369,21 @@
                 <a:ea typeface="Pretendard"/>
                 <a:cs typeface="Pretendard"/>
               </a:rPr>
-              <a:t>출처 없는 답 없음
-서식 참고문헌까지</a:t>
-            </a:r>
-          </a:p>
-        </p:txBody>
-      </p:sp>
-      <p:sp>
-        <p:nvSpPr>
-          <p:cNvPr id="18" name="Rounded Rectangle 17"/>
+              <a:t>평문·git·로컬 우선
+플러그인보다 오래 남음</a:t>
+            </a:r>
+          </a:p>
+        </p:txBody>
+      </p:sp>
+      <p:sp>
+        <p:nvSpPr>
+          <p:cNvPr id="13" name="Rounded Rectangle 12"/>
           <p:cNvSpPr/>
           <p:nvPr/>
         </p:nvSpPr>
         <p:spPr>
           <a:xfrm>
-            <a:off x="8048183" y="1747509"/>
+            <a:off x="4355652" y="1747509"/>
             <a:ext cx="3491362" cy="3200400"/>
           </a:xfrm>
           <a:prstGeom prst="roundRect">
@@ -8816,13 +10425,13 @@
       </p:sp>
       <p:sp>
         <p:nvSpPr>
-          <p:cNvPr id="19" name="Rectangle 18"/>
+          <p:cNvPr id="14" name="Rectangle 13"/>
           <p:cNvSpPr/>
           <p:nvPr/>
         </p:nvSpPr>
         <p:spPr>
           <a:xfrm>
-            <a:off x="8048183" y="1747509"/>
+            <a:off x="4355652" y="1747509"/>
             <a:ext cx="3491362" cy="64008"/>
           </a:xfrm>
           <a:prstGeom prst="rect">
@@ -8860,13 +10469,13 @@
       </p:sp>
       <p:sp>
         <p:nvSpPr>
-          <p:cNvPr id="20" name="Rounded Rectangle 19"/>
+          <p:cNvPr id="15" name="Rounded Rectangle 14"/>
           <p:cNvSpPr/>
           <p:nvPr/>
         </p:nvSpPr>
         <p:spPr>
           <a:xfrm>
-            <a:off x="8925184" y="2003541"/>
+            <a:off x="5232654" y="2003541"/>
             <a:ext cx="1737360" cy="310896"/>
           </a:xfrm>
           <a:prstGeom prst="roundRect">
@@ -8906,13 +10515,13 @@
       </p:sp>
       <p:sp>
         <p:nvSpPr>
-          <p:cNvPr id="21" name="TextBox 20"/>
-          <p:cNvSpPr txBox="1"/>
-          <p:nvPr/>
-        </p:nvSpPr>
-        <p:spPr>
-          <a:xfrm>
-            <a:off x="8925184" y="2003541"/>
+          <p:cNvPr id="16" name="TextBox 15"/>
+          <p:cNvSpPr txBox="1"/>
+          <p:nvPr/>
+        </p:nvSpPr>
+        <p:spPr>
+          <a:xfrm>
+            <a:off x="5232654" y="2003541"/>
             <a:ext cx="1737360" cy="310896"/>
           </a:xfrm>
           <a:prstGeom prst="rect">
@@ -8936,20 +10545,20 @@
                 <a:ea typeface="Pretendard"/>
                 <a:cs typeface="Pretendard"/>
               </a:rPr>
-              <a:t>GRAPH-LITE</a:t>
-            </a:r>
-          </a:p>
-        </p:txBody>
-      </p:sp>
-      <p:sp>
-        <p:nvSpPr>
-          <p:cNvPr id="22" name="TextBox 21"/>
-          <p:cNvSpPr txBox="1"/>
-          <p:nvPr/>
-        </p:nvSpPr>
-        <p:spPr>
-          <a:xfrm>
-            <a:off x="8139623" y="2616189"/>
+              <a:t>GROUNDED</a:t>
+            </a:r>
+          </a:p>
+        </p:txBody>
+      </p:sp>
+      <p:sp>
+        <p:nvSpPr>
+          <p:cNvPr id="17" name="TextBox 16"/>
+          <p:cNvSpPr txBox="1"/>
+          <p:nvPr/>
+        </p:nvSpPr>
+        <p:spPr>
+          <a:xfrm>
+            <a:off x="4447092" y="2616189"/>
             <a:ext cx="3308482" cy="1554480"/>
           </a:xfrm>
           <a:prstGeom prst="rect">
@@ -8973,7 +10582,7 @@
                 <a:ea typeface="Pretendard"/>
                 <a:cs typeface="Pretendard"/>
               </a:rPr>
-              <a:t>그래프</a:t>
+              <a:t>근거</a:t>
             </a:r>
           </a:p>
           <a:p>
@@ -8991,7 +10600,7 @@
                 <a:ea typeface="Pretendard"/>
                 <a:cs typeface="Pretendard"/>
               </a:rPr>
-              <a:t>놓친 논문</a:t>
+              <a:t>구절 인용</a:t>
             </a:r>
           </a:p>
           <a:p>
@@ -9012,6 +10621,258 @@
                 <a:ea typeface="Pretendard"/>
                 <a:cs typeface="Pretendard"/>
               </a:rPr>
+              <a:t>출처 없는 답 없음
+서식 참고문헌까지</a:t>
+            </a:r>
+          </a:p>
+        </p:txBody>
+      </p:sp>
+      <p:sp>
+        <p:nvSpPr>
+          <p:cNvPr id="18" name="Rounded Rectangle 17"/>
+          <p:cNvSpPr/>
+          <p:nvPr/>
+        </p:nvSpPr>
+        <p:spPr>
+          <a:xfrm>
+            <a:off x="8048183" y="1747509"/>
+            <a:ext cx="3491362" cy="3200400"/>
+          </a:xfrm>
+          <a:prstGeom prst="roundRect">
+            <a:avLst>
+              <a:gd name="adj" fmla="val 6000"/>
+            </a:avLst>
+          </a:prstGeom>
+          <a:solidFill>
+            <a:srgbClr val="FFFFFF"/>
+          </a:solidFill>
+          <a:ln w="9525">
+            <a:solidFill>
+              <a:srgbClr val="D9D9D9"/>
+            </a:solidFill>
+          </a:ln>
+          <a:effectLst/>
+        </p:spPr>
+        <p:style>
+          <a:lnRef idx="1">
+            <a:schemeClr val="accent1"/>
+          </a:lnRef>
+          <a:fillRef idx="3">
+            <a:schemeClr val="accent1"/>
+          </a:fillRef>
+          <a:effectRef idx="2">
+            <a:schemeClr val="accent1"/>
+          </a:effectRef>
+          <a:fontRef idx="minor">
+            <a:schemeClr val="lt1"/>
+          </a:fontRef>
+        </p:style>
+        <p:txBody>
+          <a:bodyPr rtlCol="0" anchor="ctr"/>
+          <a:lstStyle/>
+          <a:p>
+            <a:pPr algn="ctr"/>
+          </a:p>
+        </p:txBody>
+      </p:sp>
+      <p:sp>
+        <p:nvSpPr>
+          <p:cNvPr id="19" name="Rectangle 18"/>
+          <p:cNvSpPr/>
+          <p:nvPr/>
+        </p:nvSpPr>
+        <p:spPr>
+          <a:xfrm>
+            <a:off x="8048183" y="1747509"/>
+            <a:ext cx="3491362" cy="64008"/>
+          </a:xfrm>
+          <a:prstGeom prst="rect">
+            <a:avLst/>
+          </a:prstGeom>
+          <a:solidFill>
+            <a:srgbClr val="00754A"/>
+          </a:solidFill>
+          <a:ln>
+            <a:noFill/>
+          </a:ln>
+          <a:effectLst/>
+        </p:spPr>
+        <p:style>
+          <a:lnRef idx="1">
+            <a:schemeClr val="accent1"/>
+          </a:lnRef>
+          <a:fillRef idx="3">
+            <a:schemeClr val="accent1"/>
+          </a:fillRef>
+          <a:effectRef idx="2">
+            <a:schemeClr val="accent1"/>
+          </a:effectRef>
+          <a:fontRef idx="minor">
+            <a:schemeClr val="lt1"/>
+          </a:fontRef>
+        </p:style>
+        <p:txBody>
+          <a:bodyPr rtlCol="0" anchor="ctr"/>
+          <a:lstStyle/>
+          <a:p>
+            <a:pPr algn="ctr"/>
+          </a:p>
+        </p:txBody>
+      </p:sp>
+      <p:sp>
+        <p:nvSpPr>
+          <p:cNvPr id="20" name="Rounded Rectangle 19"/>
+          <p:cNvSpPr/>
+          <p:nvPr/>
+        </p:nvSpPr>
+        <p:spPr>
+          <a:xfrm>
+            <a:off x="8925184" y="2003541"/>
+            <a:ext cx="1737360" cy="310896"/>
+          </a:xfrm>
+          <a:prstGeom prst="roundRect">
+            <a:avLst>
+              <a:gd name="adj" fmla="val 50000"/>
+            </a:avLst>
+          </a:prstGeom>
+          <a:solidFill>
+            <a:srgbClr val="00754A"/>
+          </a:solidFill>
+          <a:ln>
+            <a:noFill/>
+          </a:ln>
+          <a:effectLst/>
+        </p:spPr>
+        <p:style>
+          <a:lnRef idx="1">
+            <a:schemeClr val="accent1"/>
+          </a:lnRef>
+          <a:fillRef idx="3">
+            <a:schemeClr val="accent1"/>
+          </a:fillRef>
+          <a:effectRef idx="2">
+            <a:schemeClr val="accent1"/>
+          </a:effectRef>
+          <a:fontRef idx="minor">
+            <a:schemeClr val="lt1"/>
+          </a:fontRef>
+        </p:style>
+        <p:txBody>
+          <a:bodyPr rtlCol="0" anchor="ctr"/>
+          <a:lstStyle/>
+          <a:p>
+            <a:pPr algn="ctr"/>
+          </a:p>
+        </p:txBody>
+      </p:sp>
+      <p:sp>
+        <p:nvSpPr>
+          <p:cNvPr id="21" name="TextBox 20"/>
+          <p:cNvSpPr txBox="1"/>
+          <p:nvPr/>
+        </p:nvSpPr>
+        <p:spPr>
+          <a:xfrm>
+            <a:off x="8925184" y="2003541"/>
+            <a:ext cx="1737360" cy="310896"/>
+          </a:xfrm>
+          <a:prstGeom prst="rect">
+            <a:avLst/>
+          </a:prstGeom>
+          <a:noFill/>
+        </p:spPr>
+        <p:txBody>
+          <a:bodyPr wrap="square" anchor="ctr" lIns="0" rIns="0" tIns="0" bIns="0">
+            <a:spAutoFit/>
+          </a:bodyPr>
+          <a:lstStyle/>
+          <a:p>
+            <a:pPr algn="ctr"/>
+            <a:r>
+              <a:rPr sz="1100" b="1" i="0" spc="-11">
+                <a:solidFill>
+                  <a:srgbClr val="FFFFFF"/>
+                </a:solidFill>
+                <a:latin typeface="Pretendard"/>
+                <a:ea typeface="Pretendard"/>
+                <a:cs typeface="Pretendard"/>
+              </a:rPr>
+              <a:t>GRAPH-LITE</a:t>
+            </a:r>
+          </a:p>
+        </p:txBody>
+      </p:sp>
+      <p:sp>
+        <p:nvSpPr>
+          <p:cNvPr id="22" name="TextBox 21"/>
+          <p:cNvSpPr txBox="1"/>
+          <p:nvPr/>
+        </p:nvSpPr>
+        <p:spPr>
+          <a:xfrm>
+            <a:off x="8139623" y="2616189"/>
+            <a:ext cx="3308482" cy="1554480"/>
+          </a:xfrm>
+          <a:prstGeom prst="rect">
+            <a:avLst/>
+          </a:prstGeom>
+          <a:noFill/>
+        </p:spPr>
+        <p:txBody>
+          <a:bodyPr wrap="square" anchor="t" lIns="0" rIns="0" tIns="0" bIns="0">
+            <a:spAutoFit/>
+          </a:bodyPr>
+          <a:lstStyle/>
+          <a:p>
+            <a:pPr algn="ctr"/>
+            <a:r>
+              <a:rPr sz="3400" b="1" i="0" spc="-34">
+                <a:solidFill>
+                  <a:srgbClr val="006241"/>
+                </a:solidFill>
+                <a:latin typeface="Pretendard"/>
+                <a:ea typeface="Pretendard"/>
+                <a:cs typeface="Pretendard"/>
+              </a:rPr>
+              <a:t>그래프</a:t>
+            </a:r>
+          </a:p>
+          <a:p>
+            <a:pPr algn="ctr">
+              <a:spcBef>
+                <a:spcPts val="200"/>
+              </a:spcBef>
+            </a:pPr>
+            <a:r>
+              <a:rPr sz="1600" b="1" i="0" spc="-16">
+                <a:solidFill>
+                  <a:srgbClr val="1F1F1F"/>
+                </a:solidFill>
+                <a:latin typeface="Pretendard"/>
+                <a:ea typeface="Pretendard"/>
+                <a:cs typeface="Pretendard"/>
+              </a:rPr>
+              <a:t>놓친 논문</a:t>
+            </a:r>
+          </a:p>
+          <a:p>
+            <a:pPr algn="ctr">
+              <a:lnSpc>
+                <a:spcPts val="1600"/>
+              </a:lnSpc>
+              <a:spcBef>
+                <a:spcPts val="1000"/>
+              </a:spcBef>
+            </a:pPr>
+            <a:r>
+              <a:rPr sz="1200" b="0" i="0" spc="-12">
+                <a:solidFill>
+                  <a:srgbClr val="6B6B6B"/>
+                </a:solidFill>
+                <a:latin typeface="Pretendard"/>
+                <a:ea typeface="Pretendard"/>
+                <a:cs typeface="Pretendard"/>
+              </a:rPr>
               <a:t>OpenAlex 인용엣지
 LLM 비용 0</a:t>
             </a:r>
@@ -9109,7 +10970,7 @@
 </p:sld>
 </file>
 
-<file path=ppt/slides/slide16.xml><?xml version="1.0" encoding="utf-8"?>
+<file path=ppt/slides/slide17.xml><?xml version="1.0" encoding="utf-8"?>
 <p:sld xmlns:a="http://schemas.openxmlformats.org/drawingml/2006/main" xmlns:p="http://schemas.openxmlformats.org/presentationml/2006/main" xmlns:r="http://schemas.openxmlformats.org/officeDocument/2006/relationships">
   <p:cSld>
     <p:spTree>

</xml_diff>

<commit_message>
docs: deck — usage slide gains PubMed search + journal-style row (6 actions)
Ribbon mislabel fixed (magnifier opens PubMed search, not library
search); row 6 notes per-note csl: frontmatter switching among 10k+
auto-downloaded CSL styles.

Co-Authored-By: Claude Fable 5 <noreply@anthropic.com>
</commit_message>
<xml_diff>
--- a/presentation/rag_obsidian_deck.pptx
+++ b/presentation/rag_obsidian_deck.pptx
@@ -8148,7 +8148,7 @@
                 <a:ea typeface="Pretendard"/>
                 <a:cs typeface="Pretendard"/>
               </a:rPr>
-              <a:t>쓰는 법은 다섯 동작이 전부다</a:t>
+              <a:t>쓰는 법은 여섯 동작이 전부다</a:t>
             </a:r>
           </a:p>
         </p:txBody>
@@ -8308,8 +8308,8 @@
         </p:nvSpPr>
         <p:spPr>
           <a:xfrm>
-            <a:off x="663122" y="1701789"/>
-            <a:ext cx="10876422" cy="676656"/>
+            <a:off x="663122" y="1637781"/>
+            <a:ext cx="10876422" cy="603504"/>
           </a:xfrm>
           <a:prstGeom prst="roundRect">
             <a:avLst>
@@ -8356,7 +8356,7 @@
         </p:nvSpPr>
         <p:spPr>
           <a:xfrm>
-            <a:off x="864290" y="1857237"/>
+            <a:off x="864290" y="1756653"/>
             <a:ext cx="365760" cy="365760"/>
           </a:xfrm>
           <a:prstGeom prst="ellipse">
@@ -8400,7 +8400,7 @@
         </p:nvSpPr>
         <p:spPr>
           <a:xfrm>
-            <a:off x="864290" y="1857237"/>
+            <a:off x="864290" y="1756653"/>
             <a:ext cx="365760" cy="365760"/>
           </a:xfrm>
           <a:prstGeom prst="rect">
@@ -8437,8 +8437,8 @@
         </p:nvSpPr>
         <p:spPr>
           <a:xfrm>
-            <a:off x="1348922" y="1701789"/>
-            <a:ext cx="1783080" cy="676656"/>
+            <a:off x="1348922" y="1637781"/>
+            <a:ext cx="1783080" cy="603504"/>
           </a:xfrm>
           <a:prstGeom prst="rect">
             <a:avLst/>
@@ -8478,8 +8478,8 @@
         </p:nvSpPr>
         <p:spPr>
           <a:xfrm>
-            <a:off x="3177722" y="1820661"/>
-            <a:ext cx="4526280" cy="438912"/>
+            <a:off x="3177722" y="1756653"/>
+            <a:ext cx="4526280" cy="365760"/>
           </a:xfrm>
           <a:prstGeom prst="roundRect">
             <a:avLst>
@@ -8524,8 +8524,8 @@
         </p:nvSpPr>
         <p:spPr>
           <a:xfrm>
-            <a:off x="3314882" y="1820661"/>
-            <a:ext cx="4251960" cy="438912"/>
+            <a:off x="3314882" y="1756653"/>
+            <a:ext cx="4251960" cy="365760"/>
           </a:xfrm>
           <a:prstGeom prst="rect">
             <a:avLst/>
@@ -8565,8 +8565,8 @@
         </p:nvSpPr>
         <p:spPr>
           <a:xfrm>
-            <a:off x="7932602" y="1701789"/>
-            <a:ext cx="3469782" cy="676656"/>
+            <a:off x="7932602" y="1637781"/>
+            <a:ext cx="3469782" cy="603504"/>
           </a:xfrm>
           <a:prstGeom prst="rect">
             <a:avLst/>
@@ -8606,8 +8606,8 @@
         </p:nvSpPr>
         <p:spPr>
           <a:xfrm>
-            <a:off x="663122" y="2479029"/>
-            <a:ext cx="10876422" cy="676656"/>
+            <a:off x="663122" y="2332725"/>
+            <a:ext cx="10876422" cy="603504"/>
           </a:xfrm>
           <a:prstGeom prst="roundRect">
             <a:avLst>
@@ -8654,7 +8654,7 @@
         </p:nvSpPr>
         <p:spPr>
           <a:xfrm>
-            <a:off x="864290" y="2634477"/>
+            <a:off x="864290" y="2451597"/>
             <a:ext cx="365760" cy="365760"/>
           </a:xfrm>
           <a:prstGeom prst="ellipse">
@@ -8698,7 +8698,7 @@
         </p:nvSpPr>
         <p:spPr>
           <a:xfrm>
-            <a:off x="864290" y="2634477"/>
+            <a:off x="864290" y="2451597"/>
             <a:ext cx="365760" cy="365760"/>
           </a:xfrm>
           <a:prstGeom prst="rect">
@@ -8735,8 +8735,8 @@
         </p:nvSpPr>
         <p:spPr>
           <a:xfrm>
-            <a:off x="1348922" y="2479029"/>
-            <a:ext cx="1783080" cy="676656"/>
+            <a:off x="1348922" y="2332725"/>
+            <a:ext cx="1783080" cy="603504"/>
           </a:xfrm>
           <a:prstGeom prst="rect">
             <a:avLst/>
@@ -8763,7 +8763,7 @@
                 <a:ea typeface="Pretendard"/>
                 <a:cs typeface="Pretendard"/>
               </a:rPr>
-              <a:t>뜻으로 검색</a:t>
+              <a:t>PubMed 검색</a:t>
             </a:r>
           </a:p>
         </p:txBody>
@@ -8776,8 +8776,8 @@
         </p:nvSpPr>
         <p:spPr>
           <a:xfrm>
-            <a:off x="3177722" y="2597901"/>
-            <a:ext cx="4526280" cy="438912"/>
+            <a:off x="3177722" y="2451597"/>
+            <a:ext cx="4526280" cy="365760"/>
           </a:xfrm>
           <a:prstGeom prst="roundRect">
             <a:avLst>
@@ -8822,8 +8822,8 @@
         </p:nvSpPr>
         <p:spPr>
           <a:xfrm>
-            <a:off x="3314882" y="2597901"/>
-            <a:ext cx="4251960" cy="438912"/>
+            <a:off x="3314882" y="2451597"/>
+            <a:ext cx="4251960" cy="365760"/>
           </a:xfrm>
           <a:prstGeom prst="rect">
             <a:avLst/>
@@ -8850,7 +8850,7 @@
                 <a:ea typeface="Pretendard"/>
                 <a:cs typeface="Pretendard"/>
               </a:rPr>
-              <a:t>“Search library (semantic)”  (리본: 돋보기)</a:t>
+              <a:t>“Search PubMed and add references”  (리본: 돋보기)</a:t>
             </a:r>
           </a:p>
         </p:txBody>
@@ -8863,8 +8863,8 @@
         </p:nvSpPr>
         <p:spPr>
           <a:xfrm>
-            <a:off x="7932602" y="2479029"/>
-            <a:ext cx="3469782" cy="676656"/>
+            <a:off x="7932602" y="2332725"/>
+            <a:ext cx="3469782" cy="603504"/>
           </a:xfrm>
           <a:prstGeom prst="rect">
             <a:avLst/>
@@ -8891,7 +8891,7 @@
                 <a:ea typeface="Pretendard"/>
                 <a:cs typeface="Pretendard"/>
               </a:rPr>
-              <a:t>단어+뜻 하이브리드 검색, 저자·연도로 좁히기</a:t>
+              <a:t>키워드로 PubMed 검색 → 골라서 한 번에 서재로</a:t>
             </a:r>
           </a:p>
         </p:txBody>
@@ -8904,8 +8904,8 @@
         </p:nvSpPr>
         <p:spPr>
           <a:xfrm>
-            <a:off x="663122" y="3256269"/>
-            <a:ext cx="10876422" cy="676656"/>
+            <a:off x="663122" y="3027669"/>
+            <a:ext cx="10876422" cy="603504"/>
           </a:xfrm>
           <a:prstGeom prst="roundRect">
             <a:avLst>
@@ -8952,7 +8952,7 @@
         </p:nvSpPr>
         <p:spPr>
           <a:xfrm>
-            <a:off x="864290" y="3411717"/>
+            <a:off x="864290" y="3146541"/>
             <a:ext cx="365760" cy="365760"/>
           </a:xfrm>
           <a:prstGeom prst="ellipse">
@@ -8996,7 +8996,7 @@
         </p:nvSpPr>
         <p:spPr>
           <a:xfrm>
-            <a:off x="864290" y="3411717"/>
+            <a:off x="864290" y="3146541"/>
             <a:ext cx="365760" cy="365760"/>
           </a:xfrm>
           <a:prstGeom prst="rect">
@@ -9033,8 +9033,8 @@
         </p:nvSpPr>
         <p:spPr>
           <a:xfrm>
-            <a:off x="1348922" y="3256269"/>
-            <a:ext cx="1783080" cy="676656"/>
+            <a:off x="1348922" y="3027669"/>
+            <a:ext cx="1783080" cy="603504"/>
           </a:xfrm>
           <a:prstGeom prst="rect">
             <a:avLst/>
@@ -9061,7 +9061,7 @@
                 <a:ea typeface="Pretendard"/>
                 <a:cs typeface="Pretendard"/>
               </a:rPr>
-              <a:t>서재에 질문</a:t>
+              <a:t>뜻으로 검색</a:t>
             </a:r>
           </a:p>
         </p:txBody>
@@ -9074,8 +9074,8 @@
         </p:nvSpPr>
         <p:spPr>
           <a:xfrm>
-            <a:off x="3177722" y="3375141"/>
-            <a:ext cx="4526280" cy="438912"/>
+            <a:off x="3177722" y="3146541"/>
+            <a:ext cx="4526280" cy="365760"/>
           </a:xfrm>
           <a:prstGeom prst="roundRect">
             <a:avLst>
@@ -9120,8 +9120,8 @@
         </p:nvSpPr>
         <p:spPr>
           <a:xfrm>
-            <a:off x="3314882" y="3375141"/>
-            <a:ext cx="4251960" cy="438912"/>
+            <a:off x="3314882" y="3146541"/>
+            <a:ext cx="4251960" cy="365760"/>
           </a:xfrm>
           <a:prstGeom prst="rect">
             <a:avLst/>
@@ -9148,7 +9148,7 @@
                 <a:ea typeface="Pretendard"/>
                 <a:cs typeface="Pretendard"/>
               </a:rPr>
-              <a:t>“Chat with library”  (리본: 말풍선)</a:t>
+              <a:t>“Search library (semantic)”</a:t>
             </a:r>
           </a:p>
         </p:txBody>
@@ -9161,8 +9161,8 @@
         </p:nvSpPr>
         <p:spPr>
           <a:xfrm>
-            <a:off x="7932602" y="3256269"/>
-            <a:ext cx="3469782" cy="676656"/>
+            <a:off x="7932602" y="3027669"/>
+            <a:ext cx="3469782" cy="603504"/>
           </a:xfrm>
           <a:prstGeom prst="rect">
             <a:avLst/>
@@ -9189,7 +9189,7 @@
                 <a:ea typeface="Pretendard"/>
                 <a:cs typeface="Pretendard"/>
               </a:rPr>
-              <a:t>출처 [n] 달린 답 — [n] 클릭하면 원문 노트로</a:t>
+              <a:t>내 서재를 단어+뜻 하이브리드로, 저자·연도 필터</a:t>
             </a:r>
           </a:p>
         </p:txBody>
@@ -9202,8 +9202,8 @@
         </p:nvSpPr>
         <p:spPr>
           <a:xfrm>
-            <a:off x="663122" y="4033509"/>
-            <a:ext cx="10876422" cy="676656"/>
+            <a:off x="663122" y="3722613"/>
+            <a:ext cx="10876422" cy="603504"/>
           </a:xfrm>
           <a:prstGeom prst="roundRect">
             <a:avLst>
@@ -9250,7 +9250,7 @@
         </p:nvSpPr>
         <p:spPr>
           <a:xfrm>
-            <a:off x="864290" y="4188957"/>
+            <a:off x="864290" y="3841485"/>
             <a:ext cx="365760" cy="365760"/>
           </a:xfrm>
           <a:prstGeom prst="ellipse">
@@ -9294,7 +9294,7 @@
         </p:nvSpPr>
         <p:spPr>
           <a:xfrm>
-            <a:off x="864290" y="4188957"/>
+            <a:off x="864290" y="3841485"/>
             <a:ext cx="365760" cy="365760"/>
           </a:xfrm>
           <a:prstGeom prst="rect">
@@ -9331,8 +9331,8 @@
         </p:nvSpPr>
         <p:spPr>
           <a:xfrm>
-            <a:off x="1348922" y="4033509"/>
-            <a:ext cx="1783080" cy="676656"/>
+            <a:off x="1348922" y="3722613"/>
+            <a:ext cx="1783080" cy="603504"/>
           </a:xfrm>
           <a:prstGeom prst="rect">
             <a:avLst/>
@@ -9359,7 +9359,7 @@
                 <a:ea typeface="Pretendard"/>
                 <a:cs typeface="Pretendard"/>
               </a:rPr>
-              <a:t>글 쓰며 인용</a:t>
+              <a:t>서재에 질문</a:t>
             </a:r>
           </a:p>
         </p:txBody>
@@ -9372,8 +9372,8 @@
         </p:nvSpPr>
         <p:spPr>
           <a:xfrm>
-            <a:off x="3177722" y="4152381"/>
-            <a:ext cx="4526280" cy="438912"/>
+            <a:off x="3177722" y="3841485"/>
+            <a:ext cx="4526280" cy="365760"/>
           </a:xfrm>
           <a:prstGeom prst="roundRect">
             <a:avLst>
@@ -9418,8 +9418,8 @@
         </p:nvSpPr>
         <p:spPr>
           <a:xfrm>
-            <a:off x="3314882" y="4152381"/>
-            <a:ext cx="4251960" cy="438912"/>
+            <a:off x="3314882" y="3841485"/>
+            <a:ext cx="4251960" cy="365760"/>
           </a:xfrm>
           <a:prstGeom prst="rect">
             <a:avLst/>
@@ -9446,7 +9446,7 @@
                 <a:ea typeface="Pretendard"/>
                 <a:cs typeface="Pretendard"/>
               </a:rPr>
-              <a:t>본문에서  @  입력</a:t>
+              <a:t>“Chat with library”  (리본: 말풍선)</a:t>
             </a:r>
           </a:p>
         </p:txBody>
@@ -9459,8 +9459,8 @@
         </p:nvSpPr>
         <p:spPr>
           <a:xfrm>
-            <a:off x="7932602" y="4033509"/>
-            <a:ext cx="3469782" cy="676656"/>
+            <a:off x="7932602" y="3722613"/>
+            <a:ext cx="3469782" cy="603504"/>
           </a:xfrm>
           <a:prstGeom prst="rect">
             <a:avLst/>
@@ -9487,7 +9487,7 @@
                 <a:ea typeface="Pretendard"/>
                 <a:cs typeface="Pretendard"/>
               </a:rPr>
-              <a:t>제목·저자로 골라 [@citekey] 자동완성 삽입</a:t>
+              <a:t>출처 [n] 달린 답 — [n] 클릭하면 원문 노트로</a:t>
             </a:r>
           </a:p>
         </p:txBody>
@@ -9500,8 +9500,8 @@
         </p:nvSpPr>
         <p:spPr>
           <a:xfrm>
-            <a:off x="663122" y="4810749"/>
-            <a:ext cx="10876422" cy="676656"/>
+            <a:off x="663122" y="4417557"/>
+            <a:ext cx="10876422" cy="603504"/>
           </a:xfrm>
           <a:prstGeom prst="roundRect">
             <a:avLst>
@@ -9548,7 +9548,7 @@
         </p:nvSpPr>
         <p:spPr>
           <a:xfrm>
-            <a:off x="864290" y="4966197"/>
+            <a:off x="864290" y="4536429"/>
             <a:ext cx="365760" cy="365760"/>
           </a:xfrm>
           <a:prstGeom prst="ellipse">
@@ -9592,7 +9592,7 @@
         </p:nvSpPr>
         <p:spPr>
           <a:xfrm>
-            <a:off x="864290" y="4966197"/>
+            <a:off x="864290" y="4536429"/>
             <a:ext cx="365760" cy="365760"/>
           </a:xfrm>
           <a:prstGeom prst="rect">
@@ -9629,8 +9629,8 @@
         </p:nvSpPr>
         <p:spPr>
           <a:xfrm>
-            <a:off x="1348922" y="4810749"/>
-            <a:ext cx="1783080" cy="676656"/>
+            <a:off x="1348922" y="4417557"/>
+            <a:ext cx="1783080" cy="603504"/>
           </a:xfrm>
           <a:prstGeom prst="rect">
             <a:avLst/>
@@ -9657,7 +9657,7 @@
                 <a:ea typeface="Pretendard"/>
                 <a:cs typeface="Pretendard"/>
               </a:rPr>
-              <a:t>참고문헌 생성</a:t>
+              <a:t>글 쓰며 인용</a:t>
             </a:r>
           </a:p>
         </p:txBody>
@@ -9670,8 +9670,8 @@
         </p:nvSpPr>
         <p:spPr>
           <a:xfrm>
-            <a:off x="3177722" y="4929621"/>
-            <a:ext cx="4526280" cy="438912"/>
+            <a:off x="3177722" y="4536429"/>
+            <a:ext cx="4526280" cy="365760"/>
           </a:xfrm>
           <a:prstGeom prst="roundRect">
             <a:avLst>
@@ -9716,8 +9716,8 @@
         </p:nvSpPr>
         <p:spPr>
           <a:xfrm>
-            <a:off x="3314882" y="4929621"/>
-            <a:ext cx="4251960" cy="438912"/>
+            <a:off x="3314882" y="4536429"/>
+            <a:ext cx="4251960" cy="365760"/>
           </a:xfrm>
           <a:prstGeom prst="rect">
             <a:avLst/>
@@ -9744,7 +9744,7 @@
                 <a:ea typeface="Pretendard"/>
                 <a:cs typeface="Pretendard"/>
               </a:rPr>
-              <a:t>“Update bibliography in current note”</a:t>
+              <a:t>본문에서  @  입력</a:t>
             </a:r>
           </a:p>
         </p:txBody>
@@ -9757,8 +9757,8 @@
         </p:nvSpPr>
         <p:spPr>
           <a:xfrm>
-            <a:off x="7932602" y="4810749"/>
-            <a:ext cx="3469782" cy="676656"/>
+            <a:off x="7932602" y="4417557"/>
+            <a:ext cx="3469782" cy="603504"/>
           </a:xfrm>
           <a:prstGeom prst="rect">
             <a:avLst/>
@@ -9785,7 +9785,7 @@
                 <a:ea typeface="Pretendard"/>
                 <a:cs typeface="Pretendard"/>
               </a:rPr>
-              <a:t>## References를 저널 스타일(APA·Vancouver·CSL)로 자동 생성</a:t>
+              <a:t>제목·저자로 골라 [@citekey] 자동완성 삽입</a:t>
             </a:r>
           </a:p>
         </p:txBody>
@@ -9793,6 +9793,304 @@
       <p:sp>
         <p:nvSpPr>
           <p:cNvPr id="44" name="Rounded Rectangle 43"/>
+          <p:cNvSpPr/>
+          <p:nvPr/>
+        </p:nvSpPr>
+        <p:spPr>
+          <a:xfrm>
+            <a:off x="663122" y="5112501"/>
+            <a:ext cx="10876422" cy="603504"/>
+          </a:xfrm>
+          <a:prstGeom prst="roundRect">
+            <a:avLst>
+              <a:gd name="adj" fmla="val 8000"/>
+            </a:avLst>
+          </a:prstGeom>
+          <a:solidFill>
+            <a:srgbClr val="FFFFFF"/>
+          </a:solidFill>
+          <a:ln w="11430">
+            <a:solidFill>
+              <a:srgbClr val="D9D9D9"/>
+            </a:solidFill>
+          </a:ln>
+          <a:effectLst/>
+        </p:spPr>
+        <p:style>
+          <a:lnRef idx="1">
+            <a:schemeClr val="accent1"/>
+          </a:lnRef>
+          <a:fillRef idx="3">
+            <a:schemeClr val="accent1"/>
+          </a:fillRef>
+          <a:effectRef idx="2">
+            <a:schemeClr val="accent1"/>
+          </a:effectRef>
+          <a:fontRef idx="minor">
+            <a:schemeClr val="lt1"/>
+          </a:fontRef>
+        </p:style>
+        <p:txBody>
+          <a:bodyPr rtlCol="0" anchor="ctr"/>
+          <a:lstStyle/>
+          <a:p>
+            <a:pPr algn="ctr"/>
+          </a:p>
+        </p:txBody>
+      </p:sp>
+      <p:sp>
+        <p:nvSpPr>
+          <p:cNvPr id="45" name="Oval 44"/>
+          <p:cNvSpPr/>
+          <p:nvPr/>
+        </p:nvSpPr>
+        <p:spPr>
+          <a:xfrm>
+            <a:off x="864290" y="5231373"/>
+            <a:ext cx="365760" cy="365760"/>
+          </a:xfrm>
+          <a:prstGeom prst="ellipse">
+            <a:avLst/>
+          </a:prstGeom>
+          <a:solidFill>
+            <a:srgbClr val="00754A"/>
+          </a:solidFill>
+          <a:ln>
+            <a:noFill/>
+          </a:ln>
+          <a:effectLst/>
+        </p:spPr>
+        <p:style>
+          <a:lnRef idx="1">
+            <a:schemeClr val="accent1"/>
+          </a:lnRef>
+          <a:fillRef idx="3">
+            <a:schemeClr val="accent1"/>
+          </a:fillRef>
+          <a:effectRef idx="2">
+            <a:schemeClr val="accent1"/>
+          </a:effectRef>
+          <a:fontRef idx="minor">
+            <a:schemeClr val="lt1"/>
+          </a:fontRef>
+        </p:style>
+        <p:txBody>
+          <a:bodyPr rtlCol="0" anchor="ctr"/>
+          <a:lstStyle/>
+          <a:p>
+            <a:pPr algn="ctr"/>
+          </a:p>
+        </p:txBody>
+      </p:sp>
+      <p:sp>
+        <p:nvSpPr>
+          <p:cNvPr id="46" name="TextBox 45"/>
+          <p:cNvSpPr txBox="1"/>
+          <p:nvPr/>
+        </p:nvSpPr>
+        <p:spPr>
+          <a:xfrm>
+            <a:off x="864290" y="5231373"/>
+            <a:ext cx="365760" cy="365760"/>
+          </a:xfrm>
+          <a:prstGeom prst="rect">
+            <a:avLst/>
+          </a:prstGeom>
+          <a:noFill/>
+        </p:spPr>
+        <p:txBody>
+          <a:bodyPr wrap="square" anchor="ctr" lIns="0" rIns="0" tIns="0" bIns="0">
+            <a:spAutoFit/>
+          </a:bodyPr>
+          <a:lstStyle/>
+          <a:p>
+            <a:pPr algn="ctr"/>
+            <a:r>
+              <a:rPr sz="1500" b="1" i="0" spc="-15">
+                <a:solidFill>
+                  <a:srgbClr val="FFFFFF"/>
+                </a:solidFill>
+                <a:latin typeface="Pretendard"/>
+                <a:ea typeface="Pretendard"/>
+                <a:cs typeface="Pretendard"/>
+              </a:rPr>
+              <a:t>6</a:t>
+            </a:r>
+          </a:p>
+        </p:txBody>
+      </p:sp>
+      <p:sp>
+        <p:nvSpPr>
+          <p:cNvPr id="47" name="TextBox 46"/>
+          <p:cNvSpPr txBox="1"/>
+          <p:nvPr/>
+        </p:nvSpPr>
+        <p:spPr>
+          <a:xfrm>
+            <a:off x="1348922" y="5112501"/>
+            <a:ext cx="1783080" cy="603504"/>
+          </a:xfrm>
+          <a:prstGeom prst="rect">
+            <a:avLst/>
+          </a:prstGeom>
+          <a:noFill/>
+        </p:spPr>
+        <p:txBody>
+          <a:bodyPr wrap="square" anchor="ctr" lIns="0" rIns="0" tIns="0" bIns="0">
+            <a:spAutoFit/>
+          </a:bodyPr>
+          <a:lstStyle/>
+          <a:p>
+            <a:pPr algn="l">
+              <a:lnSpc>
+                <a:spcPts val="1800"/>
+              </a:lnSpc>
+            </a:pPr>
+            <a:r>
+              <a:rPr sz="1500" b="1" i="0" spc="-15">
+                <a:solidFill>
+                  <a:srgbClr val="006241"/>
+                </a:solidFill>
+                <a:latin typeface="Pretendard"/>
+                <a:ea typeface="Pretendard"/>
+                <a:cs typeface="Pretendard"/>
+              </a:rPr>
+              <a:t>참고문헌 생성</a:t>
+            </a:r>
+          </a:p>
+        </p:txBody>
+      </p:sp>
+      <p:sp>
+        <p:nvSpPr>
+          <p:cNvPr id="48" name="Rounded Rectangle 47"/>
+          <p:cNvSpPr/>
+          <p:nvPr/>
+        </p:nvSpPr>
+        <p:spPr>
+          <a:xfrm>
+            <a:off x="3177722" y="5231373"/>
+            <a:ext cx="4526280" cy="365760"/>
+          </a:xfrm>
+          <a:prstGeom prst="roundRect">
+            <a:avLst>
+              <a:gd name="adj" fmla="val 12000"/>
+            </a:avLst>
+          </a:prstGeom>
+          <a:solidFill>
+            <a:srgbClr val="F2F0EB"/>
+          </a:solidFill>
+          <a:ln>
+            <a:noFill/>
+          </a:ln>
+          <a:effectLst/>
+        </p:spPr>
+        <p:style>
+          <a:lnRef idx="1">
+            <a:schemeClr val="accent1"/>
+          </a:lnRef>
+          <a:fillRef idx="3">
+            <a:schemeClr val="accent1"/>
+          </a:fillRef>
+          <a:effectRef idx="2">
+            <a:schemeClr val="accent1"/>
+          </a:effectRef>
+          <a:fontRef idx="minor">
+            <a:schemeClr val="lt1"/>
+          </a:fontRef>
+        </p:style>
+        <p:txBody>
+          <a:bodyPr rtlCol="0" anchor="ctr"/>
+          <a:lstStyle/>
+          <a:p>
+            <a:pPr algn="ctr"/>
+          </a:p>
+        </p:txBody>
+      </p:sp>
+      <p:sp>
+        <p:nvSpPr>
+          <p:cNvPr id="49" name="TextBox 48"/>
+          <p:cNvSpPr txBox="1"/>
+          <p:nvPr/>
+        </p:nvSpPr>
+        <p:spPr>
+          <a:xfrm>
+            <a:off x="3314882" y="5231373"/>
+            <a:ext cx="4251960" cy="365760"/>
+          </a:xfrm>
+          <a:prstGeom prst="rect">
+            <a:avLst/>
+          </a:prstGeom>
+          <a:noFill/>
+        </p:spPr>
+        <p:txBody>
+          <a:bodyPr wrap="square" anchor="ctr" lIns="0" rIns="0" tIns="0" bIns="0">
+            <a:spAutoFit/>
+          </a:bodyPr>
+          <a:lstStyle/>
+          <a:p>
+            <a:pPr algn="l">
+              <a:lnSpc>
+                <a:spcPts val="1500"/>
+              </a:lnSpc>
+            </a:pPr>
+            <a:r>
+              <a:rPr sz="1200" b="1" i="0" spc="-12">
+                <a:solidFill>
+                  <a:srgbClr val="00754A"/>
+                </a:solidFill>
+                <a:latin typeface="Pretendard"/>
+                <a:ea typeface="Pretendard"/>
+                <a:cs typeface="Pretendard"/>
+              </a:rPr>
+              <a:t>“Update bibliography in current note”</a:t>
+            </a:r>
+          </a:p>
+        </p:txBody>
+      </p:sp>
+      <p:sp>
+        <p:nvSpPr>
+          <p:cNvPr id="50" name="TextBox 49"/>
+          <p:cNvSpPr txBox="1"/>
+          <p:nvPr/>
+        </p:nvSpPr>
+        <p:spPr>
+          <a:xfrm>
+            <a:off x="7932602" y="5112501"/>
+            <a:ext cx="3469782" cy="603504"/>
+          </a:xfrm>
+          <a:prstGeom prst="rect">
+            <a:avLst/>
+          </a:prstGeom>
+          <a:noFill/>
+        </p:spPr>
+        <p:txBody>
+          <a:bodyPr wrap="square" anchor="ctr" lIns="0" rIns="0" tIns="0" bIns="0">
+            <a:spAutoFit/>
+          </a:bodyPr>
+          <a:lstStyle/>
+          <a:p>
+            <a:pPr algn="l">
+              <a:lnSpc>
+                <a:spcPts val="1600"/>
+              </a:lnSpc>
+            </a:pPr>
+            <a:r>
+              <a:rPr sz="1250" b="0" i="0" spc="-12">
+                <a:solidFill>
+                  <a:srgbClr val="6B6B6B"/>
+                </a:solidFill>
+                <a:latin typeface="Pretendard"/>
+                <a:ea typeface="Pretendard"/>
+                <a:cs typeface="Pretendard"/>
+              </a:rPr>
+              <a:t>저널 스타일 자동 — 노트에 csl: 한 줄이면 교체 (1만+ 스타일 자동 다운로드)</a:t>
+            </a:r>
+          </a:p>
+        </p:txBody>
+      </p:sp>
+      <p:sp>
+        <p:nvSpPr>
+          <p:cNvPr id="51" name="Rounded Rectangle 50"/>
           <p:cNvSpPr/>
           <p:nvPr/>
         </p:nvSpPr>
@@ -9838,7 +10136,7 @@
       </p:sp>
       <p:sp>
         <p:nvSpPr>
-          <p:cNvPr id="45" name="TextBox 44"/>
+          <p:cNvPr id="52" name="TextBox 51"/>
           <p:cNvSpPr txBox="1"/>
           <p:nvPr/>
         </p:nvSpPr>

</xml_diff>

<commit_message>
docs: deck — MORE TOOLS slide (migration, LLM summaries, manuscript, curation)
Coverage gap fix: 30 commands existed but the deck showed under half.
New slide 16 covers Zotero/EndNote import + export, PubMed-add LLM
summaries (full text for OA) with real MeSH tags, compile-manuscript,
and curation tools (retraction alerts, reading queue, dedup, OA PDF,
highlights). 18 slides; script/plan/spec renumbered.

Co-Authored-By: Claude Fable 5 <noreply@anthropic.com>
</commit_message>
<xml_diff>
--- a/presentation/rag_obsidian_deck.pptx
+++ b/presentation/rag_obsidian_deck.pptx
@@ -22,6 +22,7 @@
     <p:sldId id="270" r:id="rId21"/>
     <p:sldId id="271" r:id="rId22"/>
     <p:sldId id="272" r:id="rId23"/>
+    <p:sldId id="273" r:id="rId24"/>
   </p:sldIdLst>
   <p:sldSz cx="12191695" cy="6858000" type="screen4x3"/>
   <p:notesSz cx="6858000" cy="9144000"/>
@@ -10265,7 +10266,7 @@
                 <a:ea typeface="Pretendard"/>
                 <a:cs typeface="Pretendard"/>
               </a:rPr>
-              <a:t>CONCLUSION</a:t>
+              <a:t>MORE TOOLS</a:t>
             </a:r>
           </a:p>
         </p:txBody>
@@ -10306,7 +10307,7 @@
                 <a:ea typeface="Pretendard"/>
                 <a:cs typeface="Pretendard"/>
               </a:rPr>
-              <a:t>Zotero 없이, 서버 없이, 늘 출처와 함께</a:t>
+              <a:t>추가부터 투고까지, 연구 워크플로 전체를 덮는다</a:t>
             </a:r>
           </a:p>
         </p:txBody>
@@ -10423,14 +10424,51 @@
       </p:sp>
       <p:sp>
         <p:nvSpPr>
-          <p:cNvPr id="8" name="Rounded Rectangle 7"/>
+          <p:cNvPr id="8" name="TextBox 7"/>
+          <p:cNvSpPr txBox="1"/>
+          <p:nvPr/>
+        </p:nvSpPr>
+        <p:spPr>
+          <a:xfrm>
+            <a:off x="6567403" y="6617421"/>
+            <a:ext cx="5486400" cy="228600"/>
+          </a:xfrm>
+          <a:prstGeom prst="rect">
+            <a:avLst/>
+          </a:prstGeom>
+          <a:noFill/>
+        </p:spPr>
+        <p:txBody>
+          <a:bodyPr wrap="square" anchor="t" lIns="0" rIns="0" tIns="0" bIns="0">
+            <a:spAutoFit/>
+          </a:bodyPr>
+          <a:lstStyle/>
+          <a:p>
+            <a:pPr algn="r"/>
+            <a:r>
+              <a:rPr sz="800" b="0" i="0" spc="-8">
+                <a:solidFill>
+                  <a:srgbClr val="8E8E93"/>
+                </a:solidFill>
+                <a:latin typeface="Pretendard"/>
+                <a:ea typeface="Pretendard"/>
+                <a:cs typeface="Pretendard"/>
+              </a:rPr>
+              <a:t>명령 30개 · 전부 Cmd+P</a:t>
+            </a:r>
+          </a:p>
+        </p:txBody>
+      </p:sp>
+      <p:sp>
+        <p:nvSpPr>
+          <p:cNvPr id="9" name="Rounded Rectangle 8"/>
           <p:cNvSpPr/>
           <p:nvPr/>
         </p:nvSpPr>
         <p:spPr>
           <a:xfrm>
             <a:off x="663122" y="1747509"/>
-            <a:ext cx="3491362" cy="3200400"/>
+            <a:ext cx="2568229" cy="3200400"/>
           </a:xfrm>
           <a:prstGeom prst="roundRect">
             <a:avLst>
@@ -10471,14 +10509,14 @@
       </p:sp>
       <p:sp>
         <p:nvSpPr>
-          <p:cNvPr id="9" name="Rectangle 8"/>
+          <p:cNvPr id="10" name="Rectangle 9"/>
           <p:cNvSpPr/>
           <p:nvPr/>
         </p:nvSpPr>
         <p:spPr>
           <a:xfrm>
             <a:off x="663122" y="1747509"/>
-            <a:ext cx="3491362" cy="64008"/>
+            <a:ext cx="2568229" cy="64008"/>
           </a:xfrm>
           <a:prstGeom prst="rect">
             <a:avLst/>
@@ -10515,13 +10553,13 @@
       </p:sp>
       <p:sp>
         <p:nvSpPr>
-          <p:cNvPr id="10" name="Rounded Rectangle 9"/>
+          <p:cNvPr id="11" name="Rounded Rectangle 10"/>
           <p:cNvSpPr/>
           <p:nvPr/>
         </p:nvSpPr>
         <p:spPr>
           <a:xfrm>
-            <a:off x="1540123" y="2003541"/>
+            <a:off x="1078557" y="2003541"/>
             <a:ext cx="1737360" cy="310896"/>
           </a:xfrm>
           <a:prstGeom prst="roundRect">
@@ -10561,13 +10599,13 @@
       </p:sp>
       <p:sp>
         <p:nvSpPr>
-          <p:cNvPr id="11" name="TextBox 10"/>
-          <p:cNvSpPr txBox="1"/>
-          <p:nvPr/>
-        </p:nvSpPr>
-        <p:spPr>
-          <a:xfrm>
-            <a:off x="1540123" y="2003541"/>
+          <p:cNvPr id="12" name="TextBox 11"/>
+          <p:cNvSpPr txBox="1"/>
+          <p:nvPr/>
+        </p:nvSpPr>
+        <p:spPr>
+          <a:xfrm>
+            <a:off x="1078557" y="2003541"/>
             <a:ext cx="1737360" cy="310896"/>
           </a:xfrm>
           <a:prstGeom prst="rect">
@@ -10591,21 +10629,21 @@
                 <a:ea typeface="Pretendard"/>
                 <a:cs typeface="Pretendard"/>
               </a:rPr>
-              <a:t>OWN YOUR DATA</a:t>
-            </a:r>
-          </a:p>
-        </p:txBody>
-      </p:sp>
-      <p:sp>
-        <p:nvSpPr>
-          <p:cNvPr id="12" name="TextBox 11"/>
+              <a:t>MIGRATE</a:t>
+            </a:r>
+          </a:p>
+        </p:txBody>
+      </p:sp>
+      <p:sp>
+        <p:nvSpPr>
+          <p:cNvPr id="13" name="TextBox 12"/>
           <p:cNvSpPr txBox="1"/>
           <p:nvPr/>
         </p:nvSpPr>
         <p:spPr>
           <a:xfrm>
             <a:off x="754562" y="2616189"/>
-            <a:ext cx="3308482" cy="1554480"/>
+            <a:ext cx="2385349" cy="1554480"/>
           </a:xfrm>
           <a:prstGeom prst="rect">
             <a:avLst/>
@@ -10628,7 +10666,7 @@
                 <a:ea typeface="Pretendard"/>
                 <a:cs typeface="Pretendard"/>
               </a:rPr>
-              <a:t>마크다운</a:t>
+              <a:t>이관</a:t>
             </a:r>
           </a:p>
           <a:p>
@@ -10646,7 +10684,7 @@
                 <a:ea typeface="Pretendard"/>
                 <a:cs typeface="Pretendard"/>
               </a:rPr>
-              <a:t>= 내 DB</a:t>
+              <a:t>Zotero·EndNote</a:t>
             </a:r>
           </a:p>
           <a:p>
@@ -10667,22 +10705,23 @@
                 <a:ea typeface="Pretendard"/>
                 <a:cs typeface="Pretendard"/>
               </a:rPr>
-              <a:t>평문·git·로컬 우선
-플러그인보다 오래 남음</a:t>
-            </a:r>
-          </a:p>
-        </p:txBody>
-      </p:sp>
-      <p:sp>
-        <p:nvSpPr>
-          <p:cNvPr id="13" name="Rounded Rectangle 12"/>
+              <a:t>BibTeX/RIS/CSL-JSON
+한 번에 가져오고
+언제든 도로 내보내기</a:t>
+            </a:r>
+          </a:p>
+        </p:txBody>
+      </p:sp>
+      <p:sp>
+        <p:nvSpPr>
+          <p:cNvPr id="14" name="Rounded Rectangle 13"/>
           <p:cNvSpPr/>
           <p:nvPr/>
         </p:nvSpPr>
         <p:spPr>
           <a:xfrm>
-            <a:off x="4355652" y="1747509"/>
-            <a:ext cx="3491362" cy="3200400"/>
+            <a:off x="3432520" y="1747509"/>
+            <a:ext cx="2568229" cy="3200400"/>
           </a:xfrm>
           <a:prstGeom prst="roundRect">
             <a:avLst>
@@ -10723,14 +10762,14 @@
       </p:sp>
       <p:sp>
         <p:nvSpPr>
-          <p:cNvPr id="14" name="Rectangle 13"/>
+          <p:cNvPr id="15" name="Rectangle 14"/>
           <p:cNvSpPr/>
           <p:nvPr/>
         </p:nvSpPr>
         <p:spPr>
           <a:xfrm>
-            <a:off x="4355652" y="1747509"/>
-            <a:ext cx="3491362" cy="64008"/>
+            <a:off x="3432520" y="1747509"/>
+            <a:ext cx="2568229" cy="64008"/>
           </a:xfrm>
           <a:prstGeom prst="rect">
             <a:avLst/>
@@ -10767,13 +10806,13 @@
       </p:sp>
       <p:sp>
         <p:nvSpPr>
-          <p:cNvPr id="15" name="Rounded Rectangle 14"/>
+          <p:cNvPr id="16" name="Rounded Rectangle 15"/>
           <p:cNvSpPr/>
           <p:nvPr/>
         </p:nvSpPr>
         <p:spPr>
           <a:xfrm>
-            <a:off x="5232654" y="2003541"/>
+            <a:off x="3847955" y="2003541"/>
             <a:ext cx="1737360" cy="310896"/>
           </a:xfrm>
           <a:prstGeom prst="roundRect">
@@ -10813,13 +10852,13 @@
       </p:sp>
       <p:sp>
         <p:nvSpPr>
-          <p:cNvPr id="16" name="TextBox 15"/>
-          <p:cNvSpPr txBox="1"/>
-          <p:nvPr/>
-        </p:nvSpPr>
-        <p:spPr>
-          <a:xfrm>
-            <a:off x="5232654" y="2003541"/>
+          <p:cNvPr id="17" name="TextBox 16"/>
+          <p:cNvSpPr txBox="1"/>
+          <p:nvPr/>
+        </p:nvSpPr>
+        <p:spPr>
+          <a:xfrm>
+            <a:off x="3847955" y="2003541"/>
             <a:ext cx="1737360" cy="310896"/>
           </a:xfrm>
           <a:prstGeom prst="rect">
@@ -10843,21 +10882,21 @@
                 <a:ea typeface="Pretendard"/>
                 <a:cs typeface="Pretendard"/>
               </a:rPr>
-              <a:t>GROUNDED</a:t>
-            </a:r>
-          </a:p>
-        </p:txBody>
-      </p:sp>
-      <p:sp>
-        <p:nvSpPr>
-          <p:cNvPr id="17" name="TextBox 16"/>
-          <p:cNvSpPr txBox="1"/>
-          <p:nvPr/>
-        </p:nvSpPr>
-        <p:spPr>
-          <a:xfrm>
-            <a:off x="4447092" y="2616189"/>
-            <a:ext cx="3308482" cy="1554480"/>
+              <a:t>SUMMARIZE</a:t>
+            </a:r>
+          </a:p>
+        </p:txBody>
+      </p:sp>
+      <p:sp>
+        <p:nvSpPr>
+          <p:cNvPr id="18" name="TextBox 17"/>
+          <p:cNvSpPr txBox="1"/>
+          <p:nvPr/>
+        </p:nvSpPr>
+        <p:spPr>
+          <a:xfrm>
+            <a:off x="3523960" y="2616189"/>
+            <a:ext cx="2385349" cy="1554480"/>
           </a:xfrm>
           <a:prstGeom prst="rect">
             <a:avLst/>
@@ -10880,7 +10919,7 @@
                 <a:ea typeface="Pretendard"/>
                 <a:cs typeface="Pretendard"/>
               </a:rPr>
-              <a:t>근거</a:t>
+              <a:t>요약</a:t>
             </a:r>
           </a:p>
           <a:p>
@@ -10898,7 +10937,7 @@
                 <a:ea typeface="Pretendard"/>
                 <a:cs typeface="Pretendard"/>
               </a:rPr>
-              <a:t>구절 인용</a:t>
+              <a:t>LLM + MeSH</a:t>
             </a:r>
           </a:p>
           <a:p>
@@ -10919,22 +10958,23 @@
                 <a:ea typeface="Pretendard"/>
                 <a:cs typeface="Pretendard"/>
               </a:rPr>
-              <a:t>출처 없는 답 없음
-서식 참고문헌까지</a:t>
-            </a:r>
-          </a:p>
-        </p:txBody>
-      </p:sp>
-      <p:sp>
-        <p:nvSpPr>
-          <p:cNvPr id="18" name="Rounded Rectangle 17"/>
+              <a:t>PubMed 추가 시 자동 요약
+(OA는 전문 기반)
++ 진짜 MeSH 태그</a:t>
+            </a:r>
+          </a:p>
+        </p:txBody>
+      </p:sp>
+      <p:sp>
+        <p:nvSpPr>
+          <p:cNvPr id="19" name="Rounded Rectangle 18"/>
           <p:cNvSpPr/>
           <p:nvPr/>
         </p:nvSpPr>
         <p:spPr>
           <a:xfrm>
-            <a:off x="8048183" y="1747509"/>
-            <a:ext cx="3491362" cy="3200400"/>
+            <a:off x="6201918" y="1747509"/>
+            <a:ext cx="2568229" cy="3200400"/>
           </a:xfrm>
           <a:prstGeom prst="roundRect">
             <a:avLst>
@@ -10975,14 +11015,14 @@
       </p:sp>
       <p:sp>
         <p:nvSpPr>
-          <p:cNvPr id="19" name="Rectangle 18"/>
+          <p:cNvPr id="20" name="Rectangle 19"/>
           <p:cNvSpPr/>
           <p:nvPr/>
         </p:nvSpPr>
         <p:spPr>
           <a:xfrm>
-            <a:off x="8048183" y="1747509"/>
-            <a:ext cx="3491362" cy="64008"/>
+            <a:off x="6201918" y="1747509"/>
+            <a:ext cx="2568229" cy="64008"/>
           </a:xfrm>
           <a:prstGeom prst="rect">
             <a:avLst/>
@@ -11019,13 +11059,13 @@
       </p:sp>
       <p:sp>
         <p:nvSpPr>
-          <p:cNvPr id="20" name="Rounded Rectangle 19"/>
+          <p:cNvPr id="21" name="Rounded Rectangle 20"/>
           <p:cNvSpPr/>
           <p:nvPr/>
         </p:nvSpPr>
         <p:spPr>
           <a:xfrm>
-            <a:off x="8925184" y="2003541"/>
+            <a:off x="6617352" y="2003541"/>
             <a:ext cx="1737360" cy="310896"/>
           </a:xfrm>
           <a:prstGeom prst="roundRect">
@@ -11065,13 +11105,13 @@
       </p:sp>
       <p:sp>
         <p:nvSpPr>
-          <p:cNvPr id="21" name="TextBox 20"/>
-          <p:cNvSpPr txBox="1"/>
-          <p:nvPr/>
-        </p:nvSpPr>
-        <p:spPr>
-          <a:xfrm>
-            <a:off x="8925184" y="2003541"/>
+          <p:cNvPr id="22" name="TextBox 21"/>
+          <p:cNvSpPr txBox="1"/>
+          <p:nvPr/>
+        </p:nvSpPr>
+        <p:spPr>
+          <a:xfrm>
+            <a:off x="6617352" y="2003541"/>
             <a:ext cx="1737360" cy="310896"/>
           </a:xfrm>
           <a:prstGeom prst="rect">
@@ -11095,21 +11135,21 @@
                 <a:ea typeface="Pretendard"/>
                 <a:cs typeface="Pretendard"/>
               </a:rPr>
-              <a:t>GRAPH-LITE</a:t>
-            </a:r>
-          </a:p>
-        </p:txBody>
-      </p:sp>
-      <p:sp>
-        <p:nvSpPr>
-          <p:cNvPr id="22" name="TextBox 21"/>
-          <p:cNvSpPr txBox="1"/>
-          <p:nvPr/>
-        </p:nvSpPr>
-        <p:spPr>
-          <a:xfrm>
-            <a:off x="8139623" y="2616189"/>
-            <a:ext cx="3308482" cy="1554480"/>
+              <a:t>WRITE</a:t>
+            </a:r>
+          </a:p>
+        </p:txBody>
+      </p:sp>
+      <p:sp>
+        <p:nvSpPr>
+          <p:cNvPr id="23" name="TextBox 22"/>
+          <p:cNvSpPr txBox="1"/>
+          <p:nvPr/>
+        </p:nvSpPr>
+        <p:spPr>
+          <a:xfrm>
+            <a:off x="6293358" y="2616189"/>
+            <a:ext cx="2385349" cy="1554480"/>
           </a:xfrm>
           <a:prstGeom prst="rect">
             <a:avLst/>
@@ -11132,7 +11172,7 @@
                 <a:ea typeface="Pretendard"/>
                 <a:cs typeface="Pretendard"/>
               </a:rPr>
-              <a:t>그래프</a:t>
+              <a:t>투고</a:t>
             </a:r>
           </a:p>
           <a:p>
@@ -11150,7 +11190,7 @@
                 <a:ea typeface="Pretendard"/>
                 <a:cs typeface="Pretendard"/>
               </a:rPr>
-              <a:t>놓친 논문</a:t>
+              <a:t>원고 컴파일</a:t>
             </a:r>
           </a:p>
           <a:p>
@@ -11171,15 +11211,269 @@
                 <a:ea typeface="Pretendard"/>
                 <a:cs typeface="Pretendard"/>
               </a:rPr>
-              <a:t>OpenAlex 인용엣지
-LLM 비용 0</a:t>
-            </a:r>
-          </a:p>
-        </p:txBody>
-      </p:sp>
-      <p:sp>
-        <p:nvSpPr>
-          <p:cNvPr id="23" name="Rounded Rectangle 22"/>
+              <a:t>[@키] 전부 풀어
+인용+참고문헌 완성본
+(Pandoc-ready)</a:t>
+            </a:r>
+          </a:p>
+        </p:txBody>
+      </p:sp>
+      <p:sp>
+        <p:nvSpPr>
+          <p:cNvPr id="24" name="Rounded Rectangle 23"/>
+          <p:cNvSpPr/>
+          <p:nvPr/>
+        </p:nvSpPr>
+        <p:spPr>
+          <a:xfrm>
+            <a:off x="8971315" y="1747509"/>
+            <a:ext cx="2568229" cy="3200400"/>
+          </a:xfrm>
+          <a:prstGeom prst="roundRect">
+            <a:avLst>
+              <a:gd name="adj" fmla="val 6000"/>
+            </a:avLst>
+          </a:prstGeom>
+          <a:solidFill>
+            <a:srgbClr val="FFFFFF"/>
+          </a:solidFill>
+          <a:ln w="9525">
+            <a:solidFill>
+              <a:srgbClr val="D9D9D9"/>
+            </a:solidFill>
+          </a:ln>
+          <a:effectLst/>
+        </p:spPr>
+        <p:style>
+          <a:lnRef idx="1">
+            <a:schemeClr val="accent1"/>
+          </a:lnRef>
+          <a:fillRef idx="3">
+            <a:schemeClr val="accent1"/>
+          </a:fillRef>
+          <a:effectRef idx="2">
+            <a:schemeClr val="accent1"/>
+          </a:effectRef>
+          <a:fontRef idx="minor">
+            <a:schemeClr val="lt1"/>
+          </a:fontRef>
+        </p:style>
+        <p:txBody>
+          <a:bodyPr rtlCol="0" anchor="ctr"/>
+          <a:lstStyle/>
+          <a:p>
+            <a:pPr algn="ctr"/>
+          </a:p>
+        </p:txBody>
+      </p:sp>
+      <p:sp>
+        <p:nvSpPr>
+          <p:cNvPr id="25" name="Rectangle 24"/>
+          <p:cNvSpPr/>
+          <p:nvPr/>
+        </p:nvSpPr>
+        <p:spPr>
+          <a:xfrm>
+            <a:off x="8971315" y="1747509"/>
+            <a:ext cx="2568229" cy="64008"/>
+          </a:xfrm>
+          <a:prstGeom prst="rect">
+            <a:avLst/>
+          </a:prstGeom>
+          <a:solidFill>
+            <a:srgbClr val="00754A"/>
+          </a:solidFill>
+          <a:ln>
+            <a:noFill/>
+          </a:ln>
+          <a:effectLst/>
+        </p:spPr>
+        <p:style>
+          <a:lnRef idx="1">
+            <a:schemeClr val="accent1"/>
+          </a:lnRef>
+          <a:fillRef idx="3">
+            <a:schemeClr val="accent1"/>
+          </a:fillRef>
+          <a:effectRef idx="2">
+            <a:schemeClr val="accent1"/>
+          </a:effectRef>
+          <a:fontRef idx="minor">
+            <a:schemeClr val="lt1"/>
+          </a:fontRef>
+        </p:style>
+        <p:txBody>
+          <a:bodyPr rtlCol="0" anchor="ctr"/>
+          <a:lstStyle/>
+          <a:p>
+            <a:pPr algn="ctr"/>
+          </a:p>
+        </p:txBody>
+      </p:sp>
+      <p:sp>
+        <p:nvSpPr>
+          <p:cNvPr id="26" name="Rounded Rectangle 25"/>
+          <p:cNvSpPr/>
+          <p:nvPr/>
+        </p:nvSpPr>
+        <p:spPr>
+          <a:xfrm>
+            <a:off x="9386750" y="2003541"/>
+            <a:ext cx="1737360" cy="310896"/>
+          </a:xfrm>
+          <a:prstGeom prst="roundRect">
+            <a:avLst>
+              <a:gd name="adj" fmla="val 50000"/>
+            </a:avLst>
+          </a:prstGeom>
+          <a:solidFill>
+            <a:srgbClr val="00754A"/>
+          </a:solidFill>
+          <a:ln>
+            <a:noFill/>
+          </a:ln>
+          <a:effectLst/>
+        </p:spPr>
+        <p:style>
+          <a:lnRef idx="1">
+            <a:schemeClr val="accent1"/>
+          </a:lnRef>
+          <a:fillRef idx="3">
+            <a:schemeClr val="accent1"/>
+          </a:fillRef>
+          <a:effectRef idx="2">
+            <a:schemeClr val="accent1"/>
+          </a:effectRef>
+          <a:fontRef idx="minor">
+            <a:schemeClr val="lt1"/>
+          </a:fontRef>
+        </p:style>
+        <p:txBody>
+          <a:bodyPr rtlCol="0" anchor="ctr"/>
+          <a:lstStyle/>
+          <a:p>
+            <a:pPr algn="ctr"/>
+          </a:p>
+        </p:txBody>
+      </p:sp>
+      <p:sp>
+        <p:nvSpPr>
+          <p:cNvPr id="27" name="TextBox 26"/>
+          <p:cNvSpPr txBox="1"/>
+          <p:nvPr/>
+        </p:nvSpPr>
+        <p:spPr>
+          <a:xfrm>
+            <a:off x="9386750" y="2003541"/>
+            <a:ext cx="1737360" cy="310896"/>
+          </a:xfrm>
+          <a:prstGeom prst="rect">
+            <a:avLst/>
+          </a:prstGeom>
+          <a:noFill/>
+        </p:spPr>
+        <p:txBody>
+          <a:bodyPr wrap="square" anchor="ctr" lIns="0" rIns="0" tIns="0" bIns="0">
+            <a:spAutoFit/>
+          </a:bodyPr>
+          <a:lstStyle/>
+          <a:p>
+            <a:pPr algn="ctr"/>
+            <a:r>
+              <a:rPr sz="1100" b="1" i="0" spc="-11">
+                <a:solidFill>
+                  <a:srgbClr val="FFFFFF"/>
+                </a:solidFill>
+                <a:latin typeface="Pretendard"/>
+                <a:ea typeface="Pretendard"/>
+                <a:cs typeface="Pretendard"/>
+              </a:rPr>
+              <a:t>CURATE</a:t>
+            </a:r>
+          </a:p>
+        </p:txBody>
+      </p:sp>
+      <p:sp>
+        <p:nvSpPr>
+          <p:cNvPr id="28" name="TextBox 27"/>
+          <p:cNvSpPr txBox="1"/>
+          <p:nvPr/>
+        </p:nvSpPr>
+        <p:spPr>
+          <a:xfrm>
+            <a:off x="9062755" y="2616189"/>
+            <a:ext cx="2385349" cy="1554480"/>
+          </a:xfrm>
+          <a:prstGeom prst="rect">
+            <a:avLst/>
+          </a:prstGeom>
+          <a:noFill/>
+        </p:spPr>
+        <p:txBody>
+          <a:bodyPr wrap="square" anchor="t" lIns="0" rIns="0" tIns="0" bIns="0">
+            <a:spAutoFit/>
+          </a:bodyPr>
+          <a:lstStyle/>
+          <a:p>
+            <a:pPr algn="ctr"/>
+            <a:r>
+              <a:rPr sz="3400" b="1" i="0" spc="-34">
+                <a:solidFill>
+                  <a:srgbClr val="006241"/>
+                </a:solidFill>
+                <a:latin typeface="Pretendard"/>
+                <a:ea typeface="Pretendard"/>
+                <a:cs typeface="Pretendard"/>
+              </a:rPr>
+              <a:t>관리</a:t>
+            </a:r>
+          </a:p>
+          <a:p>
+            <a:pPr algn="ctr">
+              <a:spcBef>
+                <a:spcPts val="200"/>
+              </a:spcBef>
+            </a:pPr>
+            <a:r>
+              <a:rPr sz="1600" b="1" i="0" spc="-16">
+                <a:solidFill>
+                  <a:srgbClr val="1F1F1F"/>
+                </a:solidFill>
+                <a:latin typeface="Pretendard"/>
+                <a:ea typeface="Pretendard"/>
+                <a:cs typeface="Pretendard"/>
+              </a:rPr>
+              <a:t>서재 위생</a:t>
+            </a:r>
+          </a:p>
+          <a:p>
+            <a:pPr algn="ctr">
+              <a:lnSpc>
+                <a:spcPts val="1600"/>
+              </a:lnSpc>
+              <a:spcBef>
+                <a:spcPts val="1000"/>
+              </a:spcBef>
+            </a:pPr>
+            <a:r>
+              <a:rPr sz="1200" b="0" i="0" spc="-12">
+                <a:solidFill>
+                  <a:srgbClr val="6B6B6B"/>
+                </a:solidFill>
+                <a:latin typeface="Pretendard"/>
+                <a:ea typeface="Pretendard"/>
+                <a:cs typeface="Pretendard"/>
+              </a:rPr>
+              <a:t>철회 경고 · 중복 정리
+읽기 큐 · OA PDF 다운로드
+PDF 하이라이트 추출</a:t>
+            </a:r>
+          </a:p>
+        </p:txBody>
+      </p:sp>
+      <p:sp>
+        <p:nvSpPr>
+          <p:cNvPr id="29" name="Rounded Rectangle 28"/>
           <p:cNvSpPr/>
           <p:nvPr/>
         </p:nvSpPr>
@@ -11225,7 +11519,7 @@
       </p:sp>
       <p:sp>
         <p:nvSpPr>
-          <p:cNvPr id="24" name="TextBox 23"/>
+          <p:cNvPr id="30" name="TextBox 29"/>
           <p:cNvSpPr txBox="1"/>
           <p:nvPr/>
         </p:nvSpPr>
@@ -11255,7 +11549,7 @@
                 <a:ea typeface="Pretendard"/>
                 <a:cs typeface="Pretendard"/>
               </a:rPr>
-              <a:t>내 서재가 곧 검색엔진이고, 답은 늘 출처와 함께 — RAG Obsidian</a:t>
+              <a:t>갈아타기 부담 0 (이관+내보내기) — 들어온 뒤엔 읽기·쓰기·투고까지 한 앱에서</a:t>
             </a:r>
           </a:p>
         </p:txBody>
@@ -11269,6 +11563,1095 @@
 </file>
 
 <file path=ppt/slides/slide17.xml><?xml version="1.0" encoding="utf-8"?>
+<p:sld xmlns:a="http://schemas.openxmlformats.org/drawingml/2006/main" xmlns:p="http://schemas.openxmlformats.org/presentationml/2006/main" xmlns:r="http://schemas.openxmlformats.org/officeDocument/2006/relationships">
+  <p:cSld>
+    <p:spTree>
+      <p:nvGrpSpPr>
+        <p:cNvPr id="1" name=""/>
+        <p:cNvGrpSpPr/>
+        <p:nvPr/>
+      </p:nvGrpSpPr>
+      <p:grpSpPr/>
+      <p:sp>
+        <p:nvSpPr>
+          <p:cNvPr id="2" name="Rectangle 1"/>
+          <p:cNvSpPr/>
+          <p:nvPr/>
+        </p:nvSpPr>
+        <p:spPr>
+          <a:xfrm>
+            <a:off x="0" y="0"/>
+            <a:ext cx="12191695" cy="6858000"/>
+          </a:xfrm>
+          <a:prstGeom prst="rect">
+            <a:avLst/>
+          </a:prstGeom>
+          <a:solidFill>
+            <a:srgbClr val="F2F0EB"/>
+          </a:solidFill>
+          <a:ln>
+            <a:noFill/>
+          </a:ln>
+          <a:effectLst/>
+        </p:spPr>
+        <p:style>
+          <a:lnRef idx="1">
+            <a:schemeClr val="accent1"/>
+          </a:lnRef>
+          <a:fillRef idx="3">
+            <a:schemeClr val="accent1"/>
+          </a:fillRef>
+          <a:effectRef idx="2">
+            <a:schemeClr val="accent1"/>
+          </a:effectRef>
+          <a:fontRef idx="minor">
+            <a:schemeClr val="lt1"/>
+          </a:fontRef>
+        </p:style>
+        <p:txBody>
+          <a:bodyPr rtlCol="0" anchor="ctr"/>
+          <a:lstStyle/>
+          <a:p>
+            <a:pPr algn="ctr"/>
+          </a:p>
+        </p:txBody>
+      </p:sp>
+      <p:sp>
+        <p:nvSpPr>
+          <p:cNvPr id="3" name="TextBox 2"/>
+          <p:cNvSpPr txBox="1"/>
+          <p:nvPr/>
+        </p:nvSpPr>
+        <p:spPr>
+          <a:xfrm>
+            <a:off x="138257" y="123444"/>
+            <a:ext cx="5486400" cy="256032"/>
+          </a:xfrm>
+          <a:prstGeom prst="rect">
+            <a:avLst/>
+          </a:prstGeom>
+          <a:noFill/>
+        </p:spPr>
+        <p:txBody>
+          <a:bodyPr wrap="square" anchor="t" lIns="0" rIns="0" tIns="0" bIns="0">
+            <a:spAutoFit/>
+          </a:bodyPr>
+          <a:lstStyle/>
+          <a:p>
+            <a:pPr algn="l"/>
+            <a:r>
+              <a:rPr sz="1100" b="1" i="0" spc="-11">
+                <a:solidFill>
+                  <a:srgbClr val="8E8E93"/>
+                </a:solidFill>
+                <a:latin typeface="Pretendard"/>
+                <a:ea typeface="Pretendard"/>
+                <a:cs typeface="Pretendard"/>
+              </a:rPr>
+              <a:t>CONCLUSION</a:t>
+            </a:r>
+          </a:p>
+        </p:txBody>
+      </p:sp>
+      <p:sp>
+        <p:nvSpPr>
+          <p:cNvPr id="4" name="TextBox 3"/>
+          <p:cNvSpPr txBox="1"/>
+          <p:nvPr/>
+        </p:nvSpPr>
+        <p:spPr>
+          <a:xfrm>
+            <a:off x="251642" y="436260"/>
+            <a:ext cx="10972800" cy="640080"/>
+          </a:xfrm>
+          <a:prstGeom prst="rect">
+            <a:avLst/>
+          </a:prstGeom>
+          <a:noFill/>
+        </p:spPr>
+        <p:txBody>
+          <a:bodyPr wrap="square" anchor="t" lIns="0" rIns="0" tIns="0" bIns="0">
+            <a:spAutoFit/>
+          </a:bodyPr>
+          <a:lstStyle/>
+          <a:p>
+            <a:pPr algn="l">
+              <a:lnSpc>
+                <a:spcPts val="3600"/>
+              </a:lnSpc>
+            </a:pPr>
+            <a:r>
+              <a:rPr sz="3000" b="1" i="0" spc="-30">
+                <a:solidFill>
+                  <a:srgbClr val="006241"/>
+                </a:solidFill>
+                <a:latin typeface="Pretendard"/>
+                <a:ea typeface="Pretendard"/>
+                <a:cs typeface="Pretendard"/>
+              </a:rPr>
+              <a:t>Zotero 없이, 서버 없이, 늘 출처와 함께</a:t>
+            </a:r>
+          </a:p>
+        </p:txBody>
+      </p:sp>
+      <p:pic>
+        <p:nvPicPr>
+          <p:cNvPr id="5" name="Picture 4" descr="logo.png"/>
+          <p:cNvPicPr>
+            <a:picLocks noChangeAspect="1"/>
+          </p:cNvPicPr>
+          <p:nvPr/>
+        </p:nvPicPr>
+        <p:blipFill>
+          <a:blip r:embed="rId2"/>
+          <a:srcRect l="3240" r="16360" t="21390" b="11330"/>
+          <a:stretch>
+            <a:fillRect/>
+          </a:stretch>
+        </p:blipFill>
+        <p:spPr>
+          <a:xfrm>
+            <a:off x="10748314" y="11978"/>
+            <a:ext cx="1443654" cy="798545"/>
+          </a:xfrm>
+          <a:prstGeom prst="rect">
+            <a:avLst/>
+          </a:prstGeom>
+        </p:spPr>
+      </p:pic>
+      <p:sp>
+        <p:nvSpPr>
+          <p:cNvPr id="6" name="Rounded Rectangle 5"/>
+          <p:cNvSpPr/>
+          <p:nvPr/>
+        </p:nvSpPr>
+        <p:spPr>
+          <a:xfrm>
+            <a:off x="251642" y="1290309"/>
+            <a:ext cx="11699382" cy="5227350"/>
+          </a:xfrm>
+          <a:prstGeom prst="roundRect">
+            <a:avLst>
+              <a:gd name="adj" fmla="val 3500"/>
+            </a:avLst>
+          </a:prstGeom>
+          <a:solidFill>
+            <a:srgbClr val="FFFFFF"/>
+          </a:solidFill>
+          <a:ln w="9525">
+            <a:solidFill>
+              <a:srgbClr val="D9D9D9"/>
+            </a:solidFill>
+          </a:ln>
+          <a:effectLst/>
+        </p:spPr>
+        <p:style>
+          <a:lnRef idx="1">
+            <a:schemeClr val="accent1"/>
+          </a:lnRef>
+          <a:fillRef idx="3">
+            <a:schemeClr val="accent1"/>
+          </a:fillRef>
+          <a:effectRef idx="2">
+            <a:schemeClr val="accent1"/>
+          </a:effectRef>
+          <a:fontRef idx="minor">
+            <a:schemeClr val="lt1"/>
+          </a:fontRef>
+        </p:style>
+        <p:txBody>
+          <a:bodyPr rtlCol="0" anchor="ctr"/>
+          <a:lstStyle/>
+          <a:p>
+            <a:pPr algn="ctr"/>
+          </a:p>
+        </p:txBody>
+      </p:sp>
+      <p:sp>
+        <p:nvSpPr>
+          <p:cNvPr id="7" name="TextBox 6"/>
+          <p:cNvSpPr txBox="1"/>
+          <p:nvPr/>
+        </p:nvSpPr>
+        <p:spPr>
+          <a:xfrm>
+            <a:off x="138257" y="6620256"/>
+            <a:ext cx="548640" cy="228600"/>
+          </a:xfrm>
+          <a:prstGeom prst="rect">
+            <a:avLst/>
+          </a:prstGeom>
+          <a:noFill/>
+        </p:spPr>
+        <p:txBody>
+          <a:bodyPr wrap="square" anchor="t" lIns="0" rIns="0" tIns="0" bIns="0">
+            <a:spAutoFit/>
+          </a:bodyPr>
+          <a:lstStyle/>
+          <a:p>
+            <a:pPr algn="l"/>
+            <a:r>
+              <a:rPr sz="900" b="0" i="0" spc="-9">
+                <a:solidFill>
+                  <a:srgbClr val="8E8E93"/>
+                </a:solidFill>
+                <a:latin typeface="Pretendard"/>
+                <a:ea typeface="Pretendard"/>
+                <a:cs typeface="Pretendard"/>
+              </a:rPr>
+              <a:t>17</a:t>
+            </a:r>
+          </a:p>
+        </p:txBody>
+      </p:sp>
+      <p:sp>
+        <p:nvSpPr>
+          <p:cNvPr id="8" name="Rounded Rectangle 7"/>
+          <p:cNvSpPr/>
+          <p:nvPr/>
+        </p:nvSpPr>
+        <p:spPr>
+          <a:xfrm>
+            <a:off x="663122" y="1747509"/>
+            <a:ext cx="3491362" cy="3200400"/>
+          </a:xfrm>
+          <a:prstGeom prst="roundRect">
+            <a:avLst>
+              <a:gd name="adj" fmla="val 6000"/>
+            </a:avLst>
+          </a:prstGeom>
+          <a:solidFill>
+            <a:srgbClr val="FFFFFF"/>
+          </a:solidFill>
+          <a:ln w="9525">
+            <a:solidFill>
+              <a:srgbClr val="D9D9D9"/>
+            </a:solidFill>
+          </a:ln>
+          <a:effectLst/>
+        </p:spPr>
+        <p:style>
+          <a:lnRef idx="1">
+            <a:schemeClr val="accent1"/>
+          </a:lnRef>
+          <a:fillRef idx="3">
+            <a:schemeClr val="accent1"/>
+          </a:fillRef>
+          <a:effectRef idx="2">
+            <a:schemeClr val="accent1"/>
+          </a:effectRef>
+          <a:fontRef idx="minor">
+            <a:schemeClr val="lt1"/>
+          </a:fontRef>
+        </p:style>
+        <p:txBody>
+          <a:bodyPr rtlCol="0" anchor="ctr"/>
+          <a:lstStyle/>
+          <a:p>
+            <a:pPr algn="ctr"/>
+          </a:p>
+        </p:txBody>
+      </p:sp>
+      <p:sp>
+        <p:nvSpPr>
+          <p:cNvPr id="9" name="Rectangle 8"/>
+          <p:cNvSpPr/>
+          <p:nvPr/>
+        </p:nvSpPr>
+        <p:spPr>
+          <a:xfrm>
+            <a:off x="663122" y="1747509"/>
+            <a:ext cx="3491362" cy="64008"/>
+          </a:xfrm>
+          <a:prstGeom prst="rect">
+            <a:avLst/>
+          </a:prstGeom>
+          <a:solidFill>
+            <a:srgbClr val="00754A"/>
+          </a:solidFill>
+          <a:ln>
+            <a:noFill/>
+          </a:ln>
+          <a:effectLst/>
+        </p:spPr>
+        <p:style>
+          <a:lnRef idx="1">
+            <a:schemeClr val="accent1"/>
+          </a:lnRef>
+          <a:fillRef idx="3">
+            <a:schemeClr val="accent1"/>
+          </a:fillRef>
+          <a:effectRef idx="2">
+            <a:schemeClr val="accent1"/>
+          </a:effectRef>
+          <a:fontRef idx="minor">
+            <a:schemeClr val="lt1"/>
+          </a:fontRef>
+        </p:style>
+        <p:txBody>
+          <a:bodyPr rtlCol="0" anchor="ctr"/>
+          <a:lstStyle/>
+          <a:p>
+            <a:pPr algn="ctr"/>
+          </a:p>
+        </p:txBody>
+      </p:sp>
+      <p:sp>
+        <p:nvSpPr>
+          <p:cNvPr id="10" name="Rounded Rectangle 9"/>
+          <p:cNvSpPr/>
+          <p:nvPr/>
+        </p:nvSpPr>
+        <p:spPr>
+          <a:xfrm>
+            <a:off x="1540123" y="2003541"/>
+            <a:ext cx="1737360" cy="310896"/>
+          </a:xfrm>
+          <a:prstGeom prst="roundRect">
+            <a:avLst>
+              <a:gd name="adj" fmla="val 50000"/>
+            </a:avLst>
+          </a:prstGeom>
+          <a:solidFill>
+            <a:srgbClr val="00754A"/>
+          </a:solidFill>
+          <a:ln>
+            <a:noFill/>
+          </a:ln>
+          <a:effectLst/>
+        </p:spPr>
+        <p:style>
+          <a:lnRef idx="1">
+            <a:schemeClr val="accent1"/>
+          </a:lnRef>
+          <a:fillRef idx="3">
+            <a:schemeClr val="accent1"/>
+          </a:fillRef>
+          <a:effectRef idx="2">
+            <a:schemeClr val="accent1"/>
+          </a:effectRef>
+          <a:fontRef idx="minor">
+            <a:schemeClr val="lt1"/>
+          </a:fontRef>
+        </p:style>
+        <p:txBody>
+          <a:bodyPr rtlCol="0" anchor="ctr"/>
+          <a:lstStyle/>
+          <a:p>
+            <a:pPr algn="ctr"/>
+          </a:p>
+        </p:txBody>
+      </p:sp>
+      <p:sp>
+        <p:nvSpPr>
+          <p:cNvPr id="11" name="TextBox 10"/>
+          <p:cNvSpPr txBox="1"/>
+          <p:nvPr/>
+        </p:nvSpPr>
+        <p:spPr>
+          <a:xfrm>
+            <a:off x="1540123" y="2003541"/>
+            <a:ext cx="1737360" cy="310896"/>
+          </a:xfrm>
+          <a:prstGeom prst="rect">
+            <a:avLst/>
+          </a:prstGeom>
+          <a:noFill/>
+        </p:spPr>
+        <p:txBody>
+          <a:bodyPr wrap="square" anchor="ctr" lIns="0" rIns="0" tIns="0" bIns="0">
+            <a:spAutoFit/>
+          </a:bodyPr>
+          <a:lstStyle/>
+          <a:p>
+            <a:pPr algn="ctr"/>
+            <a:r>
+              <a:rPr sz="1100" b="1" i="0" spc="-11">
+                <a:solidFill>
+                  <a:srgbClr val="FFFFFF"/>
+                </a:solidFill>
+                <a:latin typeface="Pretendard"/>
+                <a:ea typeface="Pretendard"/>
+                <a:cs typeface="Pretendard"/>
+              </a:rPr>
+              <a:t>OWN YOUR DATA</a:t>
+            </a:r>
+          </a:p>
+        </p:txBody>
+      </p:sp>
+      <p:sp>
+        <p:nvSpPr>
+          <p:cNvPr id="12" name="TextBox 11"/>
+          <p:cNvSpPr txBox="1"/>
+          <p:nvPr/>
+        </p:nvSpPr>
+        <p:spPr>
+          <a:xfrm>
+            <a:off x="754562" y="2616189"/>
+            <a:ext cx="3308482" cy="1554480"/>
+          </a:xfrm>
+          <a:prstGeom prst="rect">
+            <a:avLst/>
+          </a:prstGeom>
+          <a:noFill/>
+        </p:spPr>
+        <p:txBody>
+          <a:bodyPr wrap="square" anchor="t" lIns="0" rIns="0" tIns="0" bIns="0">
+            <a:spAutoFit/>
+          </a:bodyPr>
+          <a:lstStyle/>
+          <a:p>
+            <a:pPr algn="ctr"/>
+            <a:r>
+              <a:rPr sz="3400" b="1" i="0" spc="-34">
+                <a:solidFill>
+                  <a:srgbClr val="006241"/>
+                </a:solidFill>
+                <a:latin typeface="Pretendard"/>
+                <a:ea typeface="Pretendard"/>
+                <a:cs typeface="Pretendard"/>
+              </a:rPr>
+              <a:t>마크다운</a:t>
+            </a:r>
+          </a:p>
+          <a:p>
+            <a:pPr algn="ctr">
+              <a:spcBef>
+                <a:spcPts val="200"/>
+              </a:spcBef>
+            </a:pPr>
+            <a:r>
+              <a:rPr sz="1600" b="1" i="0" spc="-16">
+                <a:solidFill>
+                  <a:srgbClr val="1F1F1F"/>
+                </a:solidFill>
+                <a:latin typeface="Pretendard"/>
+                <a:ea typeface="Pretendard"/>
+                <a:cs typeface="Pretendard"/>
+              </a:rPr>
+              <a:t>= 내 DB</a:t>
+            </a:r>
+          </a:p>
+          <a:p>
+            <a:pPr algn="ctr">
+              <a:lnSpc>
+                <a:spcPts val="1600"/>
+              </a:lnSpc>
+              <a:spcBef>
+                <a:spcPts val="1000"/>
+              </a:spcBef>
+            </a:pPr>
+            <a:r>
+              <a:rPr sz="1200" b="0" i="0" spc="-12">
+                <a:solidFill>
+                  <a:srgbClr val="6B6B6B"/>
+                </a:solidFill>
+                <a:latin typeface="Pretendard"/>
+                <a:ea typeface="Pretendard"/>
+                <a:cs typeface="Pretendard"/>
+              </a:rPr>
+              <a:t>평문·git·로컬 우선
+플러그인보다 오래 남음</a:t>
+            </a:r>
+          </a:p>
+        </p:txBody>
+      </p:sp>
+      <p:sp>
+        <p:nvSpPr>
+          <p:cNvPr id="13" name="Rounded Rectangle 12"/>
+          <p:cNvSpPr/>
+          <p:nvPr/>
+        </p:nvSpPr>
+        <p:spPr>
+          <a:xfrm>
+            <a:off x="4355652" y="1747509"/>
+            <a:ext cx="3491362" cy="3200400"/>
+          </a:xfrm>
+          <a:prstGeom prst="roundRect">
+            <a:avLst>
+              <a:gd name="adj" fmla="val 6000"/>
+            </a:avLst>
+          </a:prstGeom>
+          <a:solidFill>
+            <a:srgbClr val="FFFFFF"/>
+          </a:solidFill>
+          <a:ln w="9525">
+            <a:solidFill>
+              <a:srgbClr val="D9D9D9"/>
+            </a:solidFill>
+          </a:ln>
+          <a:effectLst/>
+        </p:spPr>
+        <p:style>
+          <a:lnRef idx="1">
+            <a:schemeClr val="accent1"/>
+          </a:lnRef>
+          <a:fillRef idx="3">
+            <a:schemeClr val="accent1"/>
+          </a:fillRef>
+          <a:effectRef idx="2">
+            <a:schemeClr val="accent1"/>
+          </a:effectRef>
+          <a:fontRef idx="minor">
+            <a:schemeClr val="lt1"/>
+          </a:fontRef>
+        </p:style>
+        <p:txBody>
+          <a:bodyPr rtlCol="0" anchor="ctr"/>
+          <a:lstStyle/>
+          <a:p>
+            <a:pPr algn="ctr"/>
+          </a:p>
+        </p:txBody>
+      </p:sp>
+      <p:sp>
+        <p:nvSpPr>
+          <p:cNvPr id="14" name="Rectangle 13"/>
+          <p:cNvSpPr/>
+          <p:nvPr/>
+        </p:nvSpPr>
+        <p:spPr>
+          <a:xfrm>
+            <a:off x="4355652" y="1747509"/>
+            <a:ext cx="3491362" cy="64008"/>
+          </a:xfrm>
+          <a:prstGeom prst="rect">
+            <a:avLst/>
+          </a:prstGeom>
+          <a:solidFill>
+            <a:srgbClr val="00754A"/>
+          </a:solidFill>
+          <a:ln>
+            <a:noFill/>
+          </a:ln>
+          <a:effectLst/>
+        </p:spPr>
+        <p:style>
+          <a:lnRef idx="1">
+            <a:schemeClr val="accent1"/>
+          </a:lnRef>
+          <a:fillRef idx="3">
+            <a:schemeClr val="accent1"/>
+          </a:fillRef>
+          <a:effectRef idx="2">
+            <a:schemeClr val="accent1"/>
+          </a:effectRef>
+          <a:fontRef idx="minor">
+            <a:schemeClr val="lt1"/>
+          </a:fontRef>
+        </p:style>
+        <p:txBody>
+          <a:bodyPr rtlCol="0" anchor="ctr"/>
+          <a:lstStyle/>
+          <a:p>
+            <a:pPr algn="ctr"/>
+          </a:p>
+        </p:txBody>
+      </p:sp>
+      <p:sp>
+        <p:nvSpPr>
+          <p:cNvPr id="15" name="Rounded Rectangle 14"/>
+          <p:cNvSpPr/>
+          <p:nvPr/>
+        </p:nvSpPr>
+        <p:spPr>
+          <a:xfrm>
+            <a:off x="5232654" y="2003541"/>
+            <a:ext cx="1737360" cy="310896"/>
+          </a:xfrm>
+          <a:prstGeom prst="roundRect">
+            <a:avLst>
+              <a:gd name="adj" fmla="val 50000"/>
+            </a:avLst>
+          </a:prstGeom>
+          <a:solidFill>
+            <a:srgbClr val="00754A"/>
+          </a:solidFill>
+          <a:ln>
+            <a:noFill/>
+          </a:ln>
+          <a:effectLst/>
+        </p:spPr>
+        <p:style>
+          <a:lnRef idx="1">
+            <a:schemeClr val="accent1"/>
+          </a:lnRef>
+          <a:fillRef idx="3">
+            <a:schemeClr val="accent1"/>
+          </a:fillRef>
+          <a:effectRef idx="2">
+            <a:schemeClr val="accent1"/>
+          </a:effectRef>
+          <a:fontRef idx="minor">
+            <a:schemeClr val="lt1"/>
+          </a:fontRef>
+        </p:style>
+        <p:txBody>
+          <a:bodyPr rtlCol="0" anchor="ctr"/>
+          <a:lstStyle/>
+          <a:p>
+            <a:pPr algn="ctr"/>
+          </a:p>
+        </p:txBody>
+      </p:sp>
+      <p:sp>
+        <p:nvSpPr>
+          <p:cNvPr id="16" name="TextBox 15"/>
+          <p:cNvSpPr txBox="1"/>
+          <p:nvPr/>
+        </p:nvSpPr>
+        <p:spPr>
+          <a:xfrm>
+            <a:off x="5232654" y="2003541"/>
+            <a:ext cx="1737360" cy="310896"/>
+          </a:xfrm>
+          <a:prstGeom prst="rect">
+            <a:avLst/>
+          </a:prstGeom>
+          <a:noFill/>
+        </p:spPr>
+        <p:txBody>
+          <a:bodyPr wrap="square" anchor="ctr" lIns="0" rIns="0" tIns="0" bIns="0">
+            <a:spAutoFit/>
+          </a:bodyPr>
+          <a:lstStyle/>
+          <a:p>
+            <a:pPr algn="ctr"/>
+            <a:r>
+              <a:rPr sz="1100" b="1" i="0" spc="-11">
+                <a:solidFill>
+                  <a:srgbClr val="FFFFFF"/>
+                </a:solidFill>
+                <a:latin typeface="Pretendard"/>
+                <a:ea typeface="Pretendard"/>
+                <a:cs typeface="Pretendard"/>
+              </a:rPr>
+              <a:t>GROUNDED</a:t>
+            </a:r>
+          </a:p>
+        </p:txBody>
+      </p:sp>
+      <p:sp>
+        <p:nvSpPr>
+          <p:cNvPr id="17" name="TextBox 16"/>
+          <p:cNvSpPr txBox="1"/>
+          <p:nvPr/>
+        </p:nvSpPr>
+        <p:spPr>
+          <a:xfrm>
+            <a:off x="4447092" y="2616189"/>
+            <a:ext cx="3308482" cy="1554480"/>
+          </a:xfrm>
+          <a:prstGeom prst="rect">
+            <a:avLst/>
+          </a:prstGeom>
+          <a:noFill/>
+        </p:spPr>
+        <p:txBody>
+          <a:bodyPr wrap="square" anchor="t" lIns="0" rIns="0" tIns="0" bIns="0">
+            <a:spAutoFit/>
+          </a:bodyPr>
+          <a:lstStyle/>
+          <a:p>
+            <a:pPr algn="ctr"/>
+            <a:r>
+              <a:rPr sz="3400" b="1" i="0" spc="-34">
+                <a:solidFill>
+                  <a:srgbClr val="006241"/>
+                </a:solidFill>
+                <a:latin typeface="Pretendard"/>
+                <a:ea typeface="Pretendard"/>
+                <a:cs typeface="Pretendard"/>
+              </a:rPr>
+              <a:t>근거</a:t>
+            </a:r>
+          </a:p>
+          <a:p>
+            <a:pPr algn="ctr">
+              <a:spcBef>
+                <a:spcPts val="200"/>
+              </a:spcBef>
+            </a:pPr>
+            <a:r>
+              <a:rPr sz="1600" b="1" i="0" spc="-16">
+                <a:solidFill>
+                  <a:srgbClr val="1F1F1F"/>
+                </a:solidFill>
+                <a:latin typeface="Pretendard"/>
+                <a:ea typeface="Pretendard"/>
+                <a:cs typeface="Pretendard"/>
+              </a:rPr>
+              <a:t>구절 인용</a:t>
+            </a:r>
+          </a:p>
+          <a:p>
+            <a:pPr algn="ctr">
+              <a:lnSpc>
+                <a:spcPts val="1600"/>
+              </a:lnSpc>
+              <a:spcBef>
+                <a:spcPts val="1000"/>
+              </a:spcBef>
+            </a:pPr>
+            <a:r>
+              <a:rPr sz="1200" b="0" i="0" spc="-12">
+                <a:solidFill>
+                  <a:srgbClr val="6B6B6B"/>
+                </a:solidFill>
+                <a:latin typeface="Pretendard"/>
+                <a:ea typeface="Pretendard"/>
+                <a:cs typeface="Pretendard"/>
+              </a:rPr>
+              <a:t>출처 없는 답 없음
+서식 참고문헌까지</a:t>
+            </a:r>
+          </a:p>
+        </p:txBody>
+      </p:sp>
+      <p:sp>
+        <p:nvSpPr>
+          <p:cNvPr id="18" name="Rounded Rectangle 17"/>
+          <p:cNvSpPr/>
+          <p:nvPr/>
+        </p:nvSpPr>
+        <p:spPr>
+          <a:xfrm>
+            <a:off x="8048183" y="1747509"/>
+            <a:ext cx="3491362" cy="3200400"/>
+          </a:xfrm>
+          <a:prstGeom prst="roundRect">
+            <a:avLst>
+              <a:gd name="adj" fmla="val 6000"/>
+            </a:avLst>
+          </a:prstGeom>
+          <a:solidFill>
+            <a:srgbClr val="FFFFFF"/>
+          </a:solidFill>
+          <a:ln w="9525">
+            <a:solidFill>
+              <a:srgbClr val="D9D9D9"/>
+            </a:solidFill>
+          </a:ln>
+          <a:effectLst/>
+        </p:spPr>
+        <p:style>
+          <a:lnRef idx="1">
+            <a:schemeClr val="accent1"/>
+          </a:lnRef>
+          <a:fillRef idx="3">
+            <a:schemeClr val="accent1"/>
+          </a:fillRef>
+          <a:effectRef idx="2">
+            <a:schemeClr val="accent1"/>
+          </a:effectRef>
+          <a:fontRef idx="minor">
+            <a:schemeClr val="lt1"/>
+          </a:fontRef>
+        </p:style>
+        <p:txBody>
+          <a:bodyPr rtlCol="0" anchor="ctr"/>
+          <a:lstStyle/>
+          <a:p>
+            <a:pPr algn="ctr"/>
+          </a:p>
+        </p:txBody>
+      </p:sp>
+      <p:sp>
+        <p:nvSpPr>
+          <p:cNvPr id="19" name="Rectangle 18"/>
+          <p:cNvSpPr/>
+          <p:nvPr/>
+        </p:nvSpPr>
+        <p:spPr>
+          <a:xfrm>
+            <a:off x="8048183" y="1747509"/>
+            <a:ext cx="3491362" cy="64008"/>
+          </a:xfrm>
+          <a:prstGeom prst="rect">
+            <a:avLst/>
+          </a:prstGeom>
+          <a:solidFill>
+            <a:srgbClr val="00754A"/>
+          </a:solidFill>
+          <a:ln>
+            <a:noFill/>
+          </a:ln>
+          <a:effectLst/>
+        </p:spPr>
+        <p:style>
+          <a:lnRef idx="1">
+            <a:schemeClr val="accent1"/>
+          </a:lnRef>
+          <a:fillRef idx="3">
+            <a:schemeClr val="accent1"/>
+          </a:fillRef>
+          <a:effectRef idx="2">
+            <a:schemeClr val="accent1"/>
+          </a:effectRef>
+          <a:fontRef idx="minor">
+            <a:schemeClr val="lt1"/>
+          </a:fontRef>
+        </p:style>
+        <p:txBody>
+          <a:bodyPr rtlCol="0" anchor="ctr"/>
+          <a:lstStyle/>
+          <a:p>
+            <a:pPr algn="ctr"/>
+          </a:p>
+        </p:txBody>
+      </p:sp>
+      <p:sp>
+        <p:nvSpPr>
+          <p:cNvPr id="20" name="Rounded Rectangle 19"/>
+          <p:cNvSpPr/>
+          <p:nvPr/>
+        </p:nvSpPr>
+        <p:spPr>
+          <a:xfrm>
+            <a:off x="8925184" y="2003541"/>
+            <a:ext cx="1737360" cy="310896"/>
+          </a:xfrm>
+          <a:prstGeom prst="roundRect">
+            <a:avLst>
+              <a:gd name="adj" fmla="val 50000"/>
+            </a:avLst>
+          </a:prstGeom>
+          <a:solidFill>
+            <a:srgbClr val="00754A"/>
+          </a:solidFill>
+          <a:ln>
+            <a:noFill/>
+          </a:ln>
+          <a:effectLst/>
+        </p:spPr>
+        <p:style>
+          <a:lnRef idx="1">
+            <a:schemeClr val="accent1"/>
+          </a:lnRef>
+          <a:fillRef idx="3">
+            <a:schemeClr val="accent1"/>
+          </a:fillRef>
+          <a:effectRef idx="2">
+            <a:schemeClr val="accent1"/>
+          </a:effectRef>
+          <a:fontRef idx="minor">
+            <a:schemeClr val="lt1"/>
+          </a:fontRef>
+        </p:style>
+        <p:txBody>
+          <a:bodyPr rtlCol="0" anchor="ctr"/>
+          <a:lstStyle/>
+          <a:p>
+            <a:pPr algn="ctr"/>
+          </a:p>
+        </p:txBody>
+      </p:sp>
+      <p:sp>
+        <p:nvSpPr>
+          <p:cNvPr id="21" name="TextBox 20"/>
+          <p:cNvSpPr txBox="1"/>
+          <p:nvPr/>
+        </p:nvSpPr>
+        <p:spPr>
+          <a:xfrm>
+            <a:off x="8925184" y="2003541"/>
+            <a:ext cx="1737360" cy="310896"/>
+          </a:xfrm>
+          <a:prstGeom prst="rect">
+            <a:avLst/>
+          </a:prstGeom>
+          <a:noFill/>
+        </p:spPr>
+        <p:txBody>
+          <a:bodyPr wrap="square" anchor="ctr" lIns="0" rIns="0" tIns="0" bIns="0">
+            <a:spAutoFit/>
+          </a:bodyPr>
+          <a:lstStyle/>
+          <a:p>
+            <a:pPr algn="ctr"/>
+            <a:r>
+              <a:rPr sz="1100" b="1" i="0" spc="-11">
+                <a:solidFill>
+                  <a:srgbClr val="FFFFFF"/>
+                </a:solidFill>
+                <a:latin typeface="Pretendard"/>
+                <a:ea typeface="Pretendard"/>
+                <a:cs typeface="Pretendard"/>
+              </a:rPr>
+              <a:t>GRAPH-LITE</a:t>
+            </a:r>
+          </a:p>
+        </p:txBody>
+      </p:sp>
+      <p:sp>
+        <p:nvSpPr>
+          <p:cNvPr id="22" name="TextBox 21"/>
+          <p:cNvSpPr txBox="1"/>
+          <p:nvPr/>
+        </p:nvSpPr>
+        <p:spPr>
+          <a:xfrm>
+            <a:off x="8139623" y="2616189"/>
+            <a:ext cx="3308482" cy="1554480"/>
+          </a:xfrm>
+          <a:prstGeom prst="rect">
+            <a:avLst/>
+          </a:prstGeom>
+          <a:noFill/>
+        </p:spPr>
+        <p:txBody>
+          <a:bodyPr wrap="square" anchor="t" lIns="0" rIns="0" tIns="0" bIns="0">
+            <a:spAutoFit/>
+          </a:bodyPr>
+          <a:lstStyle/>
+          <a:p>
+            <a:pPr algn="ctr"/>
+            <a:r>
+              <a:rPr sz="3400" b="1" i="0" spc="-34">
+                <a:solidFill>
+                  <a:srgbClr val="006241"/>
+                </a:solidFill>
+                <a:latin typeface="Pretendard"/>
+                <a:ea typeface="Pretendard"/>
+                <a:cs typeface="Pretendard"/>
+              </a:rPr>
+              <a:t>그래프</a:t>
+            </a:r>
+          </a:p>
+          <a:p>
+            <a:pPr algn="ctr">
+              <a:spcBef>
+                <a:spcPts val="200"/>
+              </a:spcBef>
+            </a:pPr>
+            <a:r>
+              <a:rPr sz="1600" b="1" i="0" spc="-16">
+                <a:solidFill>
+                  <a:srgbClr val="1F1F1F"/>
+                </a:solidFill>
+                <a:latin typeface="Pretendard"/>
+                <a:ea typeface="Pretendard"/>
+                <a:cs typeface="Pretendard"/>
+              </a:rPr>
+              <a:t>놓친 논문</a:t>
+            </a:r>
+          </a:p>
+          <a:p>
+            <a:pPr algn="ctr">
+              <a:lnSpc>
+                <a:spcPts val="1600"/>
+              </a:lnSpc>
+              <a:spcBef>
+                <a:spcPts val="1000"/>
+              </a:spcBef>
+            </a:pPr>
+            <a:r>
+              <a:rPr sz="1200" b="0" i="0" spc="-12">
+                <a:solidFill>
+                  <a:srgbClr val="6B6B6B"/>
+                </a:solidFill>
+                <a:latin typeface="Pretendard"/>
+                <a:ea typeface="Pretendard"/>
+                <a:cs typeface="Pretendard"/>
+              </a:rPr>
+              <a:t>OpenAlex 인용엣지
+LLM 비용 0</a:t>
+            </a:r>
+          </a:p>
+        </p:txBody>
+      </p:sp>
+      <p:sp>
+        <p:nvSpPr>
+          <p:cNvPr id="23" name="Rounded Rectangle 22"/>
+          <p:cNvSpPr/>
+          <p:nvPr/>
+        </p:nvSpPr>
+        <p:spPr>
+          <a:xfrm>
+            <a:off x="571682" y="5859292"/>
+            <a:ext cx="11059302" cy="457200"/>
+          </a:xfrm>
+          <a:prstGeom prst="roundRect">
+            <a:avLst>
+              <a:gd name="adj" fmla="val 18000"/>
+            </a:avLst>
+          </a:prstGeom>
+          <a:solidFill>
+            <a:srgbClr val="1E3932"/>
+          </a:solidFill>
+          <a:ln>
+            <a:noFill/>
+          </a:ln>
+          <a:effectLst/>
+        </p:spPr>
+        <p:style>
+          <a:lnRef idx="1">
+            <a:schemeClr val="accent1"/>
+          </a:lnRef>
+          <a:fillRef idx="3">
+            <a:schemeClr val="accent1"/>
+          </a:fillRef>
+          <a:effectRef idx="2">
+            <a:schemeClr val="accent1"/>
+          </a:effectRef>
+          <a:fontRef idx="minor">
+            <a:schemeClr val="lt1"/>
+          </a:fontRef>
+        </p:style>
+        <p:txBody>
+          <a:bodyPr rtlCol="0" anchor="ctr"/>
+          <a:lstStyle/>
+          <a:p>
+            <a:pPr algn="ctr"/>
+          </a:p>
+        </p:txBody>
+      </p:sp>
+      <p:sp>
+        <p:nvSpPr>
+          <p:cNvPr id="24" name="TextBox 23"/>
+          <p:cNvSpPr txBox="1"/>
+          <p:nvPr/>
+        </p:nvSpPr>
+        <p:spPr>
+          <a:xfrm>
+            <a:off x="800282" y="5859292"/>
+            <a:ext cx="10602102" cy="457200"/>
+          </a:xfrm>
+          <a:prstGeom prst="rect">
+            <a:avLst/>
+          </a:prstGeom>
+          <a:noFill/>
+        </p:spPr>
+        <p:txBody>
+          <a:bodyPr wrap="square" anchor="ctr" lIns="0" rIns="0" tIns="0" bIns="0">
+            <a:spAutoFit/>
+          </a:bodyPr>
+          <a:lstStyle/>
+          <a:p>
+            <a:pPr algn="l"/>
+            <a:r>
+              <a:rPr sz="1400" b="1" i="0" spc="-14">
+                <a:solidFill>
+                  <a:srgbClr val="FFFFFF"/>
+                </a:solidFill>
+                <a:latin typeface="Pretendard"/>
+                <a:ea typeface="Pretendard"/>
+                <a:cs typeface="Pretendard"/>
+              </a:rPr>
+              <a:t>내 서재가 곧 검색엔진이고, 답은 늘 출처와 함께 — RAG Obsidian</a:t>
+            </a:r>
+          </a:p>
+        </p:txBody>
+      </p:sp>
+    </p:spTree>
+  </p:cSld>
+  <p:clrMapOvr>
+    <a:masterClrMapping/>
+  </p:clrMapOvr>
+</p:sld>
+</file>
+
+<file path=ppt/slides/slide18.xml><?xml version="1.0" encoding="utf-8"?>
 <p:sld xmlns:a="http://schemas.openxmlformats.org/drawingml/2006/main" xmlns:p="http://schemas.openxmlformats.org/presentationml/2006/main" xmlns:r="http://schemas.openxmlformats.org/officeDocument/2006/relationships">
   <p:cSld>
     <p:spTree>

</xml_diff>

<commit_message>
docs: deck — Q&A appendix before Thank You (closing is the final slide)
Co-Authored-By: Claude Fable 5 <noreply@anthropic.com>
</commit_message>
<xml_diff>
--- a/presentation/rag_obsidian_deck.pptx
+++ b/presentation/rag_obsidian_deck.pptx
@@ -12613,9 +12613,87 @@
           </a:p>
         </p:txBody>
       </p:sp>
+      <p:sp>
+        <p:nvSpPr>
+          <p:cNvPr id="3" name="TextBox 2"/>
+          <p:cNvSpPr txBox="1"/>
+          <p:nvPr/>
+        </p:nvSpPr>
+        <p:spPr>
+          <a:xfrm>
+            <a:off x="138257" y="123444"/>
+            <a:ext cx="5486400" cy="256032"/>
+          </a:xfrm>
+          <a:prstGeom prst="rect">
+            <a:avLst/>
+          </a:prstGeom>
+          <a:noFill/>
+        </p:spPr>
+        <p:txBody>
+          <a:bodyPr wrap="square" anchor="t" lIns="0" rIns="0" tIns="0" bIns="0">
+            <a:spAutoFit/>
+          </a:bodyPr>
+          <a:lstStyle/>
+          <a:p>
+            <a:pPr algn="l"/>
+            <a:r>
+              <a:rPr sz="1100" b="1" i="0" spc="-11">
+                <a:solidFill>
+                  <a:srgbClr val="8E8E93"/>
+                </a:solidFill>
+                <a:latin typeface="Pretendard"/>
+                <a:ea typeface="Pretendard"/>
+                <a:cs typeface="Pretendard"/>
+              </a:rPr>
+              <a:t>APPENDIX · Q&amp;A</a:t>
+            </a:r>
+          </a:p>
+        </p:txBody>
+      </p:sp>
+      <p:sp>
+        <p:nvSpPr>
+          <p:cNvPr id="4" name="TextBox 3"/>
+          <p:cNvSpPr txBox="1"/>
+          <p:nvPr/>
+        </p:nvSpPr>
+        <p:spPr>
+          <a:xfrm>
+            <a:off x="251642" y="436260"/>
+            <a:ext cx="10972800" cy="640080"/>
+          </a:xfrm>
+          <a:prstGeom prst="rect">
+            <a:avLst/>
+          </a:prstGeom>
+          <a:noFill/>
+        </p:spPr>
+        <p:txBody>
+          <a:bodyPr wrap="square" anchor="t" lIns="0" rIns="0" tIns="0" bIns="0">
+            <a:spAutoFit/>
+          </a:bodyPr>
+          <a:lstStyle/>
+          <a:p>
+            <a:pPr algn="l">
+              <a:lnSpc>
+                <a:spcPts val="3600"/>
+              </a:lnSpc>
+            </a:pPr>
+            <a:r>
+              <a:rPr sz="3000" b="1" i="0" spc="-30">
+                <a:solidFill>
+                  <a:srgbClr val="006241"/>
+                </a:solidFill>
+                <a:latin typeface="Pretendard"/>
+                <a:ea typeface="Pretendard"/>
+                <a:cs typeface="Pretendard"/>
+              </a:rPr>
+              <a:t>자주 나올 질문 ①</a:t>
+            </a:r>
+          </a:p>
+        </p:txBody>
+      </p:sp>
       <p:pic>
         <p:nvPicPr>
-          <p:cNvPr id="3" name="Picture 2" descr="logo.png"/>
+          <p:cNvPr id="5" name="Picture 4" descr="logo.png"/>
           <p:cNvPicPr>
             <a:picLocks noChangeAspect="1"/>
           </p:cNvPicPr>
@@ -12640,14 +12718,145 @@
       </p:pic>
       <p:sp>
         <p:nvSpPr>
-          <p:cNvPr id="4" name="TextBox 3"/>
-          <p:cNvSpPr txBox="1"/>
-          <p:nvPr/>
-        </p:nvSpPr>
-        <p:spPr>
-          <a:xfrm>
-            <a:off x="548640" y="2377440"/>
-            <a:ext cx="11064240" cy="1280160"/>
+          <p:cNvPr id="6" name="Rounded Rectangle 5"/>
+          <p:cNvSpPr/>
+          <p:nvPr/>
+        </p:nvSpPr>
+        <p:spPr>
+          <a:xfrm>
+            <a:off x="251642" y="1290309"/>
+            <a:ext cx="11699382" cy="5227350"/>
+          </a:xfrm>
+          <a:prstGeom prst="roundRect">
+            <a:avLst>
+              <a:gd name="adj" fmla="val 3500"/>
+            </a:avLst>
+          </a:prstGeom>
+          <a:solidFill>
+            <a:srgbClr val="FFFFFF"/>
+          </a:solidFill>
+          <a:ln w="9525">
+            <a:solidFill>
+              <a:srgbClr val="D9D9D9"/>
+            </a:solidFill>
+          </a:ln>
+          <a:effectLst/>
+        </p:spPr>
+        <p:style>
+          <a:lnRef idx="1">
+            <a:schemeClr val="accent1"/>
+          </a:lnRef>
+          <a:fillRef idx="3">
+            <a:schemeClr val="accent1"/>
+          </a:fillRef>
+          <a:effectRef idx="2">
+            <a:schemeClr val="accent1"/>
+          </a:effectRef>
+          <a:fontRef idx="minor">
+            <a:schemeClr val="lt1"/>
+          </a:fontRef>
+        </p:style>
+        <p:txBody>
+          <a:bodyPr rtlCol="0" anchor="ctr"/>
+          <a:lstStyle/>
+          <a:p>
+            <a:pPr algn="ctr"/>
+          </a:p>
+        </p:txBody>
+      </p:sp>
+      <p:sp>
+        <p:nvSpPr>
+          <p:cNvPr id="7" name="TextBox 6"/>
+          <p:cNvSpPr txBox="1"/>
+          <p:nvPr/>
+        </p:nvSpPr>
+        <p:spPr>
+          <a:xfrm>
+            <a:off x="138257" y="6620256"/>
+            <a:ext cx="548640" cy="228600"/>
+          </a:xfrm>
+          <a:prstGeom prst="rect">
+            <a:avLst/>
+          </a:prstGeom>
+          <a:noFill/>
+        </p:spPr>
+        <p:txBody>
+          <a:bodyPr wrap="square" anchor="t" lIns="0" rIns="0" tIns="0" bIns="0">
+            <a:spAutoFit/>
+          </a:bodyPr>
+          <a:lstStyle/>
+          <a:p>
+            <a:pPr algn="l"/>
+            <a:r>
+              <a:rPr sz="900" b="0" i="0" spc="-9">
+                <a:solidFill>
+                  <a:srgbClr val="8E8E93"/>
+                </a:solidFill>
+                <a:latin typeface="Pretendard"/>
+                <a:ea typeface="Pretendard"/>
+                <a:cs typeface="Pretendard"/>
+              </a:rPr>
+              <a:t>18</a:t>
+            </a:r>
+          </a:p>
+        </p:txBody>
+      </p:sp>
+      <p:sp>
+        <p:nvSpPr>
+          <p:cNvPr id="8" name="Rounded Rectangle 7"/>
+          <p:cNvSpPr/>
+          <p:nvPr/>
+        </p:nvSpPr>
+        <p:spPr>
+          <a:xfrm>
+            <a:off x="663122" y="1656069"/>
+            <a:ext cx="10876422" cy="1364498"/>
+          </a:xfrm>
+          <a:prstGeom prst="roundRect">
+            <a:avLst>
+              <a:gd name="adj" fmla="val 6000"/>
+            </a:avLst>
+          </a:prstGeom>
+          <a:noFill/>
+          <a:ln w="11430">
+            <a:solidFill>
+              <a:srgbClr val="D9D9D9"/>
+            </a:solidFill>
+          </a:ln>
+          <a:effectLst/>
+        </p:spPr>
+        <p:style>
+          <a:lnRef idx="1">
+            <a:schemeClr val="accent1"/>
+          </a:lnRef>
+          <a:fillRef idx="3">
+            <a:schemeClr val="accent1"/>
+          </a:fillRef>
+          <a:effectRef idx="2">
+            <a:schemeClr val="accent1"/>
+          </a:effectRef>
+          <a:fontRef idx="minor">
+            <a:schemeClr val="lt1"/>
+          </a:fontRef>
+        </p:style>
+        <p:txBody>
+          <a:bodyPr rtlCol="0" anchor="ctr"/>
+          <a:lstStyle/>
+          <a:p>
+            <a:pPr algn="ctr"/>
+          </a:p>
+        </p:txBody>
+      </p:sp>
+      <p:sp>
+        <p:nvSpPr>
+          <p:cNvPr id="9" name="TextBox 8"/>
+          <p:cNvSpPr txBox="1"/>
+          <p:nvPr/>
+        </p:nvSpPr>
+        <p:spPr>
+          <a:xfrm>
+            <a:off x="1028882" y="1656069"/>
+            <a:ext cx="10144902" cy="1364498"/>
           </a:xfrm>
           <a:prstGeom prst="rect">
             <a:avLst/>
@@ -12660,9 +12869,13 @@
           </a:bodyPr>
           <a:lstStyle/>
           <a:p>
-            <a:pPr algn="ctr"/>
-            <a:r>
-              <a:rPr sz="5400" b="1" i="0" spc="-54">
+            <a:pPr algn="l">
+              <a:lnSpc>
+                <a:spcPts val="2000"/>
+              </a:lnSpc>
+            </a:pPr>
+            <a:r>
+              <a:rPr sz="1500" b="1" i="0" spc="-15">
                 <a:solidFill>
                   <a:srgbClr val="006241"/>
                 </a:solidFill>
@@ -12670,91 +12883,31 @@
                 <a:ea typeface="Pretendard"/>
                 <a:cs typeface="Pretendard"/>
               </a:rPr>
-              <a:t>Thank you</a:t>
-            </a:r>
-          </a:p>
-        </p:txBody>
-      </p:sp>
-      <p:sp>
-        <p:nvSpPr>
-          <p:cNvPr id="5" name="TextBox 4"/>
-          <p:cNvSpPr txBox="1"/>
-          <p:nvPr/>
-        </p:nvSpPr>
-        <p:spPr>
-          <a:xfrm>
-            <a:off x="548640" y="3749039"/>
-            <a:ext cx="11064240" cy="457200"/>
-          </a:xfrm>
-          <a:prstGeom prst="rect">
-            <a:avLst/>
-          </a:prstGeom>
-          <a:noFill/>
-        </p:spPr>
-        <p:txBody>
-          <a:bodyPr wrap="square" anchor="t" lIns="0" rIns="0" tIns="0" bIns="0">
-            <a:spAutoFit/>
-          </a:bodyPr>
-          <a:lstStyle/>
-          <a:p>
-            <a:pPr algn="ctr"/>
-            <a:r>
-              <a:rPr sz="1800" b="0" i="0" spc="-18">
-                <a:solidFill>
-                  <a:srgbClr val="6B6B6B"/>
-                </a:solidFill>
-                <a:latin typeface="Pretendard"/>
-                <a:ea typeface="Pretendard"/>
-                <a:cs typeface="Pretendard"/>
-              </a:rPr>
-              <a:t>Questions &amp; discussion</a:t>
-            </a:r>
-          </a:p>
-        </p:txBody>
-      </p:sp>
-      <p:sp>
-        <p:nvSpPr>
-          <p:cNvPr id="6" name="TextBox 5"/>
-          <p:cNvSpPr txBox="1"/>
-          <p:nvPr/>
-        </p:nvSpPr>
-        <p:spPr>
-          <a:xfrm>
-            <a:off x="548640" y="4937760"/>
-            <a:ext cx="11064240" cy="640080"/>
-          </a:xfrm>
-          <a:prstGeom prst="rect">
-            <a:avLst/>
-          </a:prstGeom>
-          <a:noFill/>
-        </p:spPr>
-        <p:txBody>
-          <a:bodyPr wrap="square" anchor="t" lIns="0" rIns="0" tIns="0" bIns="0">
-            <a:spAutoFit/>
-          </a:bodyPr>
-          <a:lstStyle/>
-          <a:p>
-            <a:pPr algn="ctr"/>
-            <a:r>
-              <a:rPr sz="1400" b="0" i="0" spc="-14">
-                <a:solidFill>
-                  <a:srgbClr val="6B6B6B"/>
-                </a:solidFill>
-                <a:latin typeface="Pretendard"/>
-                <a:ea typeface="Pretendard"/>
-                <a:cs typeface="Pretendard"/>
-              </a:rPr>
-              <a:t>박상민  ·  분당서울대학교병원 정형외과</a:t>
-            </a:r>
-          </a:p>
-          <a:p>
-            <a:pPr algn="ctr">
+              <a:t>Q.  </a:t>
+            </a:r>
+            <a:r>
+              <a:rPr sz="1500" b="1" i="0" spc="-15">
+                <a:solidFill>
+                  <a:srgbClr val="006241"/>
+                </a:solidFill>
+                <a:latin typeface="Pretendard"/>
+                <a:ea typeface="Pretendard"/>
+                <a:cs typeface="Pretendard"/>
+              </a:rPr>
+              <a:t>Zotero랑 뭐가 다른가요?</a:t>
+            </a:r>
+          </a:p>
+          <a:p>
+            <a:pPr algn="l">
+              <a:lnSpc>
+                <a:spcPts val="1700"/>
+              </a:lnSpc>
               <a:spcBef>
-                <a:spcPts val="500"/>
+                <a:spcPts val="600"/>
               </a:spcBef>
             </a:pPr>
             <a:r>
-              <a:rPr sz="1300" b="1" i="0" spc="-13">
+              <a:rPr sz="1250" b="1" i="0" spc="-12">
                 <a:solidFill>
                   <a:srgbClr val="00754A"/>
                 </a:solidFill>
@@ -12762,7 +12915,278 @@
                 <a:ea typeface="Pretendard"/>
                 <a:cs typeface="Pretendard"/>
               </a:rPr>
-              <a:t>github.com/grotyx/rag-obsidian</a:t>
+              <a:t>A.  </a:t>
+            </a:r>
+            <a:r>
+              <a:rPr sz="1250" b="0" i="0" spc="-12">
+                <a:solidFill>
+                  <a:srgbClr val="1F1F1F"/>
+                </a:solidFill>
+                <a:latin typeface="Pretendard"/>
+                <a:ea typeface="Pretendard"/>
+                <a:cs typeface="Pretendard"/>
+              </a:rPr>
+              <a:t>Zotero는 별도 앱+별도 DB. 여기선 글 쓰는 Obsidian 노트 자체가 서지 DB라 한 곳에서 끝나고, AI 근거 검색이 기본 내장.</a:t>
+            </a:r>
+          </a:p>
+        </p:txBody>
+      </p:sp>
+      <p:sp>
+        <p:nvSpPr>
+          <p:cNvPr id="10" name="Rounded Rectangle 9"/>
+          <p:cNvSpPr/>
+          <p:nvPr/>
+        </p:nvSpPr>
+        <p:spPr>
+          <a:xfrm>
+            <a:off x="663122" y="3221736"/>
+            <a:ext cx="10876422" cy="1364498"/>
+          </a:xfrm>
+          <a:prstGeom prst="roundRect">
+            <a:avLst>
+              <a:gd name="adj" fmla="val 6000"/>
+            </a:avLst>
+          </a:prstGeom>
+          <a:noFill/>
+          <a:ln w="11430">
+            <a:solidFill>
+              <a:srgbClr val="D9D9D9"/>
+            </a:solidFill>
+          </a:ln>
+          <a:effectLst/>
+        </p:spPr>
+        <p:style>
+          <a:lnRef idx="1">
+            <a:schemeClr val="accent1"/>
+          </a:lnRef>
+          <a:fillRef idx="3">
+            <a:schemeClr val="accent1"/>
+          </a:fillRef>
+          <a:effectRef idx="2">
+            <a:schemeClr val="accent1"/>
+          </a:effectRef>
+          <a:fontRef idx="minor">
+            <a:schemeClr val="lt1"/>
+          </a:fontRef>
+        </p:style>
+        <p:txBody>
+          <a:bodyPr rtlCol="0" anchor="ctr"/>
+          <a:lstStyle/>
+          <a:p>
+            <a:pPr algn="ctr"/>
+          </a:p>
+        </p:txBody>
+      </p:sp>
+      <p:sp>
+        <p:nvSpPr>
+          <p:cNvPr id="11" name="TextBox 10"/>
+          <p:cNvSpPr txBox="1"/>
+          <p:nvPr/>
+        </p:nvSpPr>
+        <p:spPr>
+          <a:xfrm>
+            <a:off x="1028882" y="3221736"/>
+            <a:ext cx="10144902" cy="1364498"/>
+          </a:xfrm>
+          <a:prstGeom prst="rect">
+            <a:avLst/>
+          </a:prstGeom>
+          <a:noFill/>
+        </p:spPr>
+        <p:txBody>
+          <a:bodyPr wrap="square" anchor="ctr" lIns="0" rIns="0" tIns="0" bIns="0">
+            <a:spAutoFit/>
+          </a:bodyPr>
+          <a:lstStyle/>
+          <a:p>
+            <a:pPr algn="l">
+              <a:lnSpc>
+                <a:spcPts val="2000"/>
+              </a:lnSpc>
+            </a:pPr>
+            <a:r>
+              <a:rPr sz="1500" b="1" i="0" spc="-15">
+                <a:solidFill>
+                  <a:srgbClr val="006241"/>
+                </a:solidFill>
+                <a:latin typeface="Pretendard"/>
+                <a:ea typeface="Pretendard"/>
+                <a:cs typeface="Pretendard"/>
+              </a:rPr>
+              <a:t>Q.  </a:t>
+            </a:r>
+            <a:r>
+              <a:rPr sz="1500" b="1" i="0" spc="-15">
+                <a:solidFill>
+                  <a:srgbClr val="006241"/>
+                </a:solidFill>
+                <a:latin typeface="Pretendard"/>
+                <a:ea typeface="Pretendard"/>
+                <a:cs typeface="Pretendard"/>
+              </a:rPr>
+              <a:t>오프라인에서도 되나요?</a:t>
+            </a:r>
+          </a:p>
+          <a:p>
+            <a:pPr algn="l">
+              <a:lnSpc>
+                <a:spcPts val="1700"/>
+              </a:lnSpc>
+              <a:spcBef>
+                <a:spcPts val="600"/>
+              </a:spcBef>
+            </a:pPr>
+            <a:r>
+              <a:rPr sz="1250" b="1" i="0" spc="-12">
+                <a:solidFill>
+                  <a:srgbClr val="00754A"/>
+                </a:solidFill>
+                <a:latin typeface="Pretendard"/>
+                <a:ea typeface="Pretendard"/>
+                <a:cs typeface="Pretendard"/>
+              </a:rPr>
+              <a:t>A.  </a:t>
+            </a:r>
+            <a:r>
+              <a:rPr sz="1250" b="0" i="0" spc="-12">
+                <a:solidFill>
+                  <a:srgbClr val="1F1F1F"/>
+                </a:solidFill>
+                <a:latin typeface="Pretendard"/>
+                <a:ea typeface="Pretendard"/>
+                <a:cs typeface="Pretendard"/>
+              </a:rPr>
+              <a:t>검색·색인은 전부 로컬. 임베딩도 로컬(Ollama) 가능. 네트워크는 메타데이터 가져오기와 인용 그래프(OpenAlex)뿐.</a:t>
+            </a:r>
+          </a:p>
+        </p:txBody>
+      </p:sp>
+      <p:sp>
+        <p:nvSpPr>
+          <p:cNvPr id="12" name="Rounded Rectangle 11"/>
+          <p:cNvSpPr/>
+          <p:nvPr/>
+        </p:nvSpPr>
+        <p:spPr>
+          <a:xfrm>
+            <a:off x="663122" y="4787402"/>
+            <a:ext cx="10876422" cy="1364498"/>
+          </a:xfrm>
+          <a:prstGeom prst="roundRect">
+            <a:avLst>
+              <a:gd name="adj" fmla="val 6000"/>
+            </a:avLst>
+          </a:prstGeom>
+          <a:noFill/>
+          <a:ln w="11430">
+            <a:solidFill>
+              <a:srgbClr val="D9D9D9"/>
+            </a:solidFill>
+          </a:ln>
+          <a:effectLst/>
+        </p:spPr>
+        <p:style>
+          <a:lnRef idx="1">
+            <a:schemeClr val="accent1"/>
+          </a:lnRef>
+          <a:fillRef idx="3">
+            <a:schemeClr val="accent1"/>
+          </a:fillRef>
+          <a:effectRef idx="2">
+            <a:schemeClr val="accent1"/>
+          </a:effectRef>
+          <a:fontRef idx="minor">
+            <a:schemeClr val="lt1"/>
+          </a:fontRef>
+        </p:style>
+        <p:txBody>
+          <a:bodyPr rtlCol="0" anchor="ctr"/>
+          <a:lstStyle/>
+          <a:p>
+            <a:pPr algn="ctr"/>
+          </a:p>
+        </p:txBody>
+      </p:sp>
+      <p:sp>
+        <p:nvSpPr>
+          <p:cNvPr id="13" name="TextBox 12"/>
+          <p:cNvSpPr txBox="1"/>
+          <p:nvPr/>
+        </p:nvSpPr>
+        <p:spPr>
+          <a:xfrm>
+            <a:off x="1028882" y="4787402"/>
+            <a:ext cx="10144902" cy="1364498"/>
+          </a:xfrm>
+          <a:prstGeom prst="rect">
+            <a:avLst/>
+          </a:prstGeom>
+          <a:noFill/>
+        </p:spPr>
+        <p:txBody>
+          <a:bodyPr wrap="square" anchor="ctr" lIns="0" rIns="0" tIns="0" bIns="0">
+            <a:spAutoFit/>
+          </a:bodyPr>
+          <a:lstStyle/>
+          <a:p>
+            <a:pPr algn="l">
+              <a:lnSpc>
+                <a:spcPts val="2000"/>
+              </a:lnSpc>
+            </a:pPr>
+            <a:r>
+              <a:rPr sz="1500" b="1" i="0" spc="-15">
+                <a:solidFill>
+                  <a:srgbClr val="006241"/>
+                </a:solidFill>
+                <a:latin typeface="Pretendard"/>
+                <a:ea typeface="Pretendard"/>
+                <a:cs typeface="Pretendard"/>
+              </a:rPr>
+              <a:t>Q.  </a:t>
+            </a:r>
+            <a:r>
+              <a:rPr sz="1500" b="1" i="0" spc="-15">
+                <a:solidFill>
+                  <a:srgbClr val="006241"/>
+                </a:solidFill>
+                <a:latin typeface="Pretendard"/>
+                <a:ea typeface="Pretendard"/>
+                <a:cs typeface="Pretendard"/>
+              </a:rPr>
+              <a:t>내 데이터는 어디에 저장되나요?</a:t>
+            </a:r>
+          </a:p>
+          <a:p>
+            <a:pPr algn="l">
+              <a:lnSpc>
+                <a:spcPts val="1700"/>
+              </a:lnSpc>
+              <a:spcBef>
+                <a:spcPts val="600"/>
+              </a:spcBef>
+            </a:pPr>
+            <a:r>
+              <a:rPr sz="1250" b="1" i="0" spc="-12">
+                <a:solidFill>
+                  <a:srgbClr val="00754A"/>
+                </a:solidFill>
+                <a:latin typeface="Pretendard"/>
+                <a:ea typeface="Pretendard"/>
+                <a:cs typeface="Pretendard"/>
+              </a:rPr>
+              <a:t>A.  </a:t>
+            </a:r>
+            <a:r>
+              <a:rPr sz="1250" b="0" i="0" spc="-12">
+                <a:solidFill>
+                  <a:srgbClr val="1F1F1F"/>
+                </a:solidFill>
+                <a:latin typeface="Pretendard"/>
+                <a:ea typeface="Pretendard"/>
+                <a:cs typeface="Pretendard"/>
+              </a:rPr>
+              <a:t>전부 내 vault 안 평문 마크다운. 외부 서버 없음 — 내가 키를 넣은 LLM 호출만 예외.</a:t>
             </a:r>
           </a:p>
         </p:txBody>
@@ -12902,7 +13326,7 @@
                 <a:ea typeface="Pretendard"/>
                 <a:cs typeface="Pretendard"/>
               </a:rPr>
-              <a:t>자주 나올 질문 ①</a:t>
+              <a:t>자주 나올 질문 ②</a:t>
             </a:r>
           </a:p>
         </p:txBody>
@@ -13110,7 +13534,7 @@
                 <a:ea typeface="Pretendard"/>
                 <a:cs typeface="Pretendard"/>
               </a:rPr>
-              <a:t>Zotero랑 뭐가 다른가요?</a:t>
+              <a:t>SNOMED·MeSH 같은 의학 용어체계도 되나요?</a:t>
             </a:r>
           </a:p>
           <a:p>
@@ -13142,7 +13566,7 @@
                 <a:ea typeface="Pretendard"/>
                 <a:cs typeface="Pretendard"/>
               </a:rPr>
-              <a:t>Zotero는 별도 앱+별도 DB. 여기선 글 쓰는 Obsidian 노트 자체가 서지 DB라 한 곳에서 끝나고, AI 근거 검색이 기본 내장.</a:t>
+              <a:t>온톨로지 팩(JSON)으로 장착. IS_A 계층·동의어 링크 지원. PubMed 추가 시 MeSH 태그는 기본.</a:t>
             </a:r>
           </a:p>
         </p:txBody>
@@ -13240,7 +13664,7 @@
                 <a:ea typeface="Pretendard"/>
                 <a:cs typeface="Pretendard"/>
               </a:rPr>
-              <a:t>오프라인에서도 되나요?</a:t>
+              <a:t>수천 편짜리 큰 서재도 버티나요?</a:t>
             </a:r>
           </a:p>
           <a:p>
@@ -13272,7 +13696,7 @@
                 <a:ea typeface="Pretendard"/>
                 <a:cs typeface="Pretendard"/>
               </a:rPr>
-              <a:t>검색·색인은 전부 로컬. 임베딩도 로컬(Ollama) 가능. 네트워크는 메타데이터 가져오기와 인용 그래프(OpenAlex)뿐.</a:t>
+              <a:t>수백~수천 편 타깃. 색인이 인메모리라 아주 큰 vault는 추후 sqlite-vec 교체 예정.</a:t>
             </a:r>
           </a:p>
         </p:txBody>
@@ -13370,7 +13794,7 @@
                 <a:ea typeface="Pretendard"/>
                 <a:cs typeface="Pretendard"/>
               </a:rPr>
-              <a:t>내 데이터는 어디에 저장되나요?</a:t>
+              <a:t>가짜 인용(환각)은 정말 없나요?</a:t>
             </a:r>
           </a:p>
           <a:p>
@@ -13402,7 +13826,7 @@
                 <a:ea typeface="Pretendard"/>
                 <a:cs typeface="Pretendard"/>
               </a:rPr>
-              <a:t>전부 내 vault 안 평문 마크다운. 외부 서버 없음 — 내가 키를 넣은 LLM 호출만 예외.</a:t>
+              <a:t>답을 서재 구절에만 근거하게 강제하고 [n]은 실제 노트에 연결. 근거 없으면 "근거 없음"이라 답하게 설계.</a:t>
             </a:r>
           </a:p>
         </p:txBody>
@@ -13730,87 +14154,9 @@
           </a:p>
         </p:txBody>
       </p:sp>
-      <p:sp>
-        <p:nvSpPr>
-          <p:cNvPr id="3" name="TextBox 2"/>
-          <p:cNvSpPr txBox="1"/>
-          <p:nvPr/>
-        </p:nvSpPr>
-        <p:spPr>
-          <a:xfrm>
-            <a:off x="138257" y="123444"/>
-            <a:ext cx="5486400" cy="256032"/>
-          </a:xfrm>
-          <a:prstGeom prst="rect">
-            <a:avLst/>
-          </a:prstGeom>
-          <a:noFill/>
-        </p:spPr>
-        <p:txBody>
-          <a:bodyPr wrap="square" anchor="t" lIns="0" rIns="0" tIns="0" bIns="0">
-            <a:spAutoFit/>
-          </a:bodyPr>
-          <a:lstStyle/>
-          <a:p>
-            <a:pPr algn="l"/>
-            <a:r>
-              <a:rPr sz="1100" b="1" i="0" spc="-11">
-                <a:solidFill>
-                  <a:srgbClr val="8E8E93"/>
-                </a:solidFill>
-                <a:latin typeface="Pretendard"/>
-                <a:ea typeface="Pretendard"/>
-                <a:cs typeface="Pretendard"/>
-              </a:rPr>
-              <a:t>APPENDIX · Q&amp;A</a:t>
-            </a:r>
-          </a:p>
-        </p:txBody>
-      </p:sp>
-      <p:sp>
-        <p:nvSpPr>
-          <p:cNvPr id="4" name="TextBox 3"/>
-          <p:cNvSpPr txBox="1"/>
-          <p:nvPr/>
-        </p:nvSpPr>
-        <p:spPr>
-          <a:xfrm>
-            <a:off x="251642" y="436260"/>
-            <a:ext cx="10972800" cy="640080"/>
-          </a:xfrm>
-          <a:prstGeom prst="rect">
-            <a:avLst/>
-          </a:prstGeom>
-          <a:noFill/>
-        </p:spPr>
-        <p:txBody>
-          <a:bodyPr wrap="square" anchor="t" lIns="0" rIns="0" tIns="0" bIns="0">
-            <a:spAutoFit/>
-          </a:bodyPr>
-          <a:lstStyle/>
-          <a:p>
-            <a:pPr algn="l">
-              <a:lnSpc>
-                <a:spcPts val="3600"/>
-              </a:lnSpc>
-            </a:pPr>
-            <a:r>
-              <a:rPr sz="3000" b="1" i="0" spc="-30">
-                <a:solidFill>
-                  <a:srgbClr val="006241"/>
-                </a:solidFill>
-                <a:latin typeface="Pretendard"/>
-                <a:ea typeface="Pretendard"/>
-                <a:cs typeface="Pretendard"/>
-              </a:rPr>
-              <a:t>자주 나올 질문 ②</a:t>
-            </a:r>
-          </a:p>
-        </p:txBody>
-      </p:sp>
       <p:pic>
         <p:nvPicPr>
-          <p:cNvPr id="5" name="Picture 4" descr="logo.png"/>
+          <p:cNvPr id="3" name="Picture 2" descr="logo.png"/>
           <p:cNvPicPr>
             <a:picLocks noChangeAspect="1"/>
           </p:cNvPicPr>
@@ -13835,62 +14181,51 @@
       </p:pic>
       <p:sp>
         <p:nvSpPr>
-          <p:cNvPr id="6" name="Rounded Rectangle 5"/>
-          <p:cNvSpPr/>
-          <p:nvPr/>
-        </p:nvSpPr>
-        <p:spPr>
-          <a:xfrm>
-            <a:off x="251642" y="1290309"/>
-            <a:ext cx="11699382" cy="5227350"/>
-          </a:xfrm>
-          <a:prstGeom prst="roundRect">
-            <a:avLst>
-              <a:gd name="adj" fmla="val 3500"/>
-            </a:avLst>
-          </a:prstGeom>
-          <a:solidFill>
-            <a:srgbClr val="FFFFFF"/>
-          </a:solidFill>
-          <a:ln w="9525">
-            <a:solidFill>
-              <a:srgbClr val="D9D9D9"/>
-            </a:solidFill>
-          </a:ln>
-          <a:effectLst/>
-        </p:spPr>
-        <p:style>
-          <a:lnRef idx="1">
-            <a:schemeClr val="accent1"/>
-          </a:lnRef>
-          <a:fillRef idx="3">
-            <a:schemeClr val="accent1"/>
-          </a:fillRef>
-          <a:effectRef idx="2">
-            <a:schemeClr val="accent1"/>
-          </a:effectRef>
-          <a:fontRef idx="minor">
-            <a:schemeClr val="lt1"/>
-          </a:fontRef>
-        </p:style>
-        <p:txBody>
-          <a:bodyPr rtlCol="0" anchor="ctr"/>
+          <p:cNvPr id="4" name="TextBox 3"/>
+          <p:cNvSpPr txBox="1"/>
+          <p:nvPr/>
+        </p:nvSpPr>
+        <p:spPr>
+          <a:xfrm>
+            <a:off x="548640" y="2377440"/>
+            <a:ext cx="11064240" cy="1280160"/>
+          </a:xfrm>
+          <a:prstGeom prst="rect">
+            <a:avLst/>
+          </a:prstGeom>
+          <a:noFill/>
+        </p:spPr>
+        <p:txBody>
+          <a:bodyPr wrap="square" anchor="ctr" lIns="0" rIns="0" tIns="0" bIns="0">
+            <a:spAutoFit/>
+          </a:bodyPr>
           <a:lstStyle/>
           <a:p>
             <a:pPr algn="ctr"/>
-          </a:p>
-        </p:txBody>
-      </p:sp>
-      <p:sp>
-        <p:nvSpPr>
-          <p:cNvPr id="7" name="TextBox 6"/>
-          <p:cNvSpPr txBox="1"/>
-          <p:nvPr/>
-        </p:nvSpPr>
-        <p:spPr>
-          <a:xfrm>
-            <a:off x="138257" y="6620256"/>
-            <a:ext cx="548640" cy="228600"/>
+            <a:r>
+              <a:rPr sz="5400" b="1" i="0" spc="-54">
+                <a:solidFill>
+                  <a:srgbClr val="006241"/>
+                </a:solidFill>
+                <a:latin typeface="Pretendard"/>
+                <a:ea typeface="Pretendard"/>
+                <a:cs typeface="Pretendard"/>
+              </a:rPr>
+              <a:t>Thank you</a:t>
+            </a:r>
+          </a:p>
+        </p:txBody>
+      </p:sp>
+      <p:sp>
+        <p:nvSpPr>
+          <p:cNvPr id="5" name="TextBox 4"/>
+          <p:cNvSpPr txBox="1"/>
+          <p:nvPr/>
+        </p:nvSpPr>
+        <p:spPr>
+          <a:xfrm>
+            <a:off x="548640" y="3749039"/>
+            <a:ext cx="11064240" cy="457200"/>
           </a:xfrm>
           <a:prstGeom prst="rect">
             <a:avLst/>
@@ -13903,128 +14238,64 @@
           </a:bodyPr>
           <a:lstStyle/>
           <a:p>
-            <a:pPr algn="l"/>
-            <a:r>
-              <a:rPr sz="900" b="0" i="0" spc="-9">
-                <a:solidFill>
-                  <a:srgbClr val="8E8E93"/>
-                </a:solidFill>
-                <a:latin typeface="Pretendard"/>
-                <a:ea typeface="Pretendard"/>
-                <a:cs typeface="Pretendard"/>
-              </a:rPr>
-              <a:t>20</a:t>
-            </a:r>
-          </a:p>
-        </p:txBody>
-      </p:sp>
-      <p:sp>
-        <p:nvSpPr>
-          <p:cNvPr id="8" name="Rounded Rectangle 7"/>
-          <p:cNvSpPr/>
-          <p:nvPr/>
-        </p:nvSpPr>
-        <p:spPr>
-          <a:xfrm>
-            <a:off x="663122" y="1656069"/>
-            <a:ext cx="10876422" cy="1364498"/>
-          </a:xfrm>
-          <a:prstGeom prst="roundRect">
-            <a:avLst>
-              <a:gd name="adj" fmla="val 6000"/>
-            </a:avLst>
-          </a:prstGeom>
-          <a:noFill/>
-          <a:ln w="11430">
-            <a:solidFill>
-              <a:srgbClr val="D9D9D9"/>
-            </a:solidFill>
-          </a:ln>
-          <a:effectLst/>
-        </p:spPr>
-        <p:style>
-          <a:lnRef idx="1">
-            <a:schemeClr val="accent1"/>
-          </a:lnRef>
-          <a:fillRef idx="3">
-            <a:schemeClr val="accent1"/>
-          </a:fillRef>
-          <a:effectRef idx="2">
-            <a:schemeClr val="accent1"/>
-          </a:effectRef>
-          <a:fontRef idx="minor">
-            <a:schemeClr val="lt1"/>
-          </a:fontRef>
-        </p:style>
-        <p:txBody>
-          <a:bodyPr rtlCol="0" anchor="ctr"/>
-          <a:lstStyle/>
-          <a:p>
             <a:pPr algn="ctr"/>
-          </a:p>
-        </p:txBody>
-      </p:sp>
-      <p:sp>
-        <p:nvSpPr>
-          <p:cNvPr id="9" name="TextBox 8"/>
-          <p:cNvSpPr txBox="1"/>
-          <p:nvPr/>
-        </p:nvSpPr>
-        <p:spPr>
-          <a:xfrm>
-            <a:off x="1028882" y="1656069"/>
-            <a:ext cx="10144902" cy="1364498"/>
-          </a:xfrm>
-          <a:prstGeom prst="rect">
-            <a:avLst/>
-          </a:prstGeom>
-          <a:noFill/>
-        </p:spPr>
-        <p:txBody>
-          <a:bodyPr wrap="square" anchor="ctr" lIns="0" rIns="0" tIns="0" bIns="0">
-            <a:spAutoFit/>
-          </a:bodyPr>
-          <a:lstStyle/>
-          <a:p>
-            <a:pPr algn="l">
-              <a:lnSpc>
-                <a:spcPts val="2000"/>
-              </a:lnSpc>
-            </a:pPr>
-            <a:r>
-              <a:rPr sz="1500" b="1" i="0" spc="-15">
-                <a:solidFill>
-                  <a:srgbClr val="006241"/>
-                </a:solidFill>
-                <a:latin typeface="Pretendard"/>
-                <a:ea typeface="Pretendard"/>
-                <a:cs typeface="Pretendard"/>
-              </a:rPr>
-              <a:t>Q.  </a:t>
-            </a:r>
-            <a:r>
-              <a:rPr sz="1500" b="1" i="0" spc="-15">
-                <a:solidFill>
-                  <a:srgbClr val="006241"/>
-                </a:solidFill>
-                <a:latin typeface="Pretendard"/>
-                <a:ea typeface="Pretendard"/>
-                <a:cs typeface="Pretendard"/>
-              </a:rPr>
-              <a:t>SNOMED·MeSH 같은 의학 용어체계도 되나요?</a:t>
-            </a:r>
-          </a:p>
-          <a:p>
-            <a:pPr algn="l">
-              <a:lnSpc>
-                <a:spcPts val="1700"/>
-              </a:lnSpc>
+            <a:r>
+              <a:rPr sz="1800" b="0" i="0" spc="-18">
+                <a:solidFill>
+                  <a:srgbClr val="6B6B6B"/>
+                </a:solidFill>
+                <a:latin typeface="Pretendard"/>
+                <a:ea typeface="Pretendard"/>
+                <a:cs typeface="Pretendard"/>
+              </a:rPr>
+              <a:t>Questions &amp; discussion</a:t>
+            </a:r>
+          </a:p>
+        </p:txBody>
+      </p:sp>
+      <p:sp>
+        <p:nvSpPr>
+          <p:cNvPr id="6" name="TextBox 5"/>
+          <p:cNvSpPr txBox="1"/>
+          <p:nvPr/>
+        </p:nvSpPr>
+        <p:spPr>
+          <a:xfrm>
+            <a:off x="548640" y="4937760"/>
+            <a:ext cx="11064240" cy="640080"/>
+          </a:xfrm>
+          <a:prstGeom prst="rect">
+            <a:avLst/>
+          </a:prstGeom>
+          <a:noFill/>
+        </p:spPr>
+        <p:txBody>
+          <a:bodyPr wrap="square" anchor="t" lIns="0" rIns="0" tIns="0" bIns="0">
+            <a:spAutoFit/>
+          </a:bodyPr>
+          <a:lstStyle/>
+          <a:p>
+            <a:pPr algn="ctr"/>
+            <a:r>
+              <a:rPr sz="1400" b="0" i="0" spc="-14">
+                <a:solidFill>
+                  <a:srgbClr val="6B6B6B"/>
+                </a:solidFill>
+                <a:latin typeface="Pretendard"/>
+                <a:ea typeface="Pretendard"/>
+                <a:cs typeface="Pretendard"/>
+              </a:rPr>
+              <a:t>박상민  ·  분당서울대학교병원 정형외과</a:t>
+            </a:r>
+          </a:p>
+          <a:p>
+            <a:pPr algn="ctr">
               <a:spcBef>
-                <a:spcPts val="600"/>
+                <a:spcPts val="500"/>
               </a:spcBef>
             </a:pPr>
             <a:r>
-              <a:rPr sz="1250" b="1" i="0" spc="-12">
+              <a:rPr sz="1300" b="1" i="0" spc="-13">
                 <a:solidFill>
                   <a:srgbClr val="00754A"/>
                 </a:solidFill>
@@ -14032,278 +14303,7 @@
                 <a:ea typeface="Pretendard"/>
                 <a:cs typeface="Pretendard"/>
               </a:rPr>
-              <a:t>A.  </a:t>
-            </a:r>
-            <a:r>
-              <a:rPr sz="1250" b="0" i="0" spc="-12">
-                <a:solidFill>
-                  <a:srgbClr val="1F1F1F"/>
-                </a:solidFill>
-                <a:latin typeface="Pretendard"/>
-                <a:ea typeface="Pretendard"/>
-                <a:cs typeface="Pretendard"/>
-              </a:rPr>
-              <a:t>온톨로지 팩(JSON)으로 장착. IS_A 계층·동의어 링크 지원. PubMed 추가 시 MeSH 태그는 기본.</a:t>
-            </a:r>
-          </a:p>
-        </p:txBody>
-      </p:sp>
-      <p:sp>
-        <p:nvSpPr>
-          <p:cNvPr id="10" name="Rounded Rectangle 9"/>
-          <p:cNvSpPr/>
-          <p:nvPr/>
-        </p:nvSpPr>
-        <p:spPr>
-          <a:xfrm>
-            <a:off x="663122" y="3221736"/>
-            <a:ext cx="10876422" cy="1364498"/>
-          </a:xfrm>
-          <a:prstGeom prst="roundRect">
-            <a:avLst>
-              <a:gd name="adj" fmla="val 6000"/>
-            </a:avLst>
-          </a:prstGeom>
-          <a:noFill/>
-          <a:ln w="11430">
-            <a:solidFill>
-              <a:srgbClr val="D9D9D9"/>
-            </a:solidFill>
-          </a:ln>
-          <a:effectLst/>
-        </p:spPr>
-        <p:style>
-          <a:lnRef idx="1">
-            <a:schemeClr val="accent1"/>
-          </a:lnRef>
-          <a:fillRef idx="3">
-            <a:schemeClr val="accent1"/>
-          </a:fillRef>
-          <a:effectRef idx="2">
-            <a:schemeClr val="accent1"/>
-          </a:effectRef>
-          <a:fontRef idx="minor">
-            <a:schemeClr val="lt1"/>
-          </a:fontRef>
-        </p:style>
-        <p:txBody>
-          <a:bodyPr rtlCol="0" anchor="ctr"/>
-          <a:lstStyle/>
-          <a:p>
-            <a:pPr algn="ctr"/>
-          </a:p>
-        </p:txBody>
-      </p:sp>
-      <p:sp>
-        <p:nvSpPr>
-          <p:cNvPr id="11" name="TextBox 10"/>
-          <p:cNvSpPr txBox="1"/>
-          <p:nvPr/>
-        </p:nvSpPr>
-        <p:spPr>
-          <a:xfrm>
-            <a:off x="1028882" y="3221736"/>
-            <a:ext cx="10144902" cy="1364498"/>
-          </a:xfrm>
-          <a:prstGeom prst="rect">
-            <a:avLst/>
-          </a:prstGeom>
-          <a:noFill/>
-        </p:spPr>
-        <p:txBody>
-          <a:bodyPr wrap="square" anchor="ctr" lIns="0" rIns="0" tIns="0" bIns="0">
-            <a:spAutoFit/>
-          </a:bodyPr>
-          <a:lstStyle/>
-          <a:p>
-            <a:pPr algn="l">
-              <a:lnSpc>
-                <a:spcPts val="2000"/>
-              </a:lnSpc>
-            </a:pPr>
-            <a:r>
-              <a:rPr sz="1500" b="1" i="0" spc="-15">
-                <a:solidFill>
-                  <a:srgbClr val="006241"/>
-                </a:solidFill>
-                <a:latin typeface="Pretendard"/>
-                <a:ea typeface="Pretendard"/>
-                <a:cs typeface="Pretendard"/>
-              </a:rPr>
-              <a:t>Q.  </a:t>
-            </a:r>
-            <a:r>
-              <a:rPr sz="1500" b="1" i="0" spc="-15">
-                <a:solidFill>
-                  <a:srgbClr val="006241"/>
-                </a:solidFill>
-                <a:latin typeface="Pretendard"/>
-                <a:ea typeface="Pretendard"/>
-                <a:cs typeface="Pretendard"/>
-              </a:rPr>
-              <a:t>수천 편짜리 큰 서재도 버티나요?</a:t>
-            </a:r>
-          </a:p>
-          <a:p>
-            <a:pPr algn="l">
-              <a:lnSpc>
-                <a:spcPts val="1700"/>
-              </a:lnSpc>
-              <a:spcBef>
-                <a:spcPts val="600"/>
-              </a:spcBef>
-            </a:pPr>
-            <a:r>
-              <a:rPr sz="1250" b="1" i="0" spc="-12">
-                <a:solidFill>
-                  <a:srgbClr val="00754A"/>
-                </a:solidFill>
-                <a:latin typeface="Pretendard"/>
-                <a:ea typeface="Pretendard"/>
-                <a:cs typeface="Pretendard"/>
-              </a:rPr>
-              <a:t>A.  </a:t>
-            </a:r>
-            <a:r>
-              <a:rPr sz="1250" b="0" i="0" spc="-12">
-                <a:solidFill>
-                  <a:srgbClr val="1F1F1F"/>
-                </a:solidFill>
-                <a:latin typeface="Pretendard"/>
-                <a:ea typeface="Pretendard"/>
-                <a:cs typeface="Pretendard"/>
-              </a:rPr>
-              <a:t>수백~수천 편 타깃. 색인이 인메모리라 아주 큰 vault는 추후 sqlite-vec 교체 예정.</a:t>
-            </a:r>
-          </a:p>
-        </p:txBody>
-      </p:sp>
-      <p:sp>
-        <p:nvSpPr>
-          <p:cNvPr id="12" name="Rounded Rectangle 11"/>
-          <p:cNvSpPr/>
-          <p:nvPr/>
-        </p:nvSpPr>
-        <p:spPr>
-          <a:xfrm>
-            <a:off x="663122" y="4787402"/>
-            <a:ext cx="10876422" cy="1364498"/>
-          </a:xfrm>
-          <a:prstGeom prst="roundRect">
-            <a:avLst>
-              <a:gd name="adj" fmla="val 6000"/>
-            </a:avLst>
-          </a:prstGeom>
-          <a:noFill/>
-          <a:ln w="11430">
-            <a:solidFill>
-              <a:srgbClr val="D9D9D9"/>
-            </a:solidFill>
-          </a:ln>
-          <a:effectLst/>
-        </p:spPr>
-        <p:style>
-          <a:lnRef idx="1">
-            <a:schemeClr val="accent1"/>
-          </a:lnRef>
-          <a:fillRef idx="3">
-            <a:schemeClr val="accent1"/>
-          </a:fillRef>
-          <a:effectRef idx="2">
-            <a:schemeClr val="accent1"/>
-          </a:effectRef>
-          <a:fontRef idx="minor">
-            <a:schemeClr val="lt1"/>
-          </a:fontRef>
-        </p:style>
-        <p:txBody>
-          <a:bodyPr rtlCol="0" anchor="ctr"/>
-          <a:lstStyle/>
-          <a:p>
-            <a:pPr algn="ctr"/>
-          </a:p>
-        </p:txBody>
-      </p:sp>
-      <p:sp>
-        <p:nvSpPr>
-          <p:cNvPr id="13" name="TextBox 12"/>
-          <p:cNvSpPr txBox="1"/>
-          <p:nvPr/>
-        </p:nvSpPr>
-        <p:spPr>
-          <a:xfrm>
-            <a:off x="1028882" y="4787402"/>
-            <a:ext cx="10144902" cy="1364498"/>
-          </a:xfrm>
-          <a:prstGeom prst="rect">
-            <a:avLst/>
-          </a:prstGeom>
-          <a:noFill/>
-        </p:spPr>
-        <p:txBody>
-          <a:bodyPr wrap="square" anchor="ctr" lIns="0" rIns="0" tIns="0" bIns="0">
-            <a:spAutoFit/>
-          </a:bodyPr>
-          <a:lstStyle/>
-          <a:p>
-            <a:pPr algn="l">
-              <a:lnSpc>
-                <a:spcPts val="2000"/>
-              </a:lnSpc>
-            </a:pPr>
-            <a:r>
-              <a:rPr sz="1500" b="1" i="0" spc="-15">
-                <a:solidFill>
-                  <a:srgbClr val="006241"/>
-                </a:solidFill>
-                <a:latin typeface="Pretendard"/>
-                <a:ea typeface="Pretendard"/>
-                <a:cs typeface="Pretendard"/>
-              </a:rPr>
-              <a:t>Q.  </a:t>
-            </a:r>
-            <a:r>
-              <a:rPr sz="1500" b="1" i="0" spc="-15">
-                <a:solidFill>
-                  <a:srgbClr val="006241"/>
-                </a:solidFill>
-                <a:latin typeface="Pretendard"/>
-                <a:ea typeface="Pretendard"/>
-                <a:cs typeface="Pretendard"/>
-              </a:rPr>
-              <a:t>가짜 인용(환각)은 정말 없나요?</a:t>
-            </a:r>
-          </a:p>
-          <a:p>
-            <a:pPr algn="l">
-              <a:lnSpc>
-                <a:spcPts val="1700"/>
-              </a:lnSpc>
-              <a:spcBef>
-                <a:spcPts val="600"/>
-              </a:spcBef>
-            </a:pPr>
-            <a:r>
-              <a:rPr sz="1250" b="1" i="0" spc="-12">
-                <a:solidFill>
-                  <a:srgbClr val="00754A"/>
-                </a:solidFill>
-                <a:latin typeface="Pretendard"/>
-                <a:ea typeface="Pretendard"/>
-                <a:cs typeface="Pretendard"/>
-              </a:rPr>
-              <a:t>A.  </a:t>
-            </a:r>
-            <a:r>
-              <a:rPr sz="1250" b="0" i="0" spc="-12">
-                <a:solidFill>
-                  <a:srgbClr val="1F1F1F"/>
-                </a:solidFill>
-                <a:latin typeface="Pretendard"/>
-                <a:ea typeface="Pretendard"/>
-                <a:cs typeface="Pretendard"/>
-              </a:rPr>
-              <a:t>답을 서재 구절에만 근거하게 강제하고 [n]은 실제 노트에 연결. 근거 없으면 "근거 없음"이라 답하게 설계.</a:t>
+              <a:t>github.com/grotyx/rag-obsidian</a:t>
             </a:r>
           </a:p>
         </p:txBody>

</xml_diff>

<commit_message>
docs: deck cover title → Academic Paper Obsidian Citation Manager
40pt two-line title (was 'RAG Obsidian' 54pt); script intro names the
full title with RAG Obsidian as the short form.

Co-Authored-By: Claude Fable 5 <noreply@anthropic.com>
</commit_message>
<xml_diff>
--- a/presentation/rag_obsidian_deck.pptx
+++ b/presentation/rag_obsidian_deck.pptx
@@ -3283,11 +3283,11 @@
           <a:p>
             <a:pPr algn="l">
               <a:lnSpc>
-                <a:spcPts val="6000"/>
+                <a:spcPts val="4800"/>
               </a:lnSpc>
             </a:pPr>
             <a:r>
-              <a:rPr sz="5400" b="1" i="0" spc="-54">
+              <a:rPr sz="4000" b="1" i="0" spc="-40">
                 <a:solidFill>
                   <a:srgbClr val="006241"/>
                 </a:solidFill>
@@ -3295,7 +3295,25 @@
                 <a:ea typeface="Pretendard"/>
                 <a:cs typeface="Pretendard"/>
               </a:rPr>
-              <a:t>RAG Obsidian</a:t>
+              <a:t>Academic Paper Obsidian</a:t>
+            </a:r>
+          </a:p>
+          <a:p>
+            <a:pPr algn="l">
+              <a:lnSpc>
+                <a:spcPts val="4800"/>
+              </a:lnSpc>
+            </a:pPr>
+            <a:r>
+              <a:rPr sz="4000" b="1" i="0" spc="-40">
+                <a:solidFill>
+                  <a:srgbClr val="006241"/>
+                </a:solidFill>
+                <a:latin typeface="Pretendard"/>
+                <a:ea typeface="Pretendard"/>
+                <a:cs typeface="Pretendard"/>
+              </a:rPr>
+              <a:t>Citation Manager</a:t>
             </a:r>
           </a:p>
         </p:txBody>

</xml_diff>

<commit_message>
docs: sync talk scripts/deck with shipped features; TTS script Hangul-only
Fix claims that no longer matched the plugin: offline answer listed only
metadata fetch + citation graph as network moments (PubMed search, CSL style
download, cloud LLM/embeddings also need it); roadmap still listed full CSL
styles as future (shipped in 0.3.0); MeSH tags described as gated by the
summary toggle (they are always fetched); "open access = full text" narrowed
to PMC; retraction check / OA PDF download described as automatic (manual
commands); "all local & free" qualified to the Ollama default; scale answer
restores the in-memory-index caveat.

TTS script: every non-narration line now starts with # or > so one rule strips
them; phase numbering spoken without digits; appendix moved after the closing
slide. Deck rebuilt from the updated strings.

Co-Authored-By: Claude Fable 5.1 <noreply@anthropic.com>
Claude-Session: https://claude.ai/code/session_01TzZuW4fZagApqTur59qQwb
</commit_message>
<xml_diff>
--- a/presentation/rag_obsidian_deck.pptx
+++ b/presentation/rag_obsidian_deck.pptx
@@ -6284,7 +6284,7 @@
                 <a:ea typeface="Pretendard"/>
                 <a:cs typeface="Pretendard"/>
               </a:rPr>
-              <a:t>향후: 풀 CSL(citeproc) 스타일 · 온톨로지 검색확장 · 모바일 QA</a:t>
+              <a:t>향후: 온톨로지 검색확장 · 모바일 QA · 대용량 색인 엔진</a:t>
             </a:r>
           </a:p>
         </p:txBody>
@@ -8035,7 +8035,7 @@
                 <a:ea typeface="Pretendard"/>
                 <a:cs typeface="Pretendard"/>
               </a:rPr>
-              <a:t>옵션: LLM 자동 요약(OA는 전문 기반) + MeSH 태그</a:t>
+              <a:t>MeSH 태그 자동 · 옵션: LLM 요약(PMC 전문 기반)</a:t>
             </a:r>
           </a:p>
         </p:txBody>
@@ -11106,7 +11106,7 @@
                 <a:cs typeface="Pretendard"/>
               </a:rPr>
               <a:t>추가 시 자동 요약·MeSH
-(OA는 전문 기반)</a:t>
+(PMC 전문 기반)</a:t>
             </a:r>
           </a:p>
         </p:txBody>
@@ -11522,7 +11522,7 @@
                 <a:ea typeface="Pretendard"/>
                 <a:cs typeface="Pretendard"/>
               </a:rPr>
-              <a:t>철회 경고 · 중복 정리
+              <a:t>철회 확인 · 중복 정리
 읽기 큐 · OA PDF 다운로드
 PDF 하이라이트 추출</a:t>
             </a:r>
@@ -13074,7 +13074,7 @@
                 <a:ea typeface="Pretendard"/>
                 <a:cs typeface="Pretendard"/>
               </a:rPr>
-              <a:t>검색·색인은 전부 로컬. 임베딩도 로컬(Ollama) 가능. 네트워크는 메타데이터 가져오기와 인용 그래프(OpenAlex)뿐.</a:t>
+              <a:t>검색·색인은 전부 로컬. 임베딩도 로컬(Ollama) 가능. 네트워크는 외부 조회(메타데이터·PubMed·OpenAlex·CSL 스타일)와 클라우드 LLM·임베딩 호출뿐.</a:t>
             </a:r>
           </a:p>
         </p:txBody>
@@ -20082,7 +20082,7 @@
                 <a:ea typeface="Pretendard"/>
                 <a:cs typeface="Pretendard"/>
               </a:rPr>
-              <a:t>단어 + 뜻 + 메타데이터를 한 번에 — 전부 로컬·무료. 필요하면 인용 그래프로 확장.</a:t>
+              <a:t>단어 + 뜻 + 메타데이터를 한 번에 — Ollama면 전부 로컬·무료. 필요하면 인용 그래프로 확장.</a:t>
             </a:r>
           </a:p>
         </p:txBody>

</xml_diff>

<commit_message>
v0.4.1: code-review fixes (main.ts + src/), docs sync
manifest / package / versions → 0.4.1; CHANGELOG [Unreleased] → [0.4.1] with the
one-off "Rebuild search index" note; version in CLAUDE.md, README badge, talk
scripts and deck; PLAN.md status + dedup row brought up to date; README.ko test
count; README keychain/sync note.

Co-Authored-By: Claude Fable 5.1 <noreply@anthropic.com>
Claude-Session: https://claude.ai/code/session_01TzZuW4fZagApqTur59qQwb
</commit_message>
<xml_diff>
--- a/presentation/rag_obsidian_deck.pptx
+++ b/presentation/rag_obsidian_deck.pptx
@@ -5408,7 +5408,7 @@
                 <a:ea typeface="Pretendard"/>
                 <a:cs typeface="Pretendard"/>
               </a:rPr>
-              <a:t>v0.4.0 · github.com/grotyx/rag-obsidian</a:t>
+              <a:t>v0.4.1 · github.com/grotyx/rag-obsidian</a:t>
             </a:r>
           </a:p>
         </p:txBody>
@@ -7027,7 +7027,7 @@
                 <a:ea typeface="Pretendard"/>
                 <a:cs typeface="Pretendard"/>
               </a:rPr>
-              <a:t>현재 v0.4.0 · 개발 빌드로 사용 중 · 공개 배포 예정</a:t>
+              <a:t>현재 v0.4.1 · 개발 빌드로 사용 중 · 공개 배포 예정</a:t>
             </a:r>
           </a:p>
         </p:txBody>

</xml_diff>

<commit_message>
v0.4.2: separate chat model, higher token budget, OpenRouter docs
manifest / package / versions -> 0.4.2; CHANGELOG [Unreleased] -> [0.4.2]
(and drops an intermediate check count from the 0.4.1 entry so each release
states one figure); PLAN.md status -> 52 checks; version in CLAUDE.md, README
badge, talk scripts and rebuilt deck.

Co-Authored-By: Claude Opus 5 <noreply@anthropic.com>
Claude-Session: https://claude.ai/code/session_01TzZuW4fZagApqTur59qQwb
</commit_message>
<xml_diff>
--- a/presentation/rag_obsidian_deck.pptx
+++ b/presentation/rag_obsidian_deck.pptx
@@ -5408,7 +5408,7 @@
                 <a:ea typeface="Pretendard"/>
                 <a:cs typeface="Pretendard"/>
               </a:rPr>
-              <a:t>v0.4.1 · github.com/grotyx/rag-obsidian</a:t>
+              <a:t>v0.4.2 · github.com/grotyx/rag-obsidian</a:t>
             </a:r>
           </a:p>
         </p:txBody>
@@ -7027,7 +7027,7 @@
                 <a:ea typeface="Pretendard"/>
                 <a:cs typeface="Pretendard"/>
               </a:rPr>
-              <a:t>현재 v0.4.1 · 개발 빌드로 사용 중 · 공개 배포 예정</a:t>
+              <a:t>현재 v0.4.2 · 개발 빌드로 사용 중 · 공개 배포 예정</a:t>
             </a:r>
           </a:p>
         </p:txBody>

</xml_diff>

<commit_message>
v0.4.3: correctness release from three review passes and in-vault testing
manifest / package / versions -> 0.4.3; CHANGELOG [Unreleased] -> [0.4.3] with a
short summary of what the release is; version in CLAUDE.md, README badge, talk
scripts and rebuilt deck.

Co-Authored-By: Claude Opus 5 <noreply@anthropic.com>
Claude-Session: https://claude.ai/code/session_01TzZuW4fZagApqTur59qQwb
</commit_message>
<xml_diff>
--- a/presentation/rag_obsidian_deck.pptx
+++ b/presentation/rag_obsidian_deck.pptx
@@ -5408,7 +5408,7 @@
                 <a:ea typeface="Pretendard"/>
                 <a:cs typeface="Pretendard"/>
               </a:rPr>
-              <a:t>v0.4.2 · github.com/grotyx/rag-obsidian</a:t>
+              <a:t>v0.4.3 · github.com/grotyx/rag-obsidian</a:t>
             </a:r>
           </a:p>
         </p:txBody>
@@ -7027,7 +7027,7 @@
                 <a:ea typeface="Pretendard"/>
                 <a:cs typeface="Pretendard"/>
               </a:rPr>
-              <a:t>현재 v0.4.2 · 개발 빌드로 사용 중 · 공개 배포 예정</a:t>
+              <a:t>현재 v0.4.3 · 개발 빌드로 사용 중 · 공개 배포 예정</a:t>
             </a:r>
           </a:p>
         </p:txBody>

</xml_diff>

<commit_message>
v0.4.4: rename to "Academic Paper Citation Manager" for the store listing
Obsidian's community-plugin guidelines forbid "Obsidian" in a plugin name, and
none of the 7371 listed plugins carry it — the old display name would be
rejected on submission. Dropping that one word keeps the identity intact.

The plugin id stays `rag-obsidian`: the settings folder, data.json and the
OS-keychain entries are keyed by it, and 445 listed plugins have "obsidian" in
their id, so there is no reason to orphan existing installs.

Renamed in manifest, both READMEs, CLAUDE.md, package.json, the talk scripts and
the deck cover. The 0.3.0 changelog entry keeps the name it shipped under.

Co-Authored-By: Claude Opus 5 <noreply@anthropic.com>
Claude-Session: https://claude.ai/code/session_01TzZuW4fZagApqTur59qQwb
</commit_message>
<xml_diff>
--- a/presentation/rag_obsidian_deck.pptx
+++ b/presentation/rag_obsidian_deck.pptx
@@ -3295,7 +3295,7 @@
                 <a:ea typeface="Pretendard"/>
                 <a:cs typeface="Pretendard"/>
               </a:rPr>
-              <a:t>Academic Paper Obsidian</a:t>
+              <a:t>Academic Paper</a:t>
             </a:r>
           </a:p>
           <a:p>
@@ -5408,7 +5408,7 @@
                 <a:ea typeface="Pretendard"/>
                 <a:cs typeface="Pretendard"/>
               </a:rPr>
-              <a:t>v0.4.3 · github.com/grotyx/rag-obsidian</a:t>
+              <a:t>v0.4.4 · github.com/grotyx/rag-obsidian</a:t>
             </a:r>
           </a:p>
         </p:txBody>
@@ -7027,7 +7027,7 @@
                 <a:ea typeface="Pretendard"/>
                 <a:cs typeface="Pretendard"/>
               </a:rPr>
-              <a:t>현재 v0.4.3 · 개발 빌드로 사용 중 · 공개 배포 예정</a:t>
+              <a:t>현재 v0.4.4 · 개발 빌드로 사용 중 · 공개 배포 예정</a:t>
             </a:r>
           </a:p>
         </p:txBody>

</xml_diff>

<commit_message>
v0.4.5: duplicate finder fix and a citation style id that exists
manifest / package / versions -> 0.4.5; CHANGELOG [Unreleased] -> [0.4.5];
version in CLAUDE.md, README badge, talk scripts and rebuilt deck.

Co-Authored-By: Claude Opus 5 <noreply@anthropic.com>
Claude-Session: https://claude.ai/code/session_01TzZuW4fZagApqTur59qQwb
</commit_message>
<xml_diff>
--- a/presentation/rag_obsidian_deck.pptx
+++ b/presentation/rag_obsidian_deck.pptx
@@ -5408,7 +5408,7 @@
                 <a:ea typeface="Pretendard"/>
                 <a:cs typeface="Pretendard"/>
               </a:rPr>
-              <a:t>v0.4.4 · github.com/grotyx/rag-obsidian</a:t>
+              <a:t>v0.4.5 · github.com/grotyx/rag-obsidian</a:t>
             </a:r>
           </a:p>
         </p:txBody>
@@ -7027,7 +7027,7 @@
                 <a:ea typeface="Pretendard"/>
                 <a:cs typeface="Pretendard"/>
               </a:rPr>
-              <a:t>현재 v0.4.4 · 개발 빌드로 사용 중 · 공개 배포 예정</a:t>
+              <a:t>현재 v0.4.5 · 개발 빌드로 사용 중 · 공개 배포 예정</a:t>
             </a:r>
           </a:p>
         </p:txBody>

</xml_diff>

<commit_message>
v0.4.8: add papers and fill gaps several at a time
Both walked their list one paper at a time, and each paper waits on a PubMed
record, sometimes a PMC full text, and an LLM summary — so a batch cost the sum
of its parts and a few dozen papers meant sitting through minutes of it.

The network and LLM half now runs through mapPool: 3 in flight, or 6 when a
PubMed API key is set (NCBI allows 3 requests/second without one, 10 with).
Vault writes stay sequential, because createReference derives the citekey and
filename from what the vault already holds and two concurrent creates can pick
the same name; duplicates are checked before the parallel phase and again before
each write, since two selected hits can be the same work.

Measured in a real vault: 14 papers added with summaries and MeSH tags in 119 s,
about 9 s each.

Co-Authored-By: Claude Opus 5 <noreply@anthropic.com>
Claude-Session: https://claude.ai/code/session_01TzZuW4fZagApqTur59qQwb
</commit_message>
<xml_diff>
--- a/presentation/rag_obsidian_deck.pptx
+++ b/presentation/rag_obsidian_deck.pptx
@@ -5408,7 +5408,7 @@
                 <a:ea typeface="Pretendard"/>
                 <a:cs typeface="Pretendard"/>
               </a:rPr>
-              <a:t>v0.4.7 · github.com/grotyx/rag-obsidian</a:t>
+              <a:t>v0.4.8 · github.com/grotyx/rag-obsidian</a:t>
             </a:r>
           </a:p>
         </p:txBody>
@@ -7027,7 +7027,7 @@
                 <a:ea typeface="Pretendard"/>
                 <a:cs typeface="Pretendard"/>
               </a:rPr>
-              <a:t>현재 v0.4.7 · 개발 빌드로 사용 중 · 공개 배포 예정</a:t>
+              <a:t>현재 v0.4.8 · 개발 빌드로 사용 중 · 공개 배포 예정</a:t>
             </a:r>
           </a:p>
         </p:txBody>

</xml_diff>

<commit_message>
v0.4.12: the NCBI queue honours the stricter of two neighbouring tiers
Each turn was spaced by its own tier, but the wait is measured from the previous
request — so a keyed call could fire 110 ms after a keyless one that had already
counted against the address's 3 requests/second budget. Take the larger of the
two gaps.

Last open item from the review of 0.4.10; the other thirteen shipped in 0.4.11.
The test that came with it measured the harmless direction (keyless after keyed,
which waits 350 ms either way) and stayed green under mutation; it now measures
the direction that can actually exceed the limit.

Co-Authored-By: Claude Opus 5 <noreply@anthropic.com>
Claude-Session: https://claude.ai/code/session_01TzZuW4fZagApqTur59qQwb
</commit_message>
<xml_diff>
--- a/presentation/rag_obsidian_deck.pptx
+++ b/presentation/rag_obsidian_deck.pptx
@@ -5408,7 +5408,7 @@
                 <a:ea typeface="Pretendard"/>
                 <a:cs typeface="Pretendard"/>
               </a:rPr>
-              <a:t>v0.4.11 · github.com/grotyx/rag-obsidian</a:t>
+              <a:t>v0.4.12 · github.com/grotyx/rag-obsidian</a:t>
             </a:r>
           </a:p>
         </p:txBody>
@@ -7027,7 +7027,7 @@
                 <a:ea typeface="Pretendard"/>
                 <a:cs typeface="Pretendard"/>
               </a:rPr>
-              <a:t>현재 v0.4.11 · 개발 빌드로 사용 중 · 공개 배포 예정</a:t>
+              <a:t>현재 v0.4.12 · 개발 빌드로 사용 중 · 공개 배포 예정</a:t>
             </a:r>
           </a:p>
         </p:txBody>

</xml_diff>